<commit_message>
docs: reconcile official AWS pricing estimate
</commit_message>
<xml_diff>
--- a/outputs/proyecto-final-sap-analytics-aws.pptx
+++ b/outputs/proyecto-final-sap-analytics-aws.pptx
@@ -2,20 +2,20 @@
 <file path=ppt/presentation.xml><?xml version="1.0" encoding="utf-8"?>
 <p:presentation xmlns:p="http://schemas.openxmlformats.org/presentationml/2006/main">
   <p:sldMasterIdLst>
-    <p:sldMasterId xmlns:r="http://schemas.openxmlformats.org/officeDocument/2006/relationships" id="2147483648" r:id="R8adf0661e4a84e96"/>
+    <p:sldMasterId xmlns:r="http://schemas.openxmlformats.org/officeDocument/2006/relationships" id="2147483648" r:id="R03bdfa3fe31444dd"/>
   </p:sldMasterIdLst>
   <p:notesMasterIdLst>
-    <p:notesMasterId xmlns:r="http://schemas.openxmlformats.org/officeDocument/2006/relationships" r:id="R0e4535fe54ea4e60"/>
+    <p:notesMasterId xmlns:r="http://schemas.openxmlformats.org/officeDocument/2006/relationships" r:id="Rb7fde6d1753e4304"/>
   </p:notesMasterIdLst>
   <p:sldIdLst>
-    <p:sldId xmlns:r="http://schemas.openxmlformats.org/officeDocument/2006/relationships" id="256" r:id="Ra445f9ec873d4abd"/>
-    <p:sldId xmlns:r="http://schemas.openxmlformats.org/officeDocument/2006/relationships" id="257" r:id="R3763b9713b4545f7"/>
-    <p:sldId xmlns:r="http://schemas.openxmlformats.org/officeDocument/2006/relationships" id="258" r:id="R3a87795656c34c0b"/>
-    <p:sldId xmlns:r="http://schemas.openxmlformats.org/officeDocument/2006/relationships" id="259" r:id="R5e3db02d7bd74552"/>
-    <p:sldId xmlns:r="http://schemas.openxmlformats.org/officeDocument/2006/relationships" id="260" r:id="Rcebd51a2323f4a7a"/>
-    <p:sldId xmlns:r="http://schemas.openxmlformats.org/officeDocument/2006/relationships" id="261" r:id="R2ad2a5d8be784dd9"/>
-    <p:sldId xmlns:r="http://schemas.openxmlformats.org/officeDocument/2006/relationships" id="262" r:id="R8671f8c295b1414b"/>
-    <p:sldId xmlns:r="http://schemas.openxmlformats.org/officeDocument/2006/relationships" id="263" r:id="R8c875efbca264576"/>
+    <p:sldId xmlns:r="http://schemas.openxmlformats.org/officeDocument/2006/relationships" id="256" r:id="Rc1b1094f40584e41"/>
+    <p:sldId xmlns:r="http://schemas.openxmlformats.org/officeDocument/2006/relationships" id="257" r:id="Re6a6daad39b94cf9"/>
+    <p:sldId xmlns:r="http://schemas.openxmlformats.org/officeDocument/2006/relationships" id="258" r:id="Re886127aec714eb6"/>
+    <p:sldId xmlns:r="http://schemas.openxmlformats.org/officeDocument/2006/relationships" id="259" r:id="R416d0a8deea0403f"/>
+    <p:sldId xmlns:r="http://schemas.openxmlformats.org/officeDocument/2006/relationships" id="260" r:id="R7baf9d35fdd9452b"/>
+    <p:sldId xmlns:r="http://schemas.openxmlformats.org/officeDocument/2006/relationships" id="261" r:id="Re41605867a904737"/>
+    <p:sldId xmlns:r="http://schemas.openxmlformats.org/officeDocument/2006/relationships" id="262" r:id="R90b5db182ea941ae"/>
+    <p:sldId xmlns:r="http://schemas.openxmlformats.org/officeDocument/2006/relationships" id="263" r:id="R17b07323238a46a1"/>
   </p:sldIdLst>
   <p:sldSz cx="12192000" cy="6858000"/>
   <p:notesSz cx="6858000" cy="9144000"/>
@@ -1233,7 +1233,7 @@
   </p:cSld>
   <p:clrMap bg1="lt1" tx1="dk1" bg2="lt2" tx2="dk2" accent1="accent1" accent2="accent2" accent3="accent3" accent4="accent4" accent5="accent5" accent6="accent6" hlink="hlink" folHlink="folHlink"/>
   <p:sldLayoutIdLst>
-    <p:sldLayoutId xmlns:r="http://schemas.openxmlformats.org/officeDocument/2006/relationships" id="2147483649" r:id="R0cb5777abc3f4fb7"/>
+    <p:sldLayoutId xmlns:r="http://schemas.openxmlformats.org/officeDocument/2006/relationships" id="2147483649" r:id="R3e0e85653cfd4b74"/>
   </p:sldLayoutIdLst>
   <p:txStyles>
     <p:titleStyle>
@@ -2115,7 +2115,7 @@
           <p:nvPr/>
         </p:nvPicPr>
         <p:blipFill>
-          <a:blip xmlns:r="http://schemas.openxmlformats.org/officeDocument/2006/relationships" xmlns:a="http://schemas.openxmlformats.org/drawingml/2006/main" r:embed="R094882a91d9a4d35"/>
+          <a:blip xmlns:r="http://schemas.openxmlformats.org/officeDocument/2006/relationships" xmlns:a="http://schemas.openxmlformats.org/drawingml/2006/main" r:embed="Rb6bf05f47a5a48b7"/>
           <a:srcRect xmlns:a="http://schemas.openxmlformats.org/drawingml/2006/main" l="19" t="0" r="18" b="0"/>
           <a:stretch xmlns:a="http://schemas.openxmlformats.org/drawingml/2006/main">
             <a:fillRect l="0" t="0" r="0" b="0"/>
@@ -2143,7 +2143,7 @@
           <p:nvPr/>
         </p:nvPicPr>
         <p:blipFill>
-          <a:blip xmlns:r="http://schemas.openxmlformats.org/officeDocument/2006/relationships" xmlns:a="http://schemas.openxmlformats.org/drawingml/2006/main" r:embed="R22a8c4ce378c41c9"/>
+          <a:blip xmlns:r="http://schemas.openxmlformats.org/officeDocument/2006/relationships" xmlns:a="http://schemas.openxmlformats.org/drawingml/2006/main" r:embed="Rbe829faa81074619"/>
           <a:stretch xmlns:a="http://schemas.openxmlformats.org/drawingml/2006/main">
             <a:fillRect l="0" t="0" r="0" b="0"/>
           </a:stretch>
@@ -2391,7 +2391,7 @@
           <p:nvPr/>
         </p:nvPicPr>
         <p:blipFill>
-          <a:blip xmlns:r="http://schemas.openxmlformats.org/officeDocument/2006/relationships" xmlns:a="http://schemas.openxmlformats.org/drawingml/2006/main" r:embed="R8ced2fe6c2a94031"/>
+          <a:blip xmlns:r="http://schemas.openxmlformats.org/officeDocument/2006/relationships" xmlns:a="http://schemas.openxmlformats.org/drawingml/2006/main" r:embed="Rd4b5e71abfe7467a"/>
           <a:srcRect xmlns:a="http://schemas.openxmlformats.org/drawingml/2006/main" l="19" t="0" r="18" b="0"/>
           <a:stretch xmlns:a="http://schemas.openxmlformats.org/drawingml/2006/main">
             <a:fillRect l="0" t="0" r="0" b="0"/>
@@ -2795,7 +2795,7 @@
           <p:nvPr/>
         </p:nvPicPr>
         <p:blipFill>
-          <a:blip xmlns:r="http://schemas.openxmlformats.org/officeDocument/2006/relationships" xmlns:a="http://schemas.openxmlformats.org/drawingml/2006/main" r:embed="R61be6ba608cd4929"/>
+          <a:blip xmlns:r="http://schemas.openxmlformats.org/officeDocument/2006/relationships" xmlns:a="http://schemas.openxmlformats.org/drawingml/2006/main" r:embed="R2525e47161fc42e8"/>
           <a:srcRect xmlns:a="http://schemas.openxmlformats.org/drawingml/2006/main" l="19" t="0" r="18" b="0"/>
           <a:stretch xmlns:a="http://schemas.openxmlformats.org/drawingml/2006/main">
             <a:fillRect l="0" t="0" r="0" b="0"/>
@@ -4115,7 +4115,7 @@
           <p:nvPr/>
         </p:nvPicPr>
         <p:blipFill>
-          <a:blip xmlns:r="http://schemas.openxmlformats.org/officeDocument/2006/relationships" xmlns:a="http://schemas.openxmlformats.org/drawingml/2006/main" r:embed="R5dd3120e558c4db0"/>
+          <a:blip xmlns:r="http://schemas.openxmlformats.org/officeDocument/2006/relationships" xmlns:a="http://schemas.openxmlformats.org/drawingml/2006/main" r:embed="R05cf515588f645a0"/>
           <a:srcRect xmlns:a="http://schemas.openxmlformats.org/drawingml/2006/main" l="19" t="0" r="18" b="0"/>
           <a:stretch xmlns:a="http://schemas.openxmlformats.org/drawingml/2006/main">
             <a:fillRect l="0" t="0" r="0" b="0"/>
@@ -7307,7 +7307,7 @@
           <p:nvPr/>
         </p:nvPicPr>
         <p:blipFill>
-          <a:blip xmlns:r="http://schemas.openxmlformats.org/officeDocument/2006/relationships" xmlns:a="http://schemas.openxmlformats.org/drawingml/2006/main" r:embed="R6c10d453ec9d476a"/>
+          <a:blip xmlns:r="http://schemas.openxmlformats.org/officeDocument/2006/relationships" xmlns:a="http://schemas.openxmlformats.org/drawingml/2006/main" r:embed="Re72833768c3044b2"/>
           <a:srcRect xmlns:a="http://schemas.openxmlformats.org/drawingml/2006/main" l="19" t="0" r="18" b="0"/>
           <a:stretch xmlns:a="http://schemas.openxmlformats.org/drawingml/2006/main">
             <a:fillRect l="0" t="0" r="0" b="0"/>
@@ -9032,7 +9032,7 @@
           <p:nvPr/>
         </p:nvPicPr>
         <p:blipFill>
-          <a:blip xmlns:r="http://schemas.openxmlformats.org/officeDocument/2006/relationships" xmlns:a="http://schemas.openxmlformats.org/drawingml/2006/main" r:embed="R1b64003bba034a23"/>
+          <a:blip xmlns:r="http://schemas.openxmlformats.org/officeDocument/2006/relationships" xmlns:a="http://schemas.openxmlformats.org/drawingml/2006/main" r:embed="R0523718026e54089"/>
           <a:srcRect xmlns:a="http://schemas.openxmlformats.org/drawingml/2006/main" l="19" t="0" r="18" b="0"/>
           <a:stretch xmlns:a="http://schemas.openxmlformats.org/drawingml/2006/main">
             <a:fillRect l="0" t="0" r="0" b="0"/>
@@ -10757,7 +10757,7 @@
           <p:nvPr/>
         </p:nvPicPr>
         <p:blipFill>
-          <a:blip xmlns:r="http://schemas.openxmlformats.org/officeDocument/2006/relationships" xmlns:a="http://schemas.openxmlformats.org/drawingml/2006/main" r:embed="R83825345833d450d"/>
+          <a:blip xmlns:r="http://schemas.openxmlformats.org/officeDocument/2006/relationships" xmlns:a="http://schemas.openxmlformats.org/drawingml/2006/main" r:embed="R7629e8cbef4d4931"/>
           <a:srcRect xmlns:a="http://schemas.openxmlformats.org/drawingml/2006/main" l="19" t="0" r="18" b="0"/>
           <a:stretch xmlns:a="http://schemas.openxmlformats.org/drawingml/2006/main">
             <a:fillRect l="0" t="0" r="0" b="0"/>
@@ -10898,7 +10898,7 @@
         <p:spPr>
           <a:xfrm xmlns:a="http://schemas.openxmlformats.org/drawingml/2006/main">
             <a:off x="838200" y="1104900"/>
-            <a:ext cx="11420475" cy="378024"/>
+            <a:ext cx="11249025" cy="378024"/>
           </a:xfrm>
           <a:prstGeom xmlns:a="http://schemas.openxmlformats.org/drawingml/2006/main" prst="rect">
             <a:avLst/>
@@ -10930,7 +10930,7 @@
               <a:buNone/>
             </a:pPr>
             <a:r>
-              <a:t>COSTO: USD 662/MES</a:t>
+              <a:t>USD 737/MES</a:t>
             </a:r>
           </a:p>
         </p:txBody>
@@ -10952,7 +10952,7 @@
         <p:spPr>
           <a:xfrm xmlns:a="http://schemas.openxmlformats.org/drawingml/2006/main">
             <a:off x="866775" y="1638300"/>
-            <a:ext cx="11420475" cy="243781"/>
+            <a:ext cx="11249025" cy="243781"/>
           </a:xfrm>
           <a:prstGeom xmlns:a="http://schemas.openxmlformats.org/drawingml/2006/main" prst="rect">
             <a:avLst/>
@@ -10984,7 +10984,7 @@
               <a:buNone/>
             </a:pPr>
             <a:r>
-              <a:t>On-Demand us-east-1; incluye backups, transferencia y logs.</a:t>
+              <a:t>Calculator 700,04 + VPN 36,50 · On-Demand us-east-1</a:t>
             </a:r>
           </a:p>
         </p:txBody>
@@ -11279,7 +11279,7 @@
               <a:buNone/>
             </a:pPr>
             <a:r>
-              <a:t>USD 662,22</a:t>
+              <a:t>USD 736,54</a:t>
             </a:r>
           </a:p>
         </p:txBody>
@@ -11333,7 +11333,7 @@
               <a:buNone/>
             </a:pPr>
             <a:r>
-              <a:t>mensual · USD 7.946,64 anual</a:t>
+              <a:t>mensual · USD 8.838,48 anual</a:t>
             </a:r>
           </a:p>
         </p:txBody>
@@ -11682,7 +11682,7 @@
               <a:buNone/>
             </a:pPr>
             <a:r>
-              <a:t>81,6 %</a:t>
+              <a:t>78,8 %</a:t>
             </a:r>
           </a:p>
         </p:txBody>
@@ -12085,7 +12085,7 @@
               <a:buNone/>
             </a:pPr>
             <a:r>
-              <a:t>USD 379,74</a:t>
+              <a:t>USD 454,06</a:t>
             </a:r>
           </a:p>
         </p:txBody>
@@ -12482,7 +12482,7 @@
           <p:nvPr/>
         </p:nvPicPr>
         <p:blipFill>
-          <a:blip xmlns:r="http://schemas.openxmlformats.org/officeDocument/2006/relationships" xmlns:a="http://schemas.openxmlformats.org/drawingml/2006/main" r:embed="R0774186d56e04944"/>
+          <a:blip xmlns:r="http://schemas.openxmlformats.org/officeDocument/2006/relationships" xmlns:a="http://schemas.openxmlformats.org/drawingml/2006/main" r:embed="R3fd555f2dcbb4ed8"/>
           <a:srcRect xmlns:a="http://schemas.openxmlformats.org/drawingml/2006/main" l="19" t="0" r="18" b="0"/>
           <a:stretch xmlns:a="http://schemas.openxmlformats.org/drawingml/2006/main">
             <a:fillRect l="0" t="0" r="0" b="0"/>

</xml_diff>

<commit_message>
docs: reconcile PrivateLink costs in final deliverables
</commit_message>
<xml_diff>
--- a/outputs/proyecto-final-sap-analytics-aws.pptx
+++ b/outputs/proyecto-final-sap-analytics-aws.pptx
@@ -2,20 +2,20 @@
 <file path=ppt/presentation.xml><?xml version="1.0" encoding="utf-8"?>
 <p:presentation xmlns:p="http://schemas.openxmlformats.org/presentationml/2006/main">
   <p:sldMasterIdLst>
-    <p:sldMasterId xmlns:r="http://schemas.openxmlformats.org/officeDocument/2006/relationships" id="2147483648" r:id="R03bdfa3fe31444dd"/>
+    <p:sldMasterId xmlns:r="http://schemas.openxmlformats.org/officeDocument/2006/relationships" id="2147483648" r:id="R80fb1794559b4aab"/>
   </p:sldMasterIdLst>
   <p:notesMasterIdLst>
-    <p:notesMasterId xmlns:r="http://schemas.openxmlformats.org/officeDocument/2006/relationships" r:id="Rb7fde6d1753e4304"/>
+    <p:notesMasterId xmlns:r="http://schemas.openxmlformats.org/officeDocument/2006/relationships" r:id="R200d8adf83c94ba4"/>
   </p:notesMasterIdLst>
   <p:sldIdLst>
-    <p:sldId xmlns:r="http://schemas.openxmlformats.org/officeDocument/2006/relationships" id="256" r:id="Rc1b1094f40584e41"/>
-    <p:sldId xmlns:r="http://schemas.openxmlformats.org/officeDocument/2006/relationships" id="257" r:id="Re6a6daad39b94cf9"/>
-    <p:sldId xmlns:r="http://schemas.openxmlformats.org/officeDocument/2006/relationships" id="258" r:id="Re886127aec714eb6"/>
-    <p:sldId xmlns:r="http://schemas.openxmlformats.org/officeDocument/2006/relationships" id="259" r:id="R416d0a8deea0403f"/>
-    <p:sldId xmlns:r="http://schemas.openxmlformats.org/officeDocument/2006/relationships" id="260" r:id="R7baf9d35fdd9452b"/>
-    <p:sldId xmlns:r="http://schemas.openxmlformats.org/officeDocument/2006/relationships" id="261" r:id="Re41605867a904737"/>
-    <p:sldId xmlns:r="http://schemas.openxmlformats.org/officeDocument/2006/relationships" id="262" r:id="R90b5db182ea941ae"/>
-    <p:sldId xmlns:r="http://schemas.openxmlformats.org/officeDocument/2006/relationships" id="263" r:id="R17b07323238a46a1"/>
+    <p:sldId xmlns:r="http://schemas.openxmlformats.org/officeDocument/2006/relationships" id="256" r:id="R4aadc721399b4468"/>
+    <p:sldId xmlns:r="http://schemas.openxmlformats.org/officeDocument/2006/relationships" id="257" r:id="R7f2a4aae1e314a27"/>
+    <p:sldId xmlns:r="http://schemas.openxmlformats.org/officeDocument/2006/relationships" id="258" r:id="Rfc1693d479e749c8"/>
+    <p:sldId xmlns:r="http://schemas.openxmlformats.org/officeDocument/2006/relationships" id="259" r:id="R2076128624414e01"/>
+    <p:sldId xmlns:r="http://schemas.openxmlformats.org/officeDocument/2006/relationships" id="260" r:id="R433fa3047dbf42e0"/>
+    <p:sldId xmlns:r="http://schemas.openxmlformats.org/officeDocument/2006/relationships" id="261" r:id="R4c1dfd06d2d045de"/>
+    <p:sldId xmlns:r="http://schemas.openxmlformats.org/officeDocument/2006/relationships" id="262" r:id="Rff23bb86eece4c0e"/>
+    <p:sldId xmlns:r="http://schemas.openxmlformats.org/officeDocument/2006/relationships" id="263" r:id="R1c82c02f44e247d2"/>
   </p:sldIdLst>
   <p:sldSz cx="12192000" cy="6858000"/>
   <p:notesSz cx="6858000" cy="9144000"/>
@@ -892,6 +892,15 @@
               <a:t>- https://calculator.aws/</a:t>
             </a:r>
           </a:p>
+          <a:p xmlns:a="http://schemas.openxmlformats.org/drawingml/2006/main">
+            <a:r>
+              <a:t>[Sources]
+- https://aws.amazon.com/privatelink/pricing/
+- https://docs.aws.amazon.com/vpc/latest/privatelink/gateway-endpoints.html
+- costs/aws-us-east-1.json (verificado 2026-08-16)
+[/Sources]</a:t>
+            </a:r>
+          </a:p>
         </p:txBody>
       </p:sp>
       <p:sp>
@@ -1233,7 +1242,7 @@
   </p:cSld>
   <p:clrMap bg1="lt1" tx1="dk1" bg2="lt2" tx2="dk2" accent1="accent1" accent2="accent2" accent3="accent3" accent4="accent4" accent5="accent5" accent6="accent6" hlink="hlink" folHlink="folHlink"/>
   <p:sldLayoutIdLst>
-    <p:sldLayoutId xmlns:r="http://schemas.openxmlformats.org/officeDocument/2006/relationships" id="2147483649" r:id="R3e0e85653cfd4b74"/>
+    <p:sldLayoutId xmlns:r="http://schemas.openxmlformats.org/officeDocument/2006/relationships" id="2147483649" r:id="R4fd69eeaa9c24503"/>
   </p:sldLayoutIdLst>
   <p:txStyles>
     <p:titleStyle>
@@ -2115,7 +2124,7 @@
           <p:nvPr/>
         </p:nvPicPr>
         <p:blipFill>
-          <a:blip xmlns:r="http://schemas.openxmlformats.org/officeDocument/2006/relationships" xmlns:a="http://schemas.openxmlformats.org/drawingml/2006/main" r:embed="Rb6bf05f47a5a48b7"/>
+          <a:blip xmlns:r="http://schemas.openxmlformats.org/officeDocument/2006/relationships" xmlns:a="http://schemas.openxmlformats.org/drawingml/2006/main" r:embed="R56e0817106484479"/>
           <a:srcRect xmlns:a="http://schemas.openxmlformats.org/drawingml/2006/main" l="19" t="0" r="18" b="0"/>
           <a:stretch xmlns:a="http://schemas.openxmlformats.org/drawingml/2006/main">
             <a:fillRect l="0" t="0" r="0" b="0"/>
@@ -2143,7 +2152,7 @@
           <p:nvPr/>
         </p:nvPicPr>
         <p:blipFill>
-          <a:blip xmlns:r="http://schemas.openxmlformats.org/officeDocument/2006/relationships" xmlns:a="http://schemas.openxmlformats.org/drawingml/2006/main" r:embed="Rbe829faa81074619"/>
+          <a:blip xmlns:r="http://schemas.openxmlformats.org/officeDocument/2006/relationships" xmlns:a="http://schemas.openxmlformats.org/drawingml/2006/main" r:embed="R99530f4a8753434d"/>
           <a:stretch xmlns:a="http://schemas.openxmlformats.org/drawingml/2006/main">
             <a:fillRect l="0" t="0" r="0" b="0"/>
           </a:stretch>
@@ -2391,7 +2400,7 @@
           <p:nvPr/>
         </p:nvPicPr>
         <p:blipFill>
-          <a:blip xmlns:r="http://schemas.openxmlformats.org/officeDocument/2006/relationships" xmlns:a="http://schemas.openxmlformats.org/drawingml/2006/main" r:embed="Rd4b5e71abfe7467a"/>
+          <a:blip xmlns:r="http://schemas.openxmlformats.org/officeDocument/2006/relationships" xmlns:a="http://schemas.openxmlformats.org/drawingml/2006/main" r:embed="R7d8613caa2314c21"/>
           <a:srcRect xmlns:a="http://schemas.openxmlformats.org/drawingml/2006/main" l="19" t="0" r="18" b="0"/>
           <a:stretch xmlns:a="http://schemas.openxmlformats.org/drawingml/2006/main">
             <a:fillRect l="0" t="0" r="0" b="0"/>
@@ -2795,7 +2804,7 @@
           <p:nvPr/>
         </p:nvPicPr>
         <p:blipFill>
-          <a:blip xmlns:r="http://schemas.openxmlformats.org/officeDocument/2006/relationships" xmlns:a="http://schemas.openxmlformats.org/drawingml/2006/main" r:embed="R2525e47161fc42e8"/>
+          <a:blip xmlns:r="http://schemas.openxmlformats.org/officeDocument/2006/relationships" xmlns:a="http://schemas.openxmlformats.org/drawingml/2006/main" r:embed="Rb93ef3ded87040d8"/>
           <a:srcRect xmlns:a="http://schemas.openxmlformats.org/drawingml/2006/main" l="19" t="0" r="18" b="0"/>
           <a:stretch xmlns:a="http://schemas.openxmlformats.org/drawingml/2006/main">
             <a:fillRect l="0" t="0" r="0" b="0"/>
@@ -4115,7 +4124,7 @@
           <p:nvPr/>
         </p:nvPicPr>
         <p:blipFill>
-          <a:blip xmlns:r="http://schemas.openxmlformats.org/officeDocument/2006/relationships" xmlns:a="http://schemas.openxmlformats.org/drawingml/2006/main" r:embed="R05cf515588f645a0"/>
+          <a:blip xmlns:r="http://schemas.openxmlformats.org/officeDocument/2006/relationships" xmlns:a="http://schemas.openxmlformats.org/drawingml/2006/main" r:embed="R6f5c47b5804948ee"/>
           <a:srcRect xmlns:a="http://schemas.openxmlformats.org/drawingml/2006/main" l="19" t="0" r="18" b="0"/>
           <a:stretch xmlns:a="http://schemas.openxmlformats.org/drawingml/2006/main">
             <a:fillRect l="0" t="0" r="0" b="0"/>
@@ -7307,7 +7316,7 @@
           <p:nvPr/>
         </p:nvPicPr>
         <p:blipFill>
-          <a:blip xmlns:r="http://schemas.openxmlformats.org/officeDocument/2006/relationships" xmlns:a="http://schemas.openxmlformats.org/drawingml/2006/main" r:embed="Re72833768c3044b2"/>
+          <a:blip xmlns:r="http://schemas.openxmlformats.org/officeDocument/2006/relationships" xmlns:a="http://schemas.openxmlformats.org/drawingml/2006/main" r:embed="R2407fa2435fd4db4"/>
           <a:srcRect xmlns:a="http://schemas.openxmlformats.org/drawingml/2006/main" l="19" t="0" r="18" b="0"/>
           <a:stretch xmlns:a="http://schemas.openxmlformats.org/drawingml/2006/main">
             <a:fillRect l="0" t="0" r="0" b="0"/>
@@ -9032,7 +9041,7 @@
           <p:nvPr/>
         </p:nvPicPr>
         <p:blipFill>
-          <a:blip xmlns:r="http://schemas.openxmlformats.org/officeDocument/2006/relationships" xmlns:a="http://schemas.openxmlformats.org/drawingml/2006/main" r:embed="R0523718026e54089"/>
+          <a:blip xmlns:r="http://schemas.openxmlformats.org/officeDocument/2006/relationships" xmlns:a="http://schemas.openxmlformats.org/drawingml/2006/main" r:embed="R42c16e2976ee4112"/>
           <a:srcRect xmlns:a="http://schemas.openxmlformats.org/drawingml/2006/main" l="19" t="0" r="18" b="0"/>
           <a:stretch xmlns:a="http://schemas.openxmlformats.org/drawingml/2006/main">
             <a:fillRect l="0" t="0" r="0" b="0"/>
@@ -10757,7 +10766,7 @@
           <p:nvPr/>
         </p:nvPicPr>
         <p:blipFill>
-          <a:blip xmlns:r="http://schemas.openxmlformats.org/officeDocument/2006/relationships" xmlns:a="http://schemas.openxmlformats.org/drawingml/2006/main" r:embed="R7629e8cbef4d4931"/>
+          <a:blip xmlns:r="http://schemas.openxmlformats.org/officeDocument/2006/relationships" xmlns:a="http://schemas.openxmlformats.org/drawingml/2006/main" r:embed="Rccc0af1c24ff442a"/>
           <a:srcRect xmlns:a="http://schemas.openxmlformats.org/drawingml/2006/main" l="19" t="0" r="18" b="0"/>
           <a:stretch xmlns:a="http://schemas.openxmlformats.org/drawingml/2006/main">
             <a:fillRect l="0" t="0" r="0" b="0"/>
@@ -10930,7 +10939,7 @@
               <a:buNone/>
             </a:pPr>
             <a:r>
-              <a:t>USD 737/MES</a:t>
+              <a:t>USD 780/MES</a:t>
             </a:r>
           </a:p>
         </p:txBody>
@@ -10984,7 +10993,7 @@
               <a:buNone/>
             </a:pPr>
             <a:r>
-              <a:t>Calculator 700,04 + VPN 36,50 · On-Demand us-east-1</a:t>
+              <a:t>Calculator 700,04 + VPN 36,50 + PrivateLink 43,90</a:t>
             </a:r>
           </a:p>
         </p:txBody>
@@ -11279,7 +11288,7 @@
               <a:buNone/>
             </a:pPr>
             <a:r>
-              <a:t>USD 736,54</a:t>
+              <a:t>USD 780,44</a:t>
             </a:r>
           </a:p>
         </p:txBody>
@@ -11333,7 +11342,7 @@
               <a:buNone/>
             </a:pPr>
             <a:r>
-              <a:t>mensual · USD 8.838,48 anual</a:t>
+              <a:t>mensual · USD 9.365,28 anual</a:t>
             </a:r>
           </a:p>
         </p:txBody>
@@ -11387,7 +11396,7 @@
               <a:buNone/>
             </a:pPr>
             <a:r>
-              <a:t>Incluye ETL, RDS Multi-AZ, dos gateways Windows, VPN, S3, AppFlow, KMS, secretos y monitoreo.</a:t>
+              <a:t>Incluye ETL, RDS Multi-AZ, gateways Windows, VPN, PrivateLink, S3, AppFlow, KMS y monitoreo.</a:t>
             </a:r>
           </a:p>
         </p:txBody>
@@ -11682,7 +11691,7 @@
               <a:buNone/>
             </a:pPr>
             <a:r>
-              <a:t>78,8 %</a:t>
+              <a:t>74,4 %</a:t>
             </a:r>
           </a:p>
         </p:txBody>
@@ -12085,7 +12094,7 @@
               <a:buNone/>
             </a:pPr>
             <a:r>
-              <a:t>USD 454,06</a:t>
+              <a:t>USD 497,96</a:t>
             </a:r>
           </a:p>
         </p:txBody>
@@ -12482,7 +12491,7 @@
           <p:nvPr/>
         </p:nvPicPr>
         <p:blipFill>
-          <a:blip xmlns:r="http://schemas.openxmlformats.org/officeDocument/2006/relationships" xmlns:a="http://schemas.openxmlformats.org/drawingml/2006/main" r:embed="R3fd555f2dcbb4ed8"/>
+          <a:blip xmlns:r="http://schemas.openxmlformats.org/officeDocument/2006/relationships" xmlns:a="http://schemas.openxmlformats.org/drawingml/2006/main" r:embed="R7989e51e288a4100"/>
           <a:srcRect xmlns:a="http://schemas.openxmlformats.org/drawingml/2006/main" l="19" t="0" r="18" b="0"/>
           <a:stretch xmlns:a="http://schemas.openxmlformats.org/drawingml/2006/main">
             <a:fillRect l="0" t="0" r="0" b="0"/>
@@ -12970,7 +12979,7 @@
               <a:buNone/>
             </a:pPr>
             <a:r>
-              <a:t>5 pruebas · Terraform 1.5.7 válido</a:t>
+              <a:t>13 pruebas · Terraform 1.5.7 válido</a:t>
             </a:r>
           </a:p>
         </p:txBody>

</xml_diff>

<commit_message>
docs: publish hardened architecture v3
</commit_message>
<xml_diff>
--- a/outputs/proyecto-final-sap-analytics-aws.pptx
+++ b/outputs/proyecto-final-sap-analytics-aws.pptx
@@ -2,20 +2,20 @@
 <file path=ppt/presentation.xml><?xml version="1.0" encoding="utf-8"?>
 <p:presentation xmlns:p="http://schemas.openxmlformats.org/presentationml/2006/main">
   <p:sldMasterIdLst>
-    <p:sldMasterId xmlns:r="http://schemas.openxmlformats.org/officeDocument/2006/relationships" id="2147483648" r:id="R80fb1794559b4aab"/>
+    <p:sldMasterId xmlns:r="http://schemas.openxmlformats.org/officeDocument/2006/relationships" id="2147483648" r:id="Rc1ec6c63a18044a9"/>
   </p:sldMasterIdLst>
   <p:notesMasterIdLst>
-    <p:notesMasterId xmlns:r="http://schemas.openxmlformats.org/officeDocument/2006/relationships" r:id="R200d8adf83c94ba4"/>
+    <p:notesMasterId xmlns:r="http://schemas.openxmlformats.org/officeDocument/2006/relationships" r:id="Rc663632451ce4f45"/>
   </p:notesMasterIdLst>
   <p:sldIdLst>
-    <p:sldId xmlns:r="http://schemas.openxmlformats.org/officeDocument/2006/relationships" id="256" r:id="R4aadc721399b4468"/>
-    <p:sldId xmlns:r="http://schemas.openxmlformats.org/officeDocument/2006/relationships" id="257" r:id="R7f2a4aae1e314a27"/>
-    <p:sldId xmlns:r="http://schemas.openxmlformats.org/officeDocument/2006/relationships" id="258" r:id="Rfc1693d479e749c8"/>
-    <p:sldId xmlns:r="http://schemas.openxmlformats.org/officeDocument/2006/relationships" id="259" r:id="R2076128624414e01"/>
-    <p:sldId xmlns:r="http://schemas.openxmlformats.org/officeDocument/2006/relationships" id="260" r:id="R433fa3047dbf42e0"/>
-    <p:sldId xmlns:r="http://schemas.openxmlformats.org/officeDocument/2006/relationships" id="261" r:id="R4c1dfd06d2d045de"/>
-    <p:sldId xmlns:r="http://schemas.openxmlformats.org/officeDocument/2006/relationships" id="262" r:id="Rff23bb86eece4c0e"/>
-    <p:sldId xmlns:r="http://schemas.openxmlformats.org/officeDocument/2006/relationships" id="263" r:id="R1c82c02f44e247d2"/>
+    <p:sldId xmlns:r="http://schemas.openxmlformats.org/officeDocument/2006/relationships" id="256" r:id="Re1af0c350e9b413c"/>
+    <p:sldId xmlns:r="http://schemas.openxmlformats.org/officeDocument/2006/relationships" id="257" r:id="R51337c4c3f7a4523"/>
+    <p:sldId xmlns:r="http://schemas.openxmlformats.org/officeDocument/2006/relationships" id="258" r:id="R770eb7305caf4149"/>
+    <p:sldId xmlns:r="http://schemas.openxmlformats.org/officeDocument/2006/relationships" id="259" r:id="R68156d012fca453a"/>
+    <p:sldId xmlns:r="http://schemas.openxmlformats.org/officeDocument/2006/relationships" id="260" r:id="R73056830521244d4"/>
+    <p:sldId xmlns:r="http://schemas.openxmlformats.org/officeDocument/2006/relationships" id="261" r:id="R00b97a4607654aaa"/>
+    <p:sldId xmlns:r="http://schemas.openxmlformats.org/officeDocument/2006/relationships" id="262" r:id="R636b2b42ae754eb2"/>
+    <p:sldId xmlns:r="http://schemas.openxmlformats.org/officeDocument/2006/relationships" id="263" r:id="R156cad9f774e4bc6"/>
   </p:sldIdLst>
   <p:sldSz cx="12192000" cy="6858000"/>
   <p:notesSz cx="6858000" cy="9144000"/>
@@ -634,17 +634,37 @@
           <a:lstStyle xmlns:a="http://schemas.openxmlformats.org/drawingml/2006/main"/>
           <a:p xmlns:a="http://schemas.openxmlformats.org/drawingml/2006/main">
             <a:r>
+              <a:t>La arquitectura v3 incorpora los controles solicitados para producción: endpoints privados, egress restringido y backend remoto de Terraform.</a:t>
+            </a:r>
+          </a:p>
+          <a:p xmlns:a="http://schemas.openxmlformats.org/drawingml/2006/main">
+            <a:r>
               <a:t>[Sources]</a:t>
             </a:r>
           </a:p>
           <a:p xmlns:a="http://schemas.openxmlformats.org/drawingml/2006/main">
             <a:r>
+              <a:t>- outputs/arquitectura-sap-erp-slt-aws-consumo-v3.png</a:t>
+            </a:r>
+          </a:p>
+          <a:p xmlns:a="http://schemas.openxmlformats.org/drawingml/2006/main">
+            <a:r>
               <a:t>- docs/architecture.md</a:t>
             </a:r>
           </a:p>
           <a:p xmlns:a="http://schemas.openxmlformats.org/drawingml/2006/main">
             <a:r>
-              <a:t>- outputs/arquitectura-sap-erp-slt-aws-consumo-v2.png</a:t>
+              <a:t>- iac/networking.tf</a:t>
+            </a:r>
+          </a:p>
+          <a:p xmlns:a="http://schemas.openxmlformats.org/drawingml/2006/main">
+            <a:r>
+              <a:t>- https://docs.aws.amazon.com/vpc/latest/privatelink/gateway-endpoints.html</a:t>
+            </a:r>
+          </a:p>
+          <a:p xmlns:a="http://schemas.openxmlformats.org/drawingml/2006/main">
+            <a:r>
+              <a:t>- https://aws.amazon.com/privatelink/pricing/</a:t>
             </a:r>
           </a:p>
         </p:txBody>
@@ -1242,7 +1262,7 @@
   </p:cSld>
   <p:clrMap bg1="lt1" tx1="dk1" bg2="lt2" tx2="dk2" accent1="accent1" accent2="accent2" accent3="accent3" accent4="accent4" accent5="accent5" accent6="accent6" hlink="hlink" folHlink="folHlink"/>
   <p:sldLayoutIdLst>
-    <p:sldLayoutId xmlns:r="http://schemas.openxmlformats.org/officeDocument/2006/relationships" id="2147483649" r:id="R4fd69eeaa9c24503"/>
+    <p:sldLayoutId xmlns:r="http://schemas.openxmlformats.org/officeDocument/2006/relationships" id="2147483649" r:id="R838c2b5227ee4c51"/>
   </p:sldLayoutIdLst>
   <p:txStyles>
     <p:titleStyle>
@@ -2124,7 +2144,7 @@
           <p:nvPr/>
         </p:nvPicPr>
         <p:blipFill>
-          <a:blip xmlns:r="http://schemas.openxmlformats.org/officeDocument/2006/relationships" xmlns:a="http://schemas.openxmlformats.org/drawingml/2006/main" r:embed="R56e0817106484479"/>
+          <a:blip xmlns:r="http://schemas.openxmlformats.org/officeDocument/2006/relationships" xmlns:a="http://schemas.openxmlformats.org/drawingml/2006/main" r:embed="Rc9b02ac328bf4b58"/>
           <a:srcRect xmlns:a="http://schemas.openxmlformats.org/drawingml/2006/main" l="19" t="0" r="18" b="0"/>
           <a:stretch xmlns:a="http://schemas.openxmlformats.org/drawingml/2006/main">
             <a:fillRect l="0" t="0" r="0" b="0"/>
@@ -2152,7 +2172,7 @@
           <p:nvPr/>
         </p:nvPicPr>
         <p:blipFill>
-          <a:blip xmlns:r="http://schemas.openxmlformats.org/officeDocument/2006/relationships" xmlns:a="http://schemas.openxmlformats.org/drawingml/2006/main" r:embed="R99530f4a8753434d"/>
+          <a:blip xmlns:r="http://schemas.openxmlformats.org/officeDocument/2006/relationships" xmlns:a="http://schemas.openxmlformats.org/drawingml/2006/main" r:embed="R011788ea841c417e"/>
           <a:stretch xmlns:a="http://schemas.openxmlformats.org/drawingml/2006/main">
             <a:fillRect l="0" t="0" r="0" b="0"/>
           </a:stretch>
@@ -2400,7 +2420,7 @@
           <p:nvPr/>
         </p:nvPicPr>
         <p:blipFill>
-          <a:blip xmlns:r="http://schemas.openxmlformats.org/officeDocument/2006/relationships" xmlns:a="http://schemas.openxmlformats.org/drawingml/2006/main" r:embed="R7d8613caa2314c21"/>
+          <a:blip xmlns:r="http://schemas.openxmlformats.org/officeDocument/2006/relationships" xmlns:a="http://schemas.openxmlformats.org/drawingml/2006/main" r:embed="R4cf5fcb998874a9d"/>
           <a:srcRect xmlns:a="http://schemas.openxmlformats.org/drawingml/2006/main" l="19" t="0" r="18" b="0"/>
           <a:stretch xmlns:a="http://schemas.openxmlformats.org/drawingml/2006/main">
             <a:fillRect l="0" t="0" r="0" b="0"/>
@@ -2804,7 +2824,7 @@
           <p:nvPr/>
         </p:nvPicPr>
         <p:blipFill>
-          <a:blip xmlns:r="http://schemas.openxmlformats.org/officeDocument/2006/relationships" xmlns:a="http://schemas.openxmlformats.org/drawingml/2006/main" r:embed="Rb93ef3ded87040d8"/>
+          <a:blip xmlns:r="http://schemas.openxmlformats.org/officeDocument/2006/relationships" xmlns:a="http://schemas.openxmlformats.org/drawingml/2006/main" r:embed="R5d0a0c4fcd344f92"/>
           <a:srcRect xmlns:a="http://schemas.openxmlformats.org/drawingml/2006/main" l="19" t="0" r="18" b="0"/>
           <a:stretch xmlns:a="http://schemas.openxmlformats.org/drawingml/2006/main">
             <a:fillRect l="0" t="0" r="0" b="0"/>
@@ -4078,3176 +4098,28 @@
       <p:grpSpPr>
         <a:xfrm xmlns:a="http://schemas.openxmlformats.org/drawingml/2006/main"/>
       </p:grpSpPr>
-      <p:sp>
-        <p:nvSpPr>
-          <p:cNvPr id="238" name="Shape 0">
-            <a:extLst xmlns:a="http://schemas.openxmlformats.org/drawingml/2006/main">
-              <a:ext uri="{FF2B5EF4-FFF2-40B4-BE49-F238E27FC236}">
-                <a16:creationId xmlns:a16="http://schemas.microsoft.com/office/drawing/2014/main" id="{2A6B98D2-3949-45DF-801A-36F21AB89AB4}"/>
-              </a:ext>
-            </a:extLst>
-          </p:cNvPr>
-          <p:cNvSpPr>
-            <a:spLocks xmlns:a="http://schemas.openxmlformats.org/drawingml/2006/main" noGrp="1"/>
-          </p:cNvSpPr>
-          <p:nvPr/>
-        </p:nvSpPr>
-        <p:spPr>
-          <a:xfrm xmlns:a="http://schemas.openxmlformats.org/drawingml/2006/main">
-            <a:off x="0" y="0"/>
-            <a:ext cx="12192000" cy="6858000"/>
-          </a:xfrm>
-          <a:prstGeom xmlns:a="http://schemas.openxmlformats.org/drawingml/2006/main" prst="rect">
-            <a:avLst/>
-          </a:prstGeom>
-          <a:solidFill xmlns:a="http://schemas.openxmlformats.org/drawingml/2006/main">
-            <a:srgbClr val="FFFFFF"/>
-          </a:solidFill>
-          <a:ln xmlns:a="http://schemas.openxmlformats.org/drawingml/2006/main" w="12700"/>
-        </p:spPr>
-        <p:txBody>
-          <a:bodyPr xmlns:a="http://schemas.openxmlformats.org/drawingml/2006/main" lIns="45719" rIns="45719"/>
-          <a:lstStyle xmlns:a="http://schemas.openxmlformats.org/drawingml/2006/main"/>
-          <a:p xmlns:a="http://schemas.openxmlformats.org/drawingml/2006/main">
-            <a:pPr>
-              <a:buNone/>
-            </a:pPr>
-          </a:p>
-        </p:txBody>
-      </p:sp>
       <p:pic>
         <p:nvPicPr>
-          <p:cNvPr id="305" name="Image 0"/>
+          <p:cNvPr id="2" name=""/>
           <p:cNvPicPr>
             <a:picLocks xmlns:a="http://schemas.openxmlformats.org/drawingml/2006/main" noChangeAspect="1"/>
           </p:cNvPicPr>
           <p:nvPr/>
         </p:nvPicPr>
         <p:blipFill>
-          <a:blip xmlns:r="http://schemas.openxmlformats.org/officeDocument/2006/relationships" xmlns:a="http://schemas.openxmlformats.org/drawingml/2006/main" r:embed="R6f5c47b5804948ee"/>
-          <a:srcRect xmlns:a="http://schemas.openxmlformats.org/drawingml/2006/main" l="19" t="0" r="18" b="0"/>
-          <a:stretch xmlns:a="http://schemas.openxmlformats.org/drawingml/2006/main">
-            <a:fillRect l="0" t="0" r="0" b="0"/>
-          </a:stretch>
+          <a:blip xmlns:r="http://schemas.openxmlformats.org/officeDocument/2006/relationships" xmlns:a="http://schemas.openxmlformats.org/drawingml/2006/main" r:embed="R2390ee0ed4ea4a9f"/>
+          <a:stretch xmlns:a="http://schemas.openxmlformats.org/drawingml/2006/main"/>
         </p:blipFill>
         <p:spPr>
           <a:xfrm xmlns:a="http://schemas.openxmlformats.org/drawingml/2006/main">
-            <a:off x="0" y="0"/>
-            <a:ext cx="12192001" cy="6858000"/>
-          </a:xfrm>
-          <a:prstGeom xmlns:a="http://schemas.openxmlformats.org/drawingml/2006/main" prst="rect">
-            <a:avLst/>
-          </a:prstGeom>
-          <a:ln xmlns:a="http://schemas.openxmlformats.org/drawingml/2006/main" w="12700">
-            <a:miter/>
-          </a:ln>
+            <a:off x="6883" y="0"/>
+            <a:ext cx="12178234" cy="6858000"/>
+          </a:xfrm>
+          <a:prstGeom xmlns:a="http://schemas.openxmlformats.org/drawingml/2006/main" prst="rect">
+            <a:avLst/>
+          </a:prstGeom>
         </p:spPr>
       </p:pic>
-      <p:sp>
-        <p:nvSpPr>
-          <p:cNvPr id="240" name="Text 1">
-            <a:extLst xmlns:a="http://schemas.openxmlformats.org/drawingml/2006/main">
-              <a:ext uri="{FF2B5EF4-FFF2-40B4-BE49-F238E27FC236}">
-                <a16:creationId xmlns:a16="http://schemas.microsoft.com/office/drawing/2014/main" id="{1A3CD259-A7C6-4016-8612-8E23D32B88BF}"/>
-              </a:ext>
-            </a:extLst>
-          </p:cNvPr>
-          <p:cNvSpPr>
-            <a:spLocks xmlns:a="http://schemas.openxmlformats.org/drawingml/2006/main" noGrp="1"/>
-          </p:cNvSpPr>
-          <p:nvPr/>
-        </p:nvSpPr>
-        <p:spPr>
-          <a:xfrm xmlns:a="http://schemas.openxmlformats.org/drawingml/2006/main">
-            <a:off x="838200" y="771525"/>
-            <a:ext cx="173386" cy="200025"/>
-          </a:xfrm>
-          <a:prstGeom xmlns:a="http://schemas.openxmlformats.org/drawingml/2006/main" prst="rect">
-            <a:avLst/>
-          </a:prstGeom>
-          <a:ln xmlns:a="http://schemas.openxmlformats.org/drawingml/2006/main" w="12700"/>
-        </p:spPr>
-        <p:txBody>
-          <a:bodyPr xmlns:a="http://schemas.openxmlformats.org/drawingml/2006/main" lIns="25400" tIns="25400" rIns="25400" bIns="25400">
-            <a:normAutofit fontScale="90748" lnSpcReduction="0"/>
-          </a:bodyPr>
-          <a:lstStyle xmlns:a="http://schemas.openxmlformats.org/drawingml/2006/main">
-            <a:lvl1pPr defTabSz="822959">
-              <a:buNone/>
-              <a:defRPr sz="1079" b="1">
-                <a:solidFill>
-                  <a:srgbClr val="2458FF"/>
-                </a:solidFill>
-                <a:latin typeface="Chivo"/>
-                <a:ea typeface="Chivo"/>
-                <a:cs typeface="Chivo"/>
-              </a:defRPr>
-            </a:lvl1pPr>
-          </a:lstStyle>
-          <a:p xmlns:a="http://schemas.openxmlformats.org/drawingml/2006/main">
-            <a:pPr>
-              <a:buNone/>
-            </a:pPr>
-            <a:r>
-              <a:t>&gt;</a:t>
-            </a:r>
-          </a:p>
-        </p:txBody>
-      </p:sp>
-      <p:sp>
-        <p:nvSpPr>
-          <p:cNvPr id="241" name="Text 2">
-            <a:extLst xmlns:a="http://schemas.openxmlformats.org/drawingml/2006/main">
-              <a:ext uri="{FF2B5EF4-FFF2-40B4-BE49-F238E27FC236}">
-                <a16:creationId xmlns:a16="http://schemas.microsoft.com/office/drawing/2014/main" id="{8E059322-99EA-47FF-AA61-8DDEFCCE120D}"/>
-              </a:ext>
-            </a:extLst>
-          </p:cNvPr>
-          <p:cNvSpPr>
-            <a:spLocks xmlns:a="http://schemas.openxmlformats.org/drawingml/2006/main" noGrp="1"/>
-          </p:cNvSpPr>
-          <p:nvPr/>
-        </p:nvSpPr>
-        <p:spPr>
-          <a:xfrm xmlns:a="http://schemas.openxmlformats.org/drawingml/2006/main">
-            <a:off x="1030634" y="762000"/>
-            <a:ext cx="3452671" cy="245269"/>
-          </a:xfrm>
-          <a:prstGeom xmlns:a="http://schemas.openxmlformats.org/drawingml/2006/main" prst="rect">
-            <a:avLst/>
-          </a:prstGeom>
-          <a:ln xmlns:a="http://schemas.openxmlformats.org/drawingml/2006/main" w="12700"/>
-        </p:spPr>
-        <p:txBody>
-          <a:bodyPr xmlns:a="http://schemas.openxmlformats.org/drawingml/2006/main" wrap="none" lIns="25400" tIns="25400" rIns="25400" bIns="25400">
-            <a:normAutofit fontScale="80003" lnSpcReduction="0"/>
-          </a:bodyPr>
-          <a:lstStyle xmlns:a="http://schemas.openxmlformats.org/drawingml/2006/main">
-            <a:lvl1pPr>
-              <a:lnSpc>
-                <a:spcPct val="145000"/>
-              </a:lnSpc>
-              <a:buNone/>
-              <a:defRPr sz="1100" b="1" spc="100">
-                <a:solidFill>
-                  <a:srgbClr val="111111"/>
-                </a:solidFill>
-                <a:latin typeface="Chivo"/>
-                <a:ea typeface="Chivo"/>
-                <a:cs typeface="Chivo"/>
-              </a:defRPr>
-            </a:lvl1pPr>
-          </a:lstStyle>
-          <a:p xmlns:a="http://schemas.openxmlformats.org/drawingml/2006/main">
-            <a:pPr>
-              <a:buNone/>
-            </a:pPr>
-            <a:r>
-              <a:t>PROYECTO FINAL/ARQUITECTURA</a:t>
-            </a:r>
-          </a:p>
-        </p:txBody>
-      </p:sp>
-      <p:sp>
-        <p:nvSpPr>
-          <p:cNvPr id="242" name="Text 3">
-            <a:extLst xmlns:a="http://schemas.openxmlformats.org/drawingml/2006/main">
-              <a:ext uri="{FF2B5EF4-FFF2-40B4-BE49-F238E27FC236}">
-                <a16:creationId xmlns:a16="http://schemas.microsoft.com/office/drawing/2014/main" id="{AF3D01C9-673E-4CEF-9628-950C52D76355}"/>
-              </a:ext>
-            </a:extLst>
-          </p:cNvPr>
-          <p:cNvSpPr>
-            <a:spLocks xmlns:a="http://schemas.openxmlformats.org/drawingml/2006/main" noGrp="1"/>
-          </p:cNvSpPr>
-          <p:nvPr/>
-        </p:nvSpPr>
-        <p:spPr>
-          <a:xfrm xmlns:a="http://schemas.openxmlformats.org/drawingml/2006/main">
-            <a:off x="838200" y="1104900"/>
-            <a:ext cx="11420475" cy="378024"/>
-          </a:xfrm>
-          <a:prstGeom xmlns:a="http://schemas.openxmlformats.org/drawingml/2006/main" prst="rect">
-            <a:avLst/>
-          </a:prstGeom>
-          <a:ln xmlns:a="http://schemas.openxmlformats.org/drawingml/2006/main" w="12700"/>
-        </p:spPr>
-        <p:txBody>
-          <a:bodyPr xmlns:a="http://schemas.openxmlformats.org/drawingml/2006/main" lIns="25400" tIns="25400" rIns="25400" bIns="25400">
-            <a:normAutofit fontScale="90885" lnSpcReduction="0"/>
-          </a:bodyPr>
-          <a:lstStyle xmlns:a="http://schemas.openxmlformats.org/drawingml/2006/main">
-            <a:lvl1pPr defTabSz="822959">
-              <a:lnSpc>
-                <a:spcPct val="104999"/>
-              </a:lnSpc>
-              <a:buNone/>
-              <a:defRPr sz="2250" b="1" spc="-90">
-                <a:solidFill>
-                  <a:srgbClr val="111111"/>
-                </a:solidFill>
-                <a:latin typeface="Chivo"/>
-                <a:ea typeface="Chivo"/>
-                <a:cs typeface="Chivo"/>
-              </a:defRPr>
-            </a:lvl1pPr>
-          </a:lstStyle>
-          <a:p xmlns:a="http://schemas.openxmlformats.org/drawingml/2006/main">
-            <a:pPr>
-              <a:buNone/>
-            </a:pPr>
-            <a:r>
-              <a:t>CUATRO CAPAS</a:t>
-            </a:r>
-          </a:p>
-        </p:txBody>
-      </p:sp>
-      <p:sp>
-        <p:nvSpPr>
-          <p:cNvPr id="243" name="Text 4">
-            <a:extLst xmlns:a="http://schemas.openxmlformats.org/drawingml/2006/main">
-              <a:ext uri="{FF2B5EF4-FFF2-40B4-BE49-F238E27FC236}">
-                <a16:creationId xmlns:a16="http://schemas.microsoft.com/office/drawing/2014/main" id="{53E69E5E-221A-461B-A7D4-C345DFCD8228}"/>
-              </a:ext>
-            </a:extLst>
-          </p:cNvPr>
-          <p:cNvSpPr>
-            <a:spLocks xmlns:a="http://schemas.openxmlformats.org/drawingml/2006/main" noGrp="1"/>
-          </p:cNvSpPr>
-          <p:nvPr/>
-        </p:nvSpPr>
-        <p:spPr>
-          <a:xfrm xmlns:a="http://schemas.openxmlformats.org/drawingml/2006/main">
-            <a:off x="866775" y="1638300"/>
-            <a:ext cx="11420475" cy="243781"/>
-          </a:xfrm>
-          <a:prstGeom xmlns:a="http://schemas.openxmlformats.org/drawingml/2006/main" prst="rect">
-            <a:avLst/>
-          </a:prstGeom>
-          <a:ln xmlns:a="http://schemas.openxmlformats.org/drawingml/2006/main" w="12700"/>
-        </p:spPr>
-        <p:txBody>
-          <a:bodyPr xmlns:a="http://schemas.openxmlformats.org/drawingml/2006/main" lIns="25400" tIns="25400" rIns="25400" bIns="25400">
-            <a:normAutofit fontScale="78165" lnSpcReduction="0"/>
-          </a:bodyPr>
-          <a:lstStyle xmlns:a="http://schemas.openxmlformats.org/drawingml/2006/main">
-            <a:lvl1pPr>
-              <a:lnSpc>
-                <a:spcPct val="135000"/>
-              </a:lnSpc>
-              <a:buNone/>
-              <a:defRPr sz="1200">
-                <a:solidFill>
-                  <a:srgbClr val="666666"/>
-                </a:solidFill>
-                <a:latin typeface="Chivo"/>
-                <a:ea typeface="Chivo"/>
-                <a:cs typeface="Chivo"/>
-              </a:defRPr>
-            </a:lvl1pPr>
-          </a:lstStyle>
-          <a:p xmlns:a="http://schemas.openxmlformats.org/drawingml/2006/main">
-            <a:pPr>
-              <a:buNone/>
-            </a:pPr>
-            <a:r>
-              <a:t>Responsabilidad, identidad y reproceso en cada capa.</a:t>
-            </a:r>
-          </a:p>
-        </p:txBody>
-      </p:sp>
-      <p:sp>
-        <p:nvSpPr>
-          <p:cNvPr id="244" name="Shape 5">
-            <a:extLst xmlns:a="http://schemas.openxmlformats.org/drawingml/2006/main">
-              <a:ext uri="{FF2B5EF4-FFF2-40B4-BE49-F238E27FC236}">
-                <a16:creationId xmlns:a16="http://schemas.microsoft.com/office/drawing/2014/main" id="{BC25D237-3DDA-46A5-95C5-E4B85933DD37}"/>
-              </a:ext>
-            </a:extLst>
-          </p:cNvPr>
-          <p:cNvSpPr>
-            <a:spLocks xmlns:a="http://schemas.openxmlformats.org/drawingml/2006/main" noGrp="1"/>
-          </p:cNvSpPr>
-          <p:nvPr/>
-        </p:nvSpPr>
-        <p:spPr>
-          <a:xfrm xmlns:a="http://schemas.openxmlformats.org/drawingml/2006/main">
-            <a:off x="838200" y="2247900"/>
-            <a:ext cx="5305425" cy="1694409"/>
-          </a:xfrm>
-          <a:prstGeom xmlns:a="http://schemas.openxmlformats.org/drawingml/2006/main" prst="roundRect">
-            <a:avLst>
-              <a:gd name="adj" fmla="val 6746"/>
-            </a:avLst>
-          </a:prstGeom>
-          <a:solidFill xmlns:a="http://schemas.openxmlformats.org/drawingml/2006/main">
-            <a:srgbClr val="FFFFFF"/>
-          </a:solidFill>
-          <a:ln xmlns:a="http://schemas.openxmlformats.org/drawingml/2006/main">
-            <a:solidFill>
-              <a:srgbClr val="D8D8D8"/>
-            </a:solidFill>
-          </a:ln>
-        </p:spPr>
-        <p:txBody>
-          <a:bodyPr xmlns:a="http://schemas.openxmlformats.org/drawingml/2006/main" lIns="45719" rIns="45719"/>
-          <a:lstStyle xmlns:a="http://schemas.openxmlformats.org/drawingml/2006/main"/>
-          <a:p xmlns:a="http://schemas.openxmlformats.org/drawingml/2006/main">
-            <a:pPr>
-              <a:buNone/>
-            </a:pPr>
-          </a:p>
-        </p:txBody>
-      </p:sp>
-      <p:sp>
-        <p:nvSpPr>
-          <p:cNvPr id="245" name="Shape 6">
-            <a:extLst xmlns:a="http://schemas.openxmlformats.org/drawingml/2006/main">
-              <a:ext uri="{FF2B5EF4-FFF2-40B4-BE49-F238E27FC236}">
-                <a16:creationId xmlns:a16="http://schemas.microsoft.com/office/drawing/2014/main" id="{FBB739F4-75EB-4A28-9183-6F1BAAF2FBC0}"/>
-              </a:ext>
-            </a:extLst>
-          </p:cNvPr>
-          <p:cNvSpPr>
-            <a:spLocks xmlns:a="http://schemas.openxmlformats.org/drawingml/2006/main" noGrp="1"/>
-          </p:cNvSpPr>
-          <p:nvPr/>
-        </p:nvSpPr>
-        <p:spPr>
-          <a:xfrm xmlns:a="http://schemas.openxmlformats.org/drawingml/2006/main">
-            <a:off x="1057275" y="2466975"/>
-            <a:ext cx="1523108" cy="208956"/>
-          </a:xfrm>
-          <a:prstGeom xmlns:a="http://schemas.openxmlformats.org/drawingml/2006/main" prst="roundRect">
-            <a:avLst>
-              <a:gd name="adj" fmla="val 27350"/>
-            </a:avLst>
-          </a:prstGeom>
-          <a:solidFill xmlns:a="http://schemas.openxmlformats.org/drawingml/2006/main">
-            <a:srgbClr val="2458FF">
-              <a:alpha val="10000"/>
-            </a:srgbClr>
-          </a:solidFill>
-          <a:ln xmlns:a="http://schemas.openxmlformats.org/drawingml/2006/main" w="12700"/>
-        </p:spPr>
-        <p:txBody>
-          <a:bodyPr xmlns:a="http://schemas.openxmlformats.org/drawingml/2006/main" lIns="45719" rIns="45719"/>
-          <a:lstStyle xmlns:a="http://schemas.openxmlformats.org/drawingml/2006/main"/>
-          <a:p xmlns:a="http://schemas.openxmlformats.org/drawingml/2006/main">
-            <a:pPr>
-              <a:buNone/>
-            </a:pPr>
-          </a:p>
-        </p:txBody>
-      </p:sp>
-      <p:sp>
-        <p:nvSpPr>
-          <p:cNvPr id="246" name="Text 7">
-            <a:extLst xmlns:a="http://schemas.openxmlformats.org/drawingml/2006/main">
-              <a:ext uri="{FF2B5EF4-FFF2-40B4-BE49-F238E27FC236}">
-                <a16:creationId xmlns:a16="http://schemas.microsoft.com/office/drawing/2014/main" id="{31E6E61B-9EC8-4F21-9810-9FECF49090F8}"/>
-              </a:ext>
-            </a:extLst>
-          </p:cNvPr>
-          <p:cNvSpPr>
-            <a:spLocks xmlns:a="http://schemas.openxmlformats.org/drawingml/2006/main" noGrp="1"/>
-          </p:cNvSpPr>
-          <p:nvPr/>
-        </p:nvSpPr>
-        <p:spPr>
-          <a:xfrm xmlns:a="http://schemas.openxmlformats.org/drawingml/2006/main">
-            <a:off x="1143000" y="2495550"/>
-            <a:ext cx="1427858" cy="189906"/>
-          </a:xfrm>
-          <a:prstGeom xmlns:a="http://schemas.openxmlformats.org/drawingml/2006/main" prst="rect">
-            <a:avLst/>
-          </a:prstGeom>
-          <a:ln xmlns:a="http://schemas.openxmlformats.org/drawingml/2006/main" w="12700"/>
-        </p:spPr>
-        <p:txBody>
-          <a:bodyPr xmlns:a="http://schemas.openxmlformats.org/drawingml/2006/main" lIns="25400" tIns="25400" rIns="25400" bIns="25400">
-            <a:normAutofit fontScale="78687" lnSpcReduction="0"/>
-          </a:bodyPr>
-          <a:lstStyle xmlns:a="http://schemas.openxmlformats.org/drawingml/2006/main">
-            <a:lvl1pPr>
-              <a:lnSpc>
-                <a:spcPct val="145000"/>
-              </a:lnSpc>
-              <a:buNone/>
-              <a:defRPr sz="800">
-                <a:solidFill>
-                  <a:srgbClr val="2458FF"/>
-                </a:solidFill>
-                <a:latin typeface="ITBA Mono"/>
-                <a:ea typeface="ITBA Mono"/>
-                <a:cs typeface="ITBA Mono"/>
-              </a:defRPr>
-            </a:lvl1pPr>
-          </a:lstStyle>
-          <a:p xmlns:a="http://schemas.openxmlformats.org/drawingml/2006/main">
-            <a:pPr>
-              <a:buNone/>
-            </a:pPr>
-            <a:r>
-              <a:t>ORIGEN ON-PREMISE</a:t>
-            </a:r>
-          </a:p>
-        </p:txBody>
-      </p:sp>
-      <p:sp>
-        <p:nvSpPr>
-          <p:cNvPr id="247" name="Text 8">
-            <a:extLst xmlns:a="http://schemas.openxmlformats.org/drawingml/2006/main">
-              <a:ext uri="{FF2B5EF4-FFF2-40B4-BE49-F238E27FC236}">
-                <a16:creationId xmlns:a16="http://schemas.microsoft.com/office/drawing/2014/main" id="{72966C82-3C2B-448B-953D-5B5DC6F3FAB4}"/>
-              </a:ext>
-            </a:extLst>
-          </p:cNvPr>
-          <p:cNvSpPr>
-            <a:spLocks xmlns:a="http://schemas.openxmlformats.org/drawingml/2006/main" noGrp="1"/>
-          </p:cNvSpPr>
-          <p:nvPr/>
-        </p:nvSpPr>
-        <p:spPr>
-          <a:xfrm xmlns:a="http://schemas.openxmlformats.org/drawingml/2006/main">
-            <a:off x="1057275" y="2771180"/>
-            <a:ext cx="5354004" cy="286644"/>
-          </a:xfrm>
-          <a:prstGeom xmlns:a="http://schemas.openxmlformats.org/drawingml/2006/main" prst="rect">
-            <a:avLst/>
-          </a:prstGeom>
-          <a:ln xmlns:a="http://schemas.openxmlformats.org/drawingml/2006/main" w="12700"/>
-        </p:spPr>
-        <p:txBody>
-          <a:bodyPr xmlns:a="http://schemas.openxmlformats.org/drawingml/2006/main" lIns="25400" tIns="25400" rIns="25400" bIns="25400">
-            <a:normAutofit fontScale="82097" lnSpcReduction="0"/>
-          </a:bodyPr>
-          <a:lstStyle xmlns:a="http://schemas.openxmlformats.org/drawingml/2006/main">
-            <a:lvl1pPr>
-              <a:lnSpc>
-                <a:spcPct val="145000"/>
-              </a:lnSpc>
-              <a:buNone/>
-              <a:defRPr sz="1300" b="1">
-                <a:solidFill>
-                  <a:srgbClr val="111111"/>
-                </a:solidFill>
-                <a:latin typeface="Chivo"/>
-                <a:ea typeface="Chivo"/>
-                <a:cs typeface="Chivo"/>
-              </a:defRPr>
-            </a:lvl1pPr>
-          </a:lstStyle>
-          <a:p xmlns:a="http://schemas.openxmlformats.org/drawingml/2006/main">
-            <a:pPr>
-              <a:buNone/>
-            </a:pPr>
-            <a:r>
-              <a:t>ECC–SLT</a:t>
-            </a:r>
-          </a:p>
-        </p:txBody>
-      </p:sp>
-      <p:sp>
-        <p:nvSpPr>
-          <p:cNvPr id="248" name="Text 9">
-            <a:extLst xmlns:a="http://schemas.openxmlformats.org/drawingml/2006/main">
-              <a:ext uri="{FF2B5EF4-FFF2-40B4-BE49-F238E27FC236}">
-                <a16:creationId xmlns:a16="http://schemas.microsoft.com/office/drawing/2014/main" id="{998BCE47-7237-45EB-9276-1D688E905A49}"/>
-              </a:ext>
-            </a:extLst>
-          </p:cNvPr>
-          <p:cNvSpPr>
-            <a:spLocks xmlns:a="http://schemas.openxmlformats.org/drawingml/2006/main" noGrp="1"/>
-          </p:cNvSpPr>
-          <p:nvPr/>
-        </p:nvSpPr>
-        <p:spPr>
-          <a:xfrm xmlns:a="http://schemas.openxmlformats.org/drawingml/2006/main">
-            <a:off x="1057275" y="3076873"/>
-            <a:ext cx="5013293" cy="419736"/>
-          </a:xfrm>
-          <a:prstGeom xmlns:a="http://schemas.openxmlformats.org/drawingml/2006/main" prst="rect">
-            <a:avLst/>
-          </a:prstGeom>
-          <a:ln xmlns:a="http://schemas.openxmlformats.org/drawingml/2006/main" w="12700"/>
-        </p:spPr>
-        <p:txBody>
-          <a:bodyPr xmlns:a="http://schemas.openxmlformats.org/drawingml/2006/main" lIns="25400" tIns="25400" rIns="25400" bIns="25400">
-            <a:normAutofit fontScale="89919" lnSpcReduction="0"/>
-          </a:bodyPr>
-          <a:lstStyle xmlns:a="http://schemas.openxmlformats.org/drawingml/2006/main">
-            <a:lvl1pPr defTabSz="886968">
-              <a:lnSpc>
-                <a:spcPct val="140000"/>
-              </a:lnSpc>
-              <a:buNone/>
-              <a:defRPr sz="970">
-                <a:solidFill>
-                  <a:srgbClr val="666666"/>
-                </a:solidFill>
-                <a:latin typeface="Chivo"/>
-                <a:ea typeface="Chivo"/>
-                <a:cs typeface="Chivo"/>
-              </a:defRPr>
-            </a:lvl1pPr>
-          </a:lstStyle>
-          <a:p xmlns:a="http://schemas.openxmlformats.org/drawingml/2006/main">
-            <a:pPr>
-              <a:buNone/>
-            </a:pPr>
-            <a:r>
-              <a:t>CE1xxxx se replica con DMIS 2018 y se expone como proveedor ODP/OData; SAP BW no participa.</a:t>
-            </a:r>
-          </a:p>
-        </p:txBody>
-      </p:sp>
-      <p:sp>
-        <p:nvSpPr>
-          <p:cNvPr id="249" name="Shape 10">
-            <a:extLst xmlns:a="http://schemas.openxmlformats.org/drawingml/2006/main">
-              <a:ext uri="{FF2B5EF4-FFF2-40B4-BE49-F238E27FC236}">
-                <a16:creationId xmlns:a16="http://schemas.microsoft.com/office/drawing/2014/main" id="{1CAD9AA5-8B74-4B4F-89C9-EB551BAE3A89}"/>
-              </a:ext>
-            </a:extLst>
-          </p:cNvPr>
-          <p:cNvSpPr>
-            <a:spLocks xmlns:a="http://schemas.openxmlformats.org/drawingml/2006/main" noGrp="1"/>
-          </p:cNvSpPr>
-          <p:nvPr/>
-        </p:nvSpPr>
-        <p:spPr>
-          <a:xfrm xmlns:a="http://schemas.openxmlformats.org/drawingml/2006/main">
-            <a:off x="1057275" y="3545383"/>
-            <a:ext cx="828675" cy="215951"/>
-          </a:xfrm>
-          <a:prstGeom xmlns:a="http://schemas.openxmlformats.org/drawingml/2006/main" prst="roundRect">
-            <a:avLst>
-              <a:gd name="adj" fmla="val 50000"/>
-            </a:avLst>
-          </a:prstGeom>
-          <a:solidFill xmlns:a="http://schemas.openxmlformats.org/drawingml/2006/main">
-            <a:srgbClr val="F5F5F5"/>
-          </a:solidFill>
-          <a:ln xmlns:a="http://schemas.openxmlformats.org/drawingml/2006/main">
-            <a:solidFill>
-              <a:srgbClr val="E6E6E6"/>
-            </a:solidFill>
-          </a:ln>
-        </p:spPr>
-        <p:txBody>
-          <a:bodyPr xmlns:a="http://schemas.openxmlformats.org/drawingml/2006/main" lIns="45719" rIns="45719"/>
-          <a:lstStyle xmlns:a="http://schemas.openxmlformats.org/drawingml/2006/main"/>
-          <a:p xmlns:a="http://schemas.openxmlformats.org/drawingml/2006/main">
-            <a:pPr>
-              <a:buNone/>
-            </a:pPr>
-          </a:p>
-        </p:txBody>
-      </p:sp>
-      <p:sp>
-        <p:nvSpPr>
-          <p:cNvPr id="250" name="Text 11">
-            <a:extLst xmlns:a="http://schemas.openxmlformats.org/drawingml/2006/main">
-              <a:ext uri="{FF2B5EF4-FFF2-40B4-BE49-F238E27FC236}">
-                <a16:creationId xmlns:a16="http://schemas.microsoft.com/office/drawing/2014/main" id="{A1BD6CDE-2CD9-4510-B148-3389A6F4C7A3}"/>
-              </a:ext>
-            </a:extLst>
-          </p:cNvPr>
-          <p:cNvSpPr>
-            <a:spLocks xmlns:a="http://schemas.openxmlformats.org/drawingml/2006/main" noGrp="1"/>
-          </p:cNvSpPr>
-          <p:nvPr/>
-        </p:nvSpPr>
-        <p:spPr>
-          <a:xfrm xmlns:a="http://schemas.openxmlformats.org/drawingml/2006/main">
-            <a:off x="1143000" y="3573958"/>
-            <a:ext cx="733425" cy="196901"/>
-          </a:xfrm>
-          <a:prstGeom xmlns:a="http://schemas.openxmlformats.org/drawingml/2006/main" prst="rect">
-            <a:avLst/>
-          </a:prstGeom>
-          <a:ln xmlns:a="http://schemas.openxmlformats.org/drawingml/2006/main" w="12700"/>
-        </p:spPr>
-        <p:txBody>
-          <a:bodyPr xmlns:a="http://schemas.openxmlformats.org/drawingml/2006/main" lIns="25400" tIns="25400" rIns="25400" bIns="25400">
-            <a:normAutofit fontScale="82644" lnSpcReduction="0"/>
-          </a:bodyPr>
-          <a:lstStyle xmlns:a="http://schemas.openxmlformats.org/drawingml/2006/main">
-            <a:lvl1pPr>
-              <a:lnSpc>
-                <a:spcPct val="145000"/>
-              </a:lnSpc>
-              <a:buNone/>
-              <a:defRPr sz="800">
-                <a:solidFill>
-                  <a:srgbClr val="666666"/>
-                </a:solidFill>
-                <a:latin typeface="ITBA Mono"/>
-                <a:ea typeface="ITBA Mono"/>
-                <a:cs typeface="ITBA Mono"/>
-              </a:defRPr>
-            </a:lvl1pPr>
-          </a:lstStyle>
-          <a:p xmlns:a="http://schemas.openxmlformats.org/drawingml/2006/main">
-            <a:pPr>
-              <a:buNone/>
-            </a:pPr>
-            <a:r>
-              <a:t>SAP ECC</a:t>
-            </a:r>
-          </a:p>
-        </p:txBody>
-      </p:sp>
-      <p:sp>
-        <p:nvSpPr>
-          <p:cNvPr id="251" name="Shape 12">
-            <a:extLst xmlns:a="http://schemas.openxmlformats.org/drawingml/2006/main">
-              <a:ext uri="{FF2B5EF4-FFF2-40B4-BE49-F238E27FC236}">
-                <a16:creationId xmlns:a16="http://schemas.microsoft.com/office/drawing/2014/main" id="{3DBF057C-5D8F-46DC-AFDD-284A5BE33CB5}"/>
-              </a:ext>
-            </a:extLst>
-          </p:cNvPr>
-          <p:cNvSpPr>
-            <a:spLocks xmlns:a="http://schemas.openxmlformats.org/drawingml/2006/main" noGrp="1"/>
-          </p:cNvSpPr>
-          <p:nvPr/>
-        </p:nvSpPr>
-        <p:spPr>
-          <a:xfrm xmlns:a="http://schemas.openxmlformats.org/drawingml/2006/main">
-            <a:off x="1943100" y="3545383"/>
-            <a:ext cx="1485900" cy="215951"/>
-          </a:xfrm>
-          <a:prstGeom xmlns:a="http://schemas.openxmlformats.org/drawingml/2006/main" prst="roundRect">
-            <a:avLst>
-              <a:gd name="adj" fmla="val 50000"/>
-            </a:avLst>
-          </a:prstGeom>
-          <a:solidFill xmlns:a="http://schemas.openxmlformats.org/drawingml/2006/main">
-            <a:srgbClr val="F5F5F5"/>
-          </a:solidFill>
-          <a:ln xmlns:a="http://schemas.openxmlformats.org/drawingml/2006/main">
-            <a:solidFill>
-              <a:srgbClr val="E6E6E6"/>
-            </a:solidFill>
-          </a:ln>
-        </p:spPr>
-        <p:txBody>
-          <a:bodyPr xmlns:a="http://schemas.openxmlformats.org/drawingml/2006/main" lIns="45719" rIns="45719"/>
-          <a:lstStyle xmlns:a="http://schemas.openxmlformats.org/drawingml/2006/main"/>
-          <a:p xmlns:a="http://schemas.openxmlformats.org/drawingml/2006/main">
-            <a:pPr>
-              <a:buNone/>
-            </a:pPr>
-          </a:p>
-        </p:txBody>
-      </p:sp>
-      <p:sp>
-        <p:nvSpPr>
-          <p:cNvPr id="252" name="Text 13">
-            <a:extLst xmlns:a="http://schemas.openxmlformats.org/drawingml/2006/main">
-              <a:ext uri="{FF2B5EF4-FFF2-40B4-BE49-F238E27FC236}">
-                <a16:creationId xmlns:a16="http://schemas.microsoft.com/office/drawing/2014/main" id="{318C622C-FCD7-4348-B7CC-F78EC4A372C6}"/>
-              </a:ext>
-            </a:extLst>
-          </p:cNvPr>
-          <p:cNvSpPr>
-            <a:spLocks xmlns:a="http://schemas.openxmlformats.org/drawingml/2006/main" noGrp="1"/>
-          </p:cNvSpPr>
-          <p:nvPr/>
-        </p:nvSpPr>
-        <p:spPr>
-          <a:xfrm xmlns:a="http://schemas.openxmlformats.org/drawingml/2006/main">
-            <a:off x="2028825" y="3573958"/>
-            <a:ext cx="1390650" cy="196901"/>
-          </a:xfrm>
-          <a:prstGeom xmlns:a="http://schemas.openxmlformats.org/drawingml/2006/main" prst="rect">
-            <a:avLst/>
-          </a:prstGeom>
-          <a:ln xmlns:a="http://schemas.openxmlformats.org/drawingml/2006/main" w="12700"/>
-        </p:spPr>
-        <p:txBody>
-          <a:bodyPr xmlns:a="http://schemas.openxmlformats.org/drawingml/2006/main" lIns="25400" tIns="25400" rIns="25400" bIns="25400">
-            <a:normAutofit fontScale="82644" lnSpcReduction="0"/>
-          </a:bodyPr>
-          <a:lstStyle xmlns:a="http://schemas.openxmlformats.org/drawingml/2006/main">
-            <a:lvl1pPr>
-              <a:lnSpc>
-                <a:spcPct val="145000"/>
-              </a:lnSpc>
-              <a:buNone/>
-              <a:defRPr sz="800">
-                <a:solidFill>
-                  <a:srgbClr val="666666"/>
-                </a:solidFill>
-                <a:latin typeface="ITBA Mono"/>
-                <a:ea typeface="ITBA Mono"/>
-                <a:cs typeface="ITBA Mono"/>
-              </a:defRPr>
-            </a:lvl1pPr>
-          </a:lstStyle>
-          <a:p xmlns:a="http://schemas.openxmlformats.org/drawingml/2006/main">
-            <a:pPr>
-              <a:buNone/>
-            </a:pPr>
-            <a:r>
-              <a:t>SAP SLT</a:t>
-            </a:r>
-          </a:p>
-        </p:txBody>
-      </p:sp>
-      <p:sp>
-        <p:nvSpPr>
-          <p:cNvPr id="253" name="Shape 14">
-            <a:extLst xmlns:a="http://schemas.openxmlformats.org/drawingml/2006/main">
-              <a:ext uri="{FF2B5EF4-FFF2-40B4-BE49-F238E27FC236}">
-                <a16:creationId xmlns:a16="http://schemas.microsoft.com/office/drawing/2014/main" id="{C0189788-9B01-45B9-BE57-C52AE545F6F5}"/>
-              </a:ext>
-            </a:extLst>
-          </p:cNvPr>
-          <p:cNvSpPr>
-            <a:spLocks xmlns:a="http://schemas.openxmlformats.org/drawingml/2006/main" noGrp="1"/>
-          </p:cNvSpPr>
-          <p:nvPr/>
-        </p:nvSpPr>
-        <p:spPr>
-          <a:xfrm xmlns:a="http://schemas.openxmlformats.org/drawingml/2006/main">
-            <a:off x="3486150" y="3545383"/>
-            <a:ext cx="390525" cy="215951"/>
-          </a:xfrm>
-          <a:prstGeom xmlns:a="http://schemas.openxmlformats.org/drawingml/2006/main" prst="roundRect">
-            <a:avLst>
-              <a:gd name="adj" fmla="val 50000"/>
-            </a:avLst>
-          </a:prstGeom>
-          <a:solidFill xmlns:a="http://schemas.openxmlformats.org/drawingml/2006/main">
-            <a:srgbClr val="F5F5F5"/>
-          </a:solidFill>
-          <a:ln xmlns:a="http://schemas.openxmlformats.org/drawingml/2006/main">
-            <a:solidFill>
-              <a:srgbClr val="E6E6E6"/>
-            </a:solidFill>
-          </a:ln>
-        </p:spPr>
-        <p:txBody>
-          <a:bodyPr xmlns:a="http://schemas.openxmlformats.org/drawingml/2006/main" lIns="45719" rIns="45719"/>
-          <a:lstStyle xmlns:a="http://schemas.openxmlformats.org/drawingml/2006/main"/>
-          <a:p xmlns:a="http://schemas.openxmlformats.org/drawingml/2006/main">
-            <a:pPr>
-              <a:buNone/>
-            </a:pPr>
-          </a:p>
-        </p:txBody>
-      </p:sp>
-      <p:sp>
-        <p:nvSpPr>
-          <p:cNvPr id="254" name="Text 15">
-            <a:extLst xmlns:a="http://schemas.openxmlformats.org/drawingml/2006/main">
-              <a:ext uri="{FF2B5EF4-FFF2-40B4-BE49-F238E27FC236}">
-                <a16:creationId xmlns:a16="http://schemas.microsoft.com/office/drawing/2014/main" id="{90171159-0620-4116-8256-457441208BAF}"/>
-              </a:ext>
-            </a:extLst>
-          </p:cNvPr>
-          <p:cNvSpPr>
-            <a:spLocks xmlns:a="http://schemas.openxmlformats.org/drawingml/2006/main" noGrp="1"/>
-          </p:cNvSpPr>
-          <p:nvPr/>
-        </p:nvSpPr>
-        <p:spPr>
-          <a:xfrm xmlns:a="http://schemas.openxmlformats.org/drawingml/2006/main">
-            <a:off x="3571875" y="3573958"/>
-            <a:ext cx="295275" cy="196901"/>
-          </a:xfrm>
-          <a:prstGeom xmlns:a="http://schemas.openxmlformats.org/drawingml/2006/main" prst="rect">
-            <a:avLst/>
-          </a:prstGeom>
-          <a:ln xmlns:a="http://schemas.openxmlformats.org/drawingml/2006/main" w="12700"/>
-        </p:spPr>
-        <p:txBody>
-          <a:bodyPr xmlns:a="http://schemas.openxmlformats.org/drawingml/2006/main" lIns="25400" tIns="25400" rIns="25400" bIns="25400">
-            <a:normAutofit fontScale="82644" lnSpcReduction="0"/>
-          </a:bodyPr>
-          <a:lstStyle xmlns:a="http://schemas.openxmlformats.org/drawingml/2006/main">
-            <a:lvl1pPr>
-              <a:lnSpc>
-                <a:spcPct val="145000"/>
-              </a:lnSpc>
-              <a:buNone/>
-              <a:defRPr sz="800">
-                <a:solidFill>
-                  <a:srgbClr val="666666"/>
-                </a:solidFill>
-                <a:latin typeface="ITBA Mono"/>
-                <a:ea typeface="ITBA Mono"/>
-                <a:cs typeface="ITBA Mono"/>
-              </a:defRPr>
-            </a:lvl1pPr>
-          </a:lstStyle>
-          <a:p xmlns:a="http://schemas.openxmlformats.org/drawingml/2006/main">
-            <a:pPr>
-              <a:buNone/>
-            </a:pPr>
-            <a:r>
-              <a:t>ODP</a:t>
-            </a:r>
-          </a:p>
-        </p:txBody>
-      </p:sp>
-      <p:sp>
-        <p:nvSpPr>
-          <p:cNvPr id="255" name="Shape 16">
-            <a:extLst xmlns:a="http://schemas.openxmlformats.org/drawingml/2006/main">
-              <a:ext uri="{FF2B5EF4-FFF2-40B4-BE49-F238E27FC236}">
-                <a16:creationId xmlns:a16="http://schemas.microsoft.com/office/drawing/2014/main" id="{27D84C81-AA8E-4D34-A929-69C1B8230C3C}"/>
-              </a:ext>
-            </a:extLst>
-          </p:cNvPr>
-          <p:cNvSpPr>
-            <a:spLocks xmlns:a="http://schemas.openxmlformats.org/drawingml/2006/main" noGrp="1"/>
-          </p:cNvSpPr>
-          <p:nvPr/>
-        </p:nvSpPr>
-        <p:spPr>
-          <a:xfrm xmlns:a="http://schemas.openxmlformats.org/drawingml/2006/main">
-            <a:off x="3933825" y="3545383"/>
-            <a:ext cx="317600" cy="215951"/>
-          </a:xfrm>
-          <a:prstGeom xmlns:a="http://schemas.openxmlformats.org/drawingml/2006/main" prst="roundRect">
-            <a:avLst>
-              <a:gd name="adj" fmla="val 50000"/>
-            </a:avLst>
-          </a:prstGeom>
-          <a:solidFill xmlns:a="http://schemas.openxmlformats.org/drawingml/2006/main">
-            <a:srgbClr val="F5F5F5"/>
-          </a:solidFill>
-          <a:ln xmlns:a="http://schemas.openxmlformats.org/drawingml/2006/main">
-            <a:solidFill>
-              <a:srgbClr val="E6E6E6"/>
-            </a:solidFill>
-          </a:ln>
-        </p:spPr>
-        <p:txBody>
-          <a:bodyPr xmlns:a="http://schemas.openxmlformats.org/drawingml/2006/main" lIns="45719" rIns="45719"/>
-          <a:lstStyle xmlns:a="http://schemas.openxmlformats.org/drawingml/2006/main"/>
-          <a:p xmlns:a="http://schemas.openxmlformats.org/drawingml/2006/main">
-            <a:pPr>
-              <a:buNone/>
-            </a:pPr>
-          </a:p>
-        </p:txBody>
-      </p:sp>
-      <p:sp>
-        <p:nvSpPr>
-          <p:cNvPr id="256" name="Text 17">
-            <a:extLst xmlns:a="http://schemas.openxmlformats.org/drawingml/2006/main">
-              <a:ext uri="{FF2B5EF4-FFF2-40B4-BE49-F238E27FC236}">
-                <a16:creationId xmlns:a16="http://schemas.microsoft.com/office/drawing/2014/main" id="{50188908-771B-428F-B138-893AEAF740DF}"/>
-              </a:ext>
-            </a:extLst>
-          </p:cNvPr>
-          <p:cNvSpPr>
-            <a:spLocks xmlns:a="http://schemas.openxmlformats.org/drawingml/2006/main" noGrp="1"/>
-          </p:cNvSpPr>
-          <p:nvPr/>
-        </p:nvSpPr>
-        <p:spPr>
-          <a:xfrm xmlns:a="http://schemas.openxmlformats.org/drawingml/2006/main">
-            <a:off x="4019550" y="3573958"/>
-            <a:ext cx="222350" cy="196901"/>
-          </a:xfrm>
-          <a:prstGeom xmlns:a="http://schemas.openxmlformats.org/drawingml/2006/main" prst="rect">
-            <a:avLst/>
-          </a:prstGeom>
-          <a:ln xmlns:a="http://schemas.openxmlformats.org/drawingml/2006/main" w="12700"/>
-        </p:spPr>
-        <p:txBody>
-          <a:bodyPr xmlns:a="http://schemas.openxmlformats.org/drawingml/2006/main" lIns="25400" tIns="25400" rIns="25400" bIns="25400">
-            <a:normAutofit fontScale="59620" lnSpcReduction="0"/>
-          </a:bodyPr>
-          <a:lstStyle xmlns:a="http://schemas.openxmlformats.org/drawingml/2006/main">
-            <a:lvl1pPr>
-              <a:lnSpc>
-                <a:spcPct val="145000"/>
-              </a:lnSpc>
-              <a:buNone/>
-              <a:defRPr sz="800">
-                <a:solidFill>
-                  <a:srgbClr val="666666"/>
-                </a:solidFill>
-                <a:latin typeface="ITBA Mono"/>
-                <a:ea typeface="ITBA Mono"/>
-                <a:cs typeface="ITBA Mono"/>
-              </a:defRPr>
-            </a:lvl1pPr>
-          </a:lstStyle>
-          <a:p xmlns:a="http://schemas.openxmlformats.org/drawingml/2006/main">
-            <a:pPr>
-              <a:buNone/>
-            </a:pPr>
-            <a:r>
-              <a:t>OData</a:t>
-            </a:r>
-          </a:p>
-        </p:txBody>
-      </p:sp>
-      <p:sp>
-        <p:nvSpPr>
-          <p:cNvPr id="257" name="Shape 18">
-            <a:extLst xmlns:a="http://schemas.openxmlformats.org/drawingml/2006/main">
-              <a:ext uri="{FF2B5EF4-FFF2-40B4-BE49-F238E27FC236}">
-                <a16:creationId xmlns:a16="http://schemas.microsoft.com/office/drawing/2014/main" id="{DED3FD37-E523-485D-93F1-50FD813372E3}"/>
-              </a:ext>
-            </a:extLst>
-          </p:cNvPr>
-          <p:cNvSpPr>
-            <a:spLocks xmlns:a="http://schemas.openxmlformats.org/drawingml/2006/main" noGrp="1"/>
-          </p:cNvSpPr>
-          <p:nvPr/>
-        </p:nvSpPr>
-        <p:spPr>
-          <a:xfrm xmlns:a="http://schemas.openxmlformats.org/drawingml/2006/main">
-            <a:off x="4308573" y="3545383"/>
-            <a:ext cx="390526" cy="215951"/>
-          </a:xfrm>
-          <a:prstGeom xmlns:a="http://schemas.openxmlformats.org/drawingml/2006/main" prst="roundRect">
-            <a:avLst>
-              <a:gd name="adj" fmla="val 50000"/>
-            </a:avLst>
-          </a:prstGeom>
-          <a:solidFill xmlns:a="http://schemas.openxmlformats.org/drawingml/2006/main">
-            <a:srgbClr val="F5F5F5"/>
-          </a:solidFill>
-          <a:ln xmlns:a="http://schemas.openxmlformats.org/drawingml/2006/main">
-            <a:solidFill>
-              <a:srgbClr val="E6E6E6"/>
-            </a:solidFill>
-          </a:ln>
-        </p:spPr>
-        <p:txBody>
-          <a:bodyPr xmlns:a="http://schemas.openxmlformats.org/drawingml/2006/main" lIns="45719" rIns="45719"/>
-          <a:lstStyle xmlns:a="http://schemas.openxmlformats.org/drawingml/2006/main"/>
-          <a:p xmlns:a="http://schemas.openxmlformats.org/drawingml/2006/main">
-            <a:pPr>
-              <a:buNone/>
-            </a:pPr>
-          </a:p>
-        </p:txBody>
-      </p:sp>
-      <p:sp>
-        <p:nvSpPr>
-          <p:cNvPr id="258" name="Text 19">
-            <a:extLst xmlns:a="http://schemas.openxmlformats.org/drawingml/2006/main">
-              <a:ext uri="{FF2B5EF4-FFF2-40B4-BE49-F238E27FC236}">
-                <a16:creationId xmlns:a16="http://schemas.microsoft.com/office/drawing/2014/main" id="{C17C5014-5FCE-4769-8A5F-40F1C062270B}"/>
-              </a:ext>
-            </a:extLst>
-          </p:cNvPr>
-          <p:cNvSpPr>
-            <a:spLocks xmlns:a="http://schemas.openxmlformats.org/drawingml/2006/main" noGrp="1"/>
-          </p:cNvSpPr>
-          <p:nvPr/>
-        </p:nvSpPr>
-        <p:spPr>
-          <a:xfrm xmlns:a="http://schemas.openxmlformats.org/drawingml/2006/main">
-            <a:off x="4394298" y="3573958"/>
-            <a:ext cx="295276" cy="196901"/>
-          </a:xfrm>
-          <a:prstGeom xmlns:a="http://schemas.openxmlformats.org/drawingml/2006/main" prst="rect">
-            <a:avLst/>
-          </a:prstGeom>
-          <a:ln xmlns:a="http://schemas.openxmlformats.org/drawingml/2006/main" w="12700"/>
-        </p:spPr>
-        <p:txBody>
-          <a:bodyPr xmlns:a="http://schemas.openxmlformats.org/drawingml/2006/main" lIns="25400" tIns="25400" rIns="25400" bIns="25400">
-            <a:normAutofit fontScale="82644" lnSpcReduction="0"/>
-          </a:bodyPr>
-          <a:lstStyle xmlns:a="http://schemas.openxmlformats.org/drawingml/2006/main">
-            <a:lvl1pPr>
-              <a:lnSpc>
-                <a:spcPct val="145000"/>
-              </a:lnSpc>
-              <a:buNone/>
-              <a:defRPr sz="800">
-                <a:solidFill>
-                  <a:srgbClr val="666666"/>
-                </a:solidFill>
-                <a:latin typeface="ITBA Mono"/>
-                <a:ea typeface="ITBA Mono"/>
-                <a:cs typeface="ITBA Mono"/>
-              </a:defRPr>
-            </a:lvl1pPr>
-          </a:lstStyle>
-          <a:p xmlns:a="http://schemas.openxmlformats.org/drawingml/2006/main">
-            <a:pPr>
-              <a:buNone/>
-            </a:pPr>
-            <a:r>
-              <a:t>VPN</a:t>
-            </a:r>
-          </a:p>
-        </p:txBody>
-      </p:sp>
-      <p:sp>
-        <p:nvSpPr>
-          <p:cNvPr id="259" name="Shape 20">
-            <a:extLst xmlns:a="http://schemas.openxmlformats.org/drawingml/2006/main">
-              <a:ext uri="{FF2B5EF4-FFF2-40B4-BE49-F238E27FC236}">
-                <a16:creationId xmlns:a16="http://schemas.microsoft.com/office/drawing/2014/main" id="{D990BEC9-9288-4EB3-AA5E-4582EB0C6AA3}"/>
-              </a:ext>
-            </a:extLst>
-          </p:cNvPr>
-          <p:cNvSpPr>
-            <a:spLocks xmlns:a="http://schemas.openxmlformats.org/drawingml/2006/main" noGrp="1"/>
-          </p:cNvSpPr>
-          <p:nvPr/>
-        </p:nvSpPr>
-        <p:spPr>
-          <a:xfrm xmlns:a="http://schemas.openxmlformats.org/drawingml/2006/main">
-            <a:off x="6315075" y="2247900"/>
-            <a:ext cx="5305425" cy="1694409"/>
-          </a:xfrm>
-          <a:prstGeom xmlns:a="http://schemas.openxmlformats.org/drawingml/2006/main" prst="roundRect">
-            <a:avLst>
-              <a:gd name="adj" fmla="val 6746"/>
-            </a:avLst>
-          </a:prstGeom>
-          <a:solidFill xmlns:a="http://schemas.openxmlformats.org/drawingml/2006/main">
-            <a:srgbClr val="FFFFFF"/>
-          </a:solidFill>
-          <a:ln xmlns:a="http://schemas.openxmlformats.org/drawingml/2006/main">
-            <a:solidFill>
-              <a:srgbClr val="D8D8D8"/>
-            </a:solidFill>
-          </a:ln>
-        </p:spPr>
-        <p:txBody>
-          <a:bodyPr xmlns:a="http://schemas.openxmlformats.org/drawingml/2006/main" lIns="45719" rIns="45719"/>
-          <a:lstStyle xmlns:a="http://schemas.openxmlformats.org/drawingml/2006/main"/>
-          <a:p xmlns:a="http://schemas.openxmlformats.org/drawingml/2006/main">
-            <a:pPr>
-              <a:buNone/>
-            </a:pPr>
-          </a:p>
-        </p:txBody>
-      </p:sp>
-      <p:sp>
-        <p:nvSpPr>
-          <p:cNvPr id="260" name="Shape 21">
-            <a:extLst xmlns:a="http://schemas.openxmlformats.org/drawingml/2006/main">
-              <a:ext uri="{FF2B5EF4-FFF2-40B4-BE49-F238E27FC236}">
-                <a16:creationId xmlns:a16="http://schemas.microsoft.com/office/drawing/2014/main" id="{0393E0FD-E045-422A-9002-21995807023C}"/>
-              </a:ext>
-            </a:extLst>
-          </p:cNvPr>
-          <p:cNvSpPr>
-            <a:spLocks xmlns:a="http://schemas.openxmlformats.org/drawingml/2006/main" noGrp="1"/>
-          </p:cNvSpPr>
-          <p:nvPr/>
-        </p:nvSpPr>
-        <p:spPr>
-          <a:xfrm xmlns:a="http://schemas.openxmlformats.org/drawingml/2006/main">
-            <a:off x="6534150" y="2466975"/>
-            <a:ext cx="1147614" cy="208956"/>
-          </a:xfrm>
-          <a:prstGeom xmlns:a="http://schemas.openxmlformats.org/drawingml/2006/main" prst="roundRect">
-            <a:avLst>
-              <a:gd name="adj" fmla="val 27350"/>
-            </a:avLst>
-          </a:prstGeom>
-          <a:solidFill xmlns:a="http://schemas.openxmlformats.org/drawingml/2006/main">
-            <a:srgbClr val="00AFCB">
-              <a:alpha val="12000"/>
-            </a:srgbClr>
-          </a:solidFill>
-          <a:ln xmlns:a="http://schemas.openxmlformats.org/drawingml/2006/main" w="12700"/>
-        </p:spPr>
-        <p:txBody>
-          <a:bodyPr xmlns:a="http://schemas.openxmlformats.org/drawingml/2006/main" lIns="45719" rIns="45719"/>
-          <a:lstStyle xmlns:a="http://schemas.openxmlformats.org/drawingml/2006/main"/>
-          <a:p xmlns:a="http://schemas.openxmlformats.org/drawingml/2006/main">
-            <a:pPr>
-              <a:buNone/>
-            </a:pPr>
-          </a:p>
-        </p:txBody>
-      </p:sp>
-      <p:sp>
-        <p:nvSpPr>
-          <p:cNvPr id="261" name="Text 22">
-            <a:extLst xmlns:a="http://schemas.openxmlformats.org/drawingml/2006/main">
-              <a:ext uri="{FF2B5EF4-FFF2-40B4-BE49-F238E27FC236}">
-                <a16:creationId xmlns:a16="http://schemas.microsoft.com/office/drawing/2014/main" id="{B08287AE-804D-4A6E-9FCA-760BEBB48B25}"/>
-              </a:ext>
-            </a:extLst>
-          </p:cNvPr>
-          <p:cNvSpPr>
-            <a:spLocks xmlns:a="http://schemas.openxmlformats.org/drawingml/2006/main" noGrp="1"/>
-          </p:cNvSpPr>
-          <p:nvPr/>
-        </p:nvSpPr>
-        <p:spPr>
-          <a:xfrm xmlns:a="http://schemas.openxmlformats.org/drawingml/2006/main">
-            <a:off x="6619875" y="2495550"/>
-            <a:ext cx="1052364" cy="189906"/>
-          </a:xfrm>
-          <a:prstGeom xmlns:a="http://schemas.openxmlformats.org/drawingml/2006/main" prst="rect">
-            <a:avLst/>
-          </a:prstGeom>
-          <a:ln xmlns:a="http://schemas.openxmlformats.org/drawingml/2006/main" w="12700"/>
-        </p:spPr>
-        <p:txBody>
-          <a:bodyPr xmlns:a="http://schemas.openxmlformats.org/drawingml/2006/main" lIns="25400" tIns="25400" rIns="25400" bIns="25400">
-            <a:normAutofit fontScale="78687" lnSpcReduction="0"/>
-          </a:bodyPr>
-          <a:lstStyle xmlns:a="http://schemas.openxmlformats.org/drawingml/2006/main">
-            <a:lvl1pPr>
-              <a:lnSpc>
-                <a:spcPct val="145000"/>
-              </a:lnSpc>
-              <a:buNone/>
-              <a:defRPr sz="800">
-                <a:solidFill>
-                  <a:srgbClr val="00AFCB"/>
-                </a:solidFill>
-                <a:latin typeface="ITBA Mono"/>
-                <a:ea typeface="ITBA Mono"/>
-                <a:cs typeface="ITBA Mono"/>
-              </a:defRPr>
-            </a:lvl1pPr>
-          </a:lstStyle>
-          <a:p xmlns:a="http://schemas.openxmlformats.org/drawingml/2006/main">
-            <a:pPr>
-              <a:buNone/>
-            </a:pPr>
-            <a:r>
-              <a:t>INGESTA</a:t>
-            </a:r>
-          </a:p>
-        </p:txBody>
-      </p:sp>
-      <p:sp>
-        <p:nvSpPr>
-          <p:cNvPr id="262" name="Text 23">
-            <a:extLst xmlns:a="http://schemas.openxmlformats.org/drawingml/2006/main">
-              <a:ext uri="{FF2B5EF4-FFF2-40B4-BE49-F238E27FC236}">
-                <a16:creationId xmlns:a16="http://schemas.microsoft.com/office/drawing/2014/main" id="{A98DCF15-0CA9-43E4-A37B-82E5A07D106A}"/>
-              </a:ext>
-            </a:extLst>
-          </p:cNvPr>
-          <p:cNvSpPr>
-            <a:spLocks xmlns:a="http://schemas.openxmlformats.org/drawingml/2006/main" noGrp="1"/>
-          </p:cNvSpPr>
-          <p:nvPr/>
-        </p:nvSpPr>
-        <p:spPr>
-          <a:xfrm xmlns:a="http://schemas.openxmlformats.org/drawingml/2006/main">
-            <a:off x="6534150" y="2771180"/>
-            <a:ext cx="5354004" cy="286644"/>
-          </a:xfrm>
-          <a:prstGeom xmlns:a="http://schemas.openxmlformats.org/drawingml/2006/main" prst="rect">
-            <a:avLst/>
-          </a:prstGeom>
-          <a:ln xmlns:a="http://schemas.openxmlformats.org/drawingml/2006/main" w="12700"/>
-        </p:spPr>
-        <p:txBody>
-          <a:bodyPr xmlns:a="http://schemas.openxmlformats.org/drawingml/2006/main" lIns="25400" tIns="25400" rIns="25400" bIns="25400">
-            <a:normAutofit fontScale="82097" lnSpcReduction="0"/>
-          </a:bodyPr>
-          <a:lstStyle xmlns:a="http://schemas.openxmlformats.org/drawingml/2006/main">
-            <a:lvl1pPr>
-              <a:lnSpc>
-                <a:spcPct val="145000"/>
-              </a:lnSpc>
-              <a:buNone/>
-              <a:defRPr sz="1300" b="1">
-                <a:solidFill>
-                  <a:srgbClr val="111111"/>
-                </a:solidFill>
-                <a:latin typeface="Chivo"/>
-                <a:ea typeface="Chivo"/>
-                <a:cs typeface="Chivo"/>
-              </a:defRPr>
-            </a:lvl1pPr>
-          </a:lstStyle>
-          <a:p xmlns:a="http://schemas.openxmlformats.org/drawingml/2006/main">
-            <a:pPr>
-              <a:buNone/>
-            </a:pPr>
-            <a:r>
-              <a:t>AppFlow → S3 Landing</a:t>
-            </a:r>
-          </a:p>
-        </p:txBody>
-      </p:sp>
-      <p:sp>
-        <p:nvSpPr>
-          <p:cNvPr id="263" name="Text 24">
-            <a:extLst xmlns:a="http://schemas.openxmlformats.org/drawingml/2006/main">
-              <a:ext uri="{FF2B5EF4-FFF2-40B4-BE49-F238E27FC236}">
-                <a16:creationId xmlns:a16="http://schemas.microsoft.com/office/drawing/2014/main" id="{39B9F185-3D3B-4EA5-AC31-6202483D7837}"/>
-              </a:ext>
-            </a:extLst>
-          </p:cNvPr>
-          <p:cNvSpPr>
-            <a:spLocks xmlns:a="http://schemas.openxmlformats.org/drawingml/2006/main" noGrp="1"/>
-          </p:cNvSpPr>
-          <p:nvPr/>
-        </p:nvSpPr>
-        <p:spPr>
-          <a:xfrm xmlns:a="http://schemas.openxmlformats.org/drawingml/2006/main">
-            <a:off x="6534150" y="3076873"/>
-            <a:ext cx="5013293" cy="419736"/>
-          </a:xfrm>
-          <a:prstGeom xmlns:a="http://schemas.openxmlformats.org/drawingml/2006/main" prst="rect">
-            <a:avLst/>
-          </a:prstGeom>
-          <a:ln xmlns:a="http://schemas.openxmlformats.org/drawingml/2006/main" w="12700"/>
-        </p:spPr>
-        <p:txBody>
-          <a:bodyPr xmlns:a="http://schemas.openxmlformats.org/drawingml/2006/main" lIns="25400" tIns="25400" rIns="25400" bIns="25400">
-            <a:normAutofit fontScale="89132" lnSpcReduction="0"/>
-          </a:bodyPr>
-          <a:lstStyle xmlns:a="http://schemas.openxmlformats.org/drawingml/2006/main">
-            <a:lvl1pPr defTabSz="886968">
-              <a:lnSpc>
-                <a:spcPct val="140000"/>
-              </a:lnSpc>
-              <a:buNone/>
-              <a:defRPr sz="970">
-                <a:solidFill>
-                  <a:srgbClr val="666666"/>
-                </a:solidFill>
-                <a:latin typeface="Chivo"/>
-                <a:ea typeface="Chivo"/>
-                <a:cs typeface="Chivo"/>
-              </a:defRPr>
-            </a:lvl1pPr>
-          </a:lstStyle>
-          <a:p xmlns:a="http://schemas.openxmlformats.org/drawingml/2006/main">
-            <a:pPr>
-              <a:buNone/>
-            </a:pPr>
-            <a:r>
-              <a:t>La carga inicial se particiona; luego AppFlow procesa deltas horarios y conserva originales para auditoría.</a:t>
-            </a:r>
-          </a:p>
-        </p:txBody>
-      </p:sp>
-      <p:sp>
-        <p:nvSpPr>
-          <p:cNvPr id="264" name="Shape 25">
-            <a:extLst xmlns:a="http://schemas.openxmlformats.org/drawingml/2006/main">
-              <a:ext uri="{FF2B5EF4-FFF2-40B4-BE49-F238E27FC236}">
-                <a16:creationId xmlns:a16="http://schemas.microsoft.com/office/drawing/2014/main" id="{1B504B68-199A-4C29-AE10-40FD3199D8AB}"/>
-              </a:ext>
-            </a:extLst>
-          </p:cNvPr>
-          <p:cNvSpPr>
-            <a:spLocks xmlns:a="http://schemas.openxmlformats.org/drawingml/2006/main" noGrp="1"/>
-          </p:cNvSpPr>
-          <p:nvPr/>
-        </p:nvSpPr>
-        <p:spPr>
-          <a:xfrm xmlns:a="http://schemas.openxmlformats.org/drawingml/2006/main">
-            <a:off x="6534150" y="3545383"/>
-            <a:ext cx="317600" cy="215951"/>
-          </a:xfrm>
-          <a:prstGeom xmlns:a="http://schemas.openxmlformats.org/drawingml/2006/main" prst="roundRect">
-            <a:avLst>
-              <a:gd name="adj" fmla="val 50000"/>
-            </a:avLst>
-          </a:prstGeom>
-          <a:solidFill xmlns:a="http://schemas.openxmlformats.org/drawingml/2006/main">
-            <a:srgbClr val="F5F5F5"/>
-          </a:solidFill>
-          <a:ln xmlns:a="http://schemas.openxmlformats.org/drawingml/2006/main">
-            <a:solidFill>
-              <a:srgbClr val="E6E6E6"/>
-            </a:solidFill>
-          </a:ln>
-        </p:spPr>
-        <p:txBody>
-          <a:bodyPr xmlns:a="http://schemas.openxmlformats.org/drawingml/2006/main" lIns="45719" rIns="45719"/>
-          <a:lstStyle xmlns:a="http://schemas.openxmlformats.org/drawingml/2006/main"/>
-          <a:p xmlns:a="http://schemas.openxmlformats.org/drawingml/2006/main">
-            <a:pPr>
-              <a:buNone/>
-            </a:pPr>
-          </a:p>
-        </p:txBody>
-      </p:sp>
-      <p:sp>
-        <p:nvSpPr>
-          <p:cNvPr id="265" name="Text 26">
-            <a:extLst xmlns:a="http://schemas.openxmlformats.org/drawingml/2006/main">
-              <a:ext uri="{FF2B5EF4-FFF2-40B4-BE49-F238E27FC236}">
-                <a16:creationId xmlns:a16="http://schemas.microsoft.com/office/drawing/2014/main" id="{C8B62ED3-62F1-4F31-9D05-30C0E6EB141D}"/>
-              </a:ext>
-            </a:extLst>
-          </p:cNvPr>
-          <p:cNvSpPr>
-            <a:spLocks xmlns:a="http://schemas.openxmlformats.org/drawingml/2006/main" noGrp="1"/>
-          </p:cNvSpPr>
-          <p:nvPr/>
-        </p:nvSpPr>
-        <p:spPr>
-          <a:xfrm xmlns:a="http://schemas.openxmlformats.org/drawingml/2006/main">
-            <a:off x="6619875" y="3573958"/>
-            <a:ext cx="222350" cy="196901"/>
-          </a:xfrm>
-          <a:prstGeom xmlns:a="http://schemas.openxmlformats.org/drawingml/2006/main" prst="rect">
-            <a:avLst/>
-          </a:prstGeom>
-          <a:ln xmlns:a="http://schemas.openxmlformats.org/drawingml/2006/main" w="12700"/>
-        </p:spPr>
-        <p:txBody>
-          <a:bodyPr xmlns:a="http://schemas.openxmlformats.org/drawingml/2006/main" lIns="25400" tIns="25400" rIns="25400" bIns="25400">
-            <a:normAutofit fontScale="42239" lnSpcReduction="0"/>
-          </a:bodyPr>
-          <a:lstStyle xmlns:a="http://schemas.openxmlformats.org/drawingml/2006/main">
-            <a:lvl1pPr>
-              <a:lnSpc>
-                <a:spcPct val="145000"/>
-              </a:lnSpc>
-              <a:buNone/>
-              <a:defRPr sz="800">
-                <a:solidFill>
-                  <a:srgbClr val="666666"/>
-                </a:solidFill>
-                <a:latin typeface="ITBA Mono"/>
-                <a:ea typeface="ITBA Mono"/>
-                <a:cs typeface="ITBA Mono"/>
-              </a:defRPr>
-            </a:lvl1pPr>
-          </a:lstStyle>
-          <a:p xmlns:a="http://schemas.openxmlformats.org/drawingml/2006/main">
-            <a:pPr>
-              <a:buNone/>
-            </a:pPr>
-            <a:r>
-              <a:t>AppFlow</a:t>
-            </a:r>
-          </a:p>
-        </p:txBody>
-      </p:sp>
-      <p:sp>
-        <p:nvSpPr>
-          <p:cNvPr id="266" name="Shape 27">
-            <a:extLst xmlns:a="http://schemas.openxmlformats.org/drawingml/2006/main">
-              <a:ext uri="{FF2B5EF4-FFF2-40B4-BE49-F238E27FC236}">
-                <a16:creationId xmlns:a16="http://schemas.microsoft.com/office/drawing/2014/main" id="{7F0347AA-4D33-4CFA-9C4F-DBADCA0331C2}"/>
-              </a:ext>
-            </a:extLst>
-          </p:cNvPr>
-          <p:cNvSpPr>
-            <a:spLocks xmlns:a="http://schemas.openxmlformats.org/drawingml/2006/main" noGrp="1"/>
-          </p:cNvSpPr>
-          <p:nvPr/>
-        </p:nvSpPr>
-        <p:spPr>
-          <a:xfrm xmlns:a="http://schemas.openxmlformats.org/drawingml/2006/main">
-            <a:off x="6908899" y="3545383"/>
-            <a:ext cx="390526" cy="215951"/>
-          </a:xfrm>
-          <a:prstGeom xmlns:a="http://schemas.openxmlformats.org/drawingml/2006/main" prst="roundRect">
-            <a:avLst>
-              <a:gd name="adj" fmla="val 50000"/>
-            </a:avLst>
-          </a:prstGeom>
-          <a:solidFill xmlns:a="http://schemas.openxmlformats.org/drawingml/2006/main">
-            <a:srgbClr val="F5F5F5"/>
-          </a:solidFill>
-          <a:ln xmlns:a="http://schemas.openxmlformats.org/drawingml/2006/main">
-            <a:solidFill>
-              <a:srgbClr val="E6E6E6"/>
-            </a:solidFill>
-          </a:ln>
-        </p:spPr>
-        <p:txBody>
-          <a:bodyPr xmlns:a="http://schemas.openxmlformats.org/drawingml/2006/main" lIns="45719" rIns="45719"/>
-          <a:lstStyle xmlns:a="http://schemas.openxmlformats.org/drawingml/2006/main"/>
-          <a:p xmlns:a="http://schemas.openxmlformats.org/drawingml/2006/main">
-            <a:pPr>
-              <a:buNone/>
-            </a:pPr>
-          </a:p>
-        </p:txBody>
-      </p:sp>
-      <p:sp>
-        <p:nvSpPr>
-          <p:cNvPr id="267" name="Text 28">
-            <a:extLst xmlns:a="http://schemas.openxmlformats.org/drawingml/2006/main">
-              <a:ext uri="{FF2B5EF4-FFF2-40B4-BE49-F238E27FC236}">
-                <a16:creationId xmlns:a16="http://schemas.microsoft.com/office/drawing/2014/main" id="{DC5ACF4A-DABE-4FE8-81FF-48D0B9EC786A}"/>
-              </a:ext>
-            </a:extLst>
-          </p:cNvPr>
-          <p:cNvSpPr>
-            <a:spLocks xmlns:a="http://schemas.openxmlformats.org/drawingml/2006/main" noGrp="1"/>
-          </p:cNvSpPr>
-          <p:nvPr/>
-        </p:nvSpPr>
-        <p:spPr>
-          <a:xfrm xmlns:a="http://schemas.openxmlformats.org/drawingml/2006/main">
-            <a:off x="6994624" y="3573958"/>
-            <a:ext cx="295276" cy="196901"/>
-          </a:xfrm>
-          <a:prstGeom xmlns:a="http://schemas.openxmlformats.org/drawingml/2006/main" prst="rect">
-            <a:avLst/>
-          </a:prstGeom>
-          <a:ln xmlns:a="http://schemas.openxmlformats.org/drawingml/2006/main" w="12700"/>
-        </p:spPr>
-        <p:txBody>
-          <a:bodyPr xmlns:a="http://schemas.openxmlformats.org/drawingml/2006/main" lIns="25400" tIns="25400" rIns="25400" bIns="25400">
-            <a:normAutofit fontScale="82644" lnSpcReduction="0"/>
-          </a:bodyPr>
-          <a:lstStyle xmlns:a="http://schemas.openxmlformats.org/drawingml/2006/main">
-            <a:lvl1pPr>
-              <a:lnSpc>
-                <a:spcPct val="145000"/>
-              </a:lnSpc>
-              <a:buNone/>
-              <a:defRPr sz="800">
-                <a:solidFill>
-                  <a:srgbClr val="666666"/>
-                </a:solidFill>
-                <a:latin typeface="ITBA Mono"/>
-                <a:ea typeface="ITBA Mono"/>
-                <a:cs typeface="ITBA Mono"/>
-              </a:defRPr>
-            </a:lvl1pPr>
-          </a:lstStyle>
-          <a:p xmlns:a="http://schemas.openxmlformats.org/drawingml/2006/main">
-            <a:pPr>
-              <a:buNone/>
-            </a:pPr>
-            <a:r>
-              <a:t>S3</a:t>
-            </a:r>
-          </a:p>
-        </p:txBody>
-      </p:sp>
-      <p:sp>
-        <p:nvSpPr>
-          <p:cNvPr id="268" name="Shape 29">
-            <a:extLst xmlns:a="http://schemas.openxmlformats.org/drawingml/2006/main">
-              <a:ext uri="{FF2B5EF4-FFF2-40B4-BE49-F238E27FC236}">
-                <a16:creationId xmlns:a16="http://schemas.microsoft.com/office/drawing/2014/main" id="{E077E5E7-FBD4-46E8-8C54-91AE45E965AF}"/>
-              </a:ext>
-            </a:extLst>
-          </p:cNvPr>
-          <p:cNvSpPr>
-            <a:spLocks xmlns:a="http://schemas.openxmlformats.org/drawingml/2006/main" noGrp="1"/>
-          </p:cNvSpPr>
-          <p:nvPr/>
-        </p:nvSpPr>
-        <p:spPr>
-          <a:xfrm xmlns:a="http://schemas.openxmlformats.org/drawingml/2006/main">
-            <a:off x="7356574" y="3545383"/>
-            <a:ext cx="1047751" cy="215951"/>
-          </a:xfrm>
-          <a:prstGeom xmlns:a="http://schemas.openxmlformats.org/drawingml/2006/main" prst="roundRect">
-            <a:avLst>
-              <a:gd name="adj" fmla="val 50000"/>
-            </a:avLst>
-          </a:prstGeom>
-          <a:solidFill xmlns:a="http://schemas.openxmlformats.org/drawingml/2006/main">
-            <a:srgbClr val="F5F5F5"/>
-          </a:solidFill>
-          <a:ln xmlns:a="http://schemas.openxmlformats.org/drawingml/2006/main">
-            <a:solidFill>
-              <a:srgbClr val="E6E6E6"/>
-            </a:solidFill>
-          </a:ln>
-        </p:spPr>
-        <p:txBody>
-          <a:bodyPr xmlns:a="http://schemas.openxmlformats.org/drawingml/2006/main" lIns="45719" rIns="45719"/>
-          <a:lstStyle xmlns:a="http://schemas.openxmlformats.org/drawingml/2006/main"/>
-          <a:p xmlns:a="http://schemas.openxmlformats.org/drawingml/2006/main">
-            <a:pPr>
-              <a:buNone/>
-            </a:pPr>
-          </a:p>
-        </p:txBody>
-      </p:sp>
-      <p:sp>
-        <p:nvSpPr>
-          <p:cNvPr id="269" name="Text 30">
-            <a:extLst xmlns:a="http://schemas.openxmlformats.org/drawingml/2006/main">
-              <a:ext uri="{FF2B5EF4-FFF2-40B4-BE49-F238E27FC236}">
-                <a16:creationId xmlns:a16="http://schemas.microsoft.com/office/drawing/2014/main" id="{FBB401E5-0B39-4623-9665-700180EB3F6D}"/>
-              </a:ext>
-            </a:extLst>
-          </p:cNvPr>
-          <p:cNvSpPr>
-            <a:spLocks xmlns:a="http://schemas.openxmlformats.org/drawingml/2006/main" noGrp="1"/>
-          </p:cNvSpPr>
-          <p:nvPr/>
-        </p:nvSpPr>
-        <p:spPr>
-          <a:xfrm xmlns:a="http://schemas.openxmlformats.org/drawingml/2006/main">
-            <a:off x="7442299" y="3573958"/>
-            <a:ext cx="952501" cy="196901"/>
-          </a:xfrm>
-          <a:prstGeom xmlns:a="http://schemas.openxmlformats.org/drawingml/2006/main" prst="rect">
-            <a:avLst/>
-          </a:prstGeom>
-          <a:ln xmlns:a="http://schemas.openxmlformats.org/drawingml/2006/main" w="12700"/>
-        </p:spPr>
-        <p:txBody>
-          <a:bodyPr xmlns:a="http://schemas.openxmlformats.org/drawingml/2006/main" lIns="25400" tIns="25400" rIns="25400" bIns="25400">
-            <a:normAutofit fontScale="82644" lnSpcReduction="0"/>
-          </a:bodyPr>
-          <a:lstStyle xmlns:a="http://schemas.openxmlformats.org/drawingml/2006/main">
-            <a:lvl1pPr>
-              <a:lnSpc>
-                <a:spcPct val="145000"/>
-              </a:lnSpc>
-              <a:buNone/>
-              <a:defRPr sz="800">
-                <a:solidFill>
-                  <a:srgbClr val="666666"/>
-                </a:solidFill>
-                <a:latin typeface="ITBA Mono"/>
-                <a:ea typeface="ITBA Mono"/>
-                <a:cs typeface="ITBA Mono"/>
-              </a:defRPr>
-            </a:lvl1pPr>
-          </a:lstStyle>
-          <a:p xmlns:a="http://schemas.openxmlformats.org/drawingml/2006/main">
-            <a:pPr>
-              <a:buNone/>
-            </a:pPr>
-            <a:r>
-              <a:t>Parquet</a:t>
-            </a:r>
-          </a:p>
-        </p:txBody>
-      </p:sp>
-      <p:sp>
-        <p:nvSpPr>
-          <p:cNvPr id="270" name="Shape 31">
-            <a:extLst xmlns:a="http://schemas.openxmlformats.org/drawingml/2006/main">
-              <a:ext uri="{FF2B5EF4-FFF2-40B4-BE49-F238E27FC236}">
-                <a16:creationId xmlns:a16="http://schemas.microsoft.com/office/drawing/2014/main" id="{F39B4764-6C48-44AE-81FB-62E2B69AE00B}"/>
-              </a:ext>
-            </a:extLst>
-          </p:cNvPr>
-          <p:cNvSpPr>
-            <a:spLocks xmlns:a="http://schemas.openxmlformats.org/drawingml/2006/main" noGrp="1"/>
-          </p:cNvSpPr>
-          <p:nvPr/>
-        </p:nvSpPr>
-        <p:spPr>
-          <a:xfrm xmlns:a="http://schemas.openxmlformats.org/drawingml/2006/main">
-            <a:off x="8461474" y="3545383"/>
-            <a:ext cx="390526" cy="215951"/>
-          </a:xfrm>
-          <a:prstGeom xmlns:a="http://schemas.openxmlformats.org/drawingml/2006/main" prst="roundRect">
-            <a:avLst>
-              <a:gd name="adj" fmla="val 50000"/>
-            </a:avLst>
-          </a:prstGeom>
-          <a:solidFill xmlns:a="http://schemas.openxmlformats.org/drawingml/2006/main">
-            <a:srgbClr val="F5F5F5"/>
-          </a:solidFill>
-          <a:ln xmlns:a="http://schemas.openxmlformats.org/drawingml/2006/main">
-            <a:solidFill>
-              <a:srgbClr val="E6E6E6"/>
-            </a:solidFill>
-          </a:ln>
-        </p:spPr>
-        <p:txBody>
-          <a:bodyPr xmlns:a="http://schemas.openxmlformats.org/drawingml/2006/main" lIns="45719" rIns="45719"/>
-          <a:lstStyle xmlns:a="http://schemas.openxmlformats.org/drawingml/2006/main"/>
-          <a:p xmlns:a="http://schemas.openxmlformats.org/drawingml/2006/main">
-            <a:pPr>
-              <a:buNone/>
-            </a:pPr>
-          </a:p>
-        </p:txBody>
-      </p:sp>
-      <p:sp>
-        <p:nvSpPr>
-          <p:cNvPr id="271" name="Text 32">
-            <a:extLst xmlns:a="http://schemas.openxmlformats.org/drawingml/2006/main">
-              <a:ext uri="{FF2B5EF4-FFF2-40B4-BE49-F238E27FC236}">
-                <a16:creationId xmlns:a16="http://schemas.microsoft.com/office/drawing/2014/main" id="{21596E3D-1757-40FA-9DE9-4AAFF23949AB}"/>
-              </a:ext>
-            </a:extLst>
-          </p:cNvPr>
-          <p:cNvSpPr>
-            <a:spLocks xmlns:a="http://schemas.openxmlformats.org/drawingml/2006/main" noGrp="1"/>
-          </p:cNvSpPr>
-          <p:nvPr/>
-        </p:nvSpPr>
-        <p:spPr>
-          <a:xfrm xmlns:a="http://schemas.openxmlformats.org/drawingml/2006/main">
-            <a:off x="8547199" y="3573958"/>
-            <a:ext cx="295276" cy="196901"/>
-          </a:xfrm>
-          <a:prstGeom xmlns:a="http://schemas.openxmlformats.org/drawingml/2006/main" prst="rect">
-            <a:avLst/>
-          </a:prstGeom>
-          <a:ln xmlns:a="http://schemas.openxmlformats.org/drawingml/2006/main" w="12700"/>
-        </p:spPr>
-        <p:txBody>
-          <a:bodyPr xmlns:a="http://schemas.openxmlformats.org/drawingml/2006/main" lIns="25400" tIns="25400" rIns="25400" bIns="25400">
-            <a:normAutofit fontScale="82644" lnSpcReduction="0"/>
-          </a:bodyPr>
-          <a:lstStyle xmlns:a="http://schemas.openxmlformats.org/drawingml/2006/main">
-            <a:lvl1pPr>
-              <a:lnSpc>
-                <a:spcPct val="145000"/>
-              </a:lnSpc>
-              <a:buNone/>
-              <a:defRPr sz="800">
-                <a:solidFill>
-                  <a:srgbClr val="666666"/>
-                </a:solidFill>
-                <a:latin typeface="ITBA Mono"/>
-                <a:ea typeface="ITBA Mono"/>
-                <a:cs typeface="ITBA Mono"/>
-              </a:defRPr>
-            </a:lvl1pPr>
-          </a:lstStyle>
-          <a:p xmlns:a="http://schemas.openxmlformats.org/drawingml/2006/main">
-            <a:pPr>
-              <a:buNone/>
-            </a:pPr>
-            <a:r>
-              <a:t>IAM</a:t>
-            </a:r>
-          </a:p>
-        </p:txBody>
-      </p:sp>
-      <p:sp>
-        <p:nvSpPr>
-          <p:cNvPr id="272" name="Shape 33">
-            <a:extLst xmlns:a="http://schemas.openxmlformats.org/drawingml/2006/main">
-              <a:ext uri="{FF2B5EF4-FFF2-40B4-BE49-F238E27FC236}">
-                <a16:creationId xmlns:a16="http://schemas.microsoft.com/office/drawing/2014/main" id="{B2ECAE17-B3E4-4C80-9E15-6CD25B962E29}"/>
-              </a:ext>
-            </a:extLst>
-          </p:cNvPr>
-          <p:cNvSpPr>
-            <a:spLocks xmlns:a="http://schemas.openxmlformats.org/drawingml/2006/main" noGrp="1"/>
-          </p:cNvSpPr>
-          <p:nvPr/>
-        </p:nvSpPr>
-        <p:spPr>
-          <a:xfrm xmlns:a="http://schemas.openxmlformats.org/drawingml/2006/main">
-            <a:off x="838200" y="4113757"/>
-            <a:ext cx="5305425" cy="1694409"/>
-          </a:xfrm>
-          <a:prstGeom xmlns:a="http://schemas.openxmlformats.org/drawingml/2006/main" prst="roundRect">
-            <a:avLst>
-              <a:gd name="adj" fmla="val 6746"/>
-            </a:avLst>
-          </a:prstGeom>
-          <a:solidFill xmlns:a="http://schemas.openxmlformats.org/drawingml/2006/main">
-            <a:srgbClr val="FFFFFF"/>
-          </a:solidFill>
-          <a:ln xmlns:a="http://schemas.openxmlformats.org/drawingml/2006/main">
-            <a:solidFill>
-              <a:srgbClr val="D8D8D8"/>
-            </a:solidFill>
-          </a:ln>
-        </p:spPr>
-        <p:txBody>
-          <a:bodyPr xmlns:a="http://schemas.openxmlformats.org/drawingml/2006/main" lIns="45719" rIns="45719"/>
-          <a:lstStyle xmlns:a="http://schemas.openxmlformats.org/drawingml/2006/main"/>
-          <a:p xmlns:a="http://schemas.openxmlformats.org/drawingml/2006/main">
-            <a:pPr>
-              <a:buNone/>
-            </a:pPr>
-          </a:p>
-        </p:txBody>
-      </p:sp>
-      <p:sp>
-        <p:nvSpPr>
-          <p:cNvPr id="273" name="Shape 34">
-            <a:extLst xmlns:a="http://schemas.openxmlformats.org/drawingml/2006/main">
-              <a:ext uri="{FF2B5EF4-FFF2-40B4-BE49-F238E27FC236}">
-                <a16:creationId xmlns:a16="http://schemas.microsoft.com/office/drawing/2014/main" id="{B0019E63-3F35-4562-91CC-1A8762FC494C}"/>
-              </a:ext>
-            </a:extLst>
-          </p:cNvPr>
-          <p:cNvSpPr>
-            <a:spLocks xmlns:a="http://schemas.openxmlformats.org/drawingml/2006/main" noGrp="1"/>
-          </p:cNvSpPr>
-          <p:nvPr/>
-        </p:nvSpPr>
-        <p:spPr>
-          <a:xfrm xmlns:a="http://schemas.openxmlformats.org/drawingml/2006/main">
-            <a:off x="1057275" y="4332832"/>
-            <a:ext cx="1147614" cy="208956"/>
-          </a:xfrm>
-          <a:prstGeom xmlns:a="http://schemas.openxmlformats.org/drawingml/2006/main" prst="roundRect">
-            <a:avLst>
-              <a:gd name="adj" fmla="val 27350"/>
-            </a:avLst>
-          </a:prstGeom>
-          <a:solidFill xmlns:a="http://schemas.openxmlformats.org/drawingml/2006/main">
-            <a:srgbClr val="00AFCB">
-              <a:alpha val="12000"/>
-            </a:srgbClr>
-          </a:solidFill>
-          <a:ln xmlns:a="http://schemas.openxmlformats.org/drawingml/2006/main" w="12700"/>
-        </p:spPr>
-        <p:txBody>
-          <a:bodyPr xmlns:a="http://schemas.openxmlformats.org/drawingml/2006/main" lIns="45719" rIns="45719"/>
-          <a:lstStyle xmlns:a="http://schemas.openxmlformats.org/drawingml/2006/main"/>
-          <a:p xmlns:a="http://schemas.openxmlformats.org/drawingml/2006/main">
-            <a:pPr>
-              <a:buNone/>
-            </a:pPr>
-          </a:p>
-        </p:txBody>
-      </p:sp>
-      <p:sp>
-        <p:nvSpPr>
-          <p:cNvPr id="274" name="Text 35">
-            <a:extLst xmlns:a="http://schemas.openxmlformats.org/drawingml/2006/main">
-              <a:ext uri="{FF2B5EF4-FFF2-40B4-BE49-F238E27FC236}">
-                <a16:creationId xmlns:a16="http://schemas.microsoft.com/office/drawing/2014/main" id="{6A97F83E-4FE6-4E4F-86BC-4502D867E98E}"/>
-              </a:ext>
-            </a:extLst>
-          </p:cNvPr>
-          <p:cNvSpPr>
-            <a:spLocks xmlns:a="http://schemas.openxmlformats.org/drawingml/2006/main" noGrp="1"/>
-          </p:cNvSpPr>
-          <p:nvPr/>
-        </p:nvSpPr>
-        <p:spPr>
-          <a:xfrm xmlns:a="http://schemas.openxmlformats.org/drawingml/2006/main">
-            <a:off x="1143000" y="4361407"/>
-            <a:ext cx="1052364" cy="189906"/>
-          </a:xfrm>
-          <a:prstGeom xmlns:a="http://schemas.openxmlformats.org/drawingml/2006/main" prst="rect">
-            <a:avLst/>
-          </a:prstGeom>
-          <a:ln xmlns:a="http://schemas.openxmlformats.org/drawingml/2006/main" w="12700"/>
-        </p:spPr>
-        <p:txBody>
-          <a:bodyPr xmlns:a="http://schemas.openxmlformats.org/drawingml/2006/main" lIns="25400" tIns="25400" rIns="25400" bIns="25400">
-            <a:normAutofit fontScale="78687" lnSpcReduction="0"/>
-          </a:bodyPr>
-          <a:lstStyle xmlns:a="http://schemas.openxmlformats.org/drawingml/2006/main">
-            <a:lvl1pPr>
-              <a:lnSpc>
-                <a:spcPct val="145000"/>
-              </a:lnSpc>
-              <a:buNone/>
-              <a:defRPr sz="800">
-                <a:solidFill>
-                  <a:srgbClr val="00AFCB"/>
-                </a:solidFill>
-                <a:latin typeface="ITBA Mono"/>
-                <a:ea typeface="ITBA Mono"/>
-                <a:cs typeface="ITBA Mono"/>
-              </a:defRPr>
-            </a:lvl1pPr>
-          </a:lstStyle>
-          <a:p xmlns:a="http://schemas.openxmlformats.org/drawingml/2006/main">
-            <a:pPr>
-              <a:buNone/>
-            </a:pPr>
-            <a:r>
-              <a:t>PROCESAMIENTO</a:t>
-            </a:r>
-          </a:p>
-        </p:txBody>
-      </p:sp>
-      <p:sp>
-        <p:nvSpPr>
-          <p:cNvPr id="275" name="Text 36">
-            <a:extLst xmlns:a="http://schemas.openxmlformats.org/drawingml/2006/main">
-              <a:ext uri="{FF2B5EF4-FFF2-40B4-BE49-F238E27FC236}">
-                <a16:creationId xmlns:a16="http://schemas.microsoft.com/office/drawing/2014/main" id="{C9064306-C00D-46B4-BF8A-5CC4BD970BE8}"/>
-              </a:ext>
-            </a:extLst>
-          </p:cNvPr>
-          <p:cNvSpPr>
-            <a:spLocks xmlns:a="http://schemas.openxmlformats.org/drawingml/2006/main" noGrp="1"/>
-          </p:cNvSpPr>
-          <p:nvPr/>
-        </p:nvSpPr>
-        <p:spPr>
-          <a:xfrm xmlns:a="http://schemas.openxmlformats.org/drawingml/2006/main">
-            <a:off x="1057275" y="4637037"/>
-            <a:ext cx="5354004" cy="286644"/>
-          </a:xfrm>
-          <a:prstGeom xmlns:a="http://schemas.openxmlformats.org/drawingml/2006/main" prst="rect">
-            <a:avLst/>
-          </a:prstGeom>
-          <a:ln xmlns:a="http://schemas.openxmlformats.org/drawingml/2006/main" w="12700"/>
-        </p:spPr>
-        <p:txBody>
-          <a:bodyPr xmlns:a="http://schemas.openxmlformats.org/drawingml/2006/main" lIns="25400" tIns="25400" rIns="25400" bIns="25400">
-            <a:normAutofit fontScale="82097" lnSpcReduction="0"/>
-          </a:bodyPr>
-          <a:lstStyle xmlns:a="http://schemas.openxmlformats.org/drawingml/2006/main">
-            <a:lvl1pPr>
-              <a:lnSpc>
-                <a:spcPct val="145000"/>
-              </a:lnSpc>
-              <a:buNone/>
-              <a:defRPr sz="1300" b="1">
-                <a:solidFill>
-                  <a:srgbClr val="111111"/>
-                </a:solidFill>
-                <a:latin typeface="Chivo"/>
-                <a:ea typeface="Chivo"/>
-                <a:cs typeface="Chivo"/>
-              </a:defRPr>
-            </a:lvl1pPr>
-          </a:lstStyle>
-          <a:p xmlns:a="http://schemas.openxmlformats.org/drawingml/2006/main">
-            <a:pPr>
-              <a:buNone/>
-            </a:pPr>
-            <a:r>
-              <a:t>ETL</a:t>
-            </a:r>
-          </a:p>
-        </p:txBody>
-      </p:sp>
-      <p:sp>
-        <p:nvSpPr>
-          <p:cNvPr id="276" name="Text 37">
-            <a:extLst xmlns:a="http://schemas.openxmlformats.org/drawingml/2006/main">
-              <a:ext uri="{FF2B5EF4-FFF2-40B4-BE49-F238E27FC236}">
-                <a16:creationId xmlns:a16="http://schemas.microsoft.com/office/drawing/2014/main" id="{0B9C90DF-859F-435D-B893-F718AB7CF5A6}"/>
-              </a:ext>
-            </a:extLst>
-          </p:cNvPr>
-          <p:cNvSpPr>
-            <a:spLocks xmlns:a="http://schemas.openxmlformats.org/drawingml/2006/main" noGrp="1"/>
-          </p:cNvSpPr>
-          <p:nvPr/>
-        </p:nvSpPr>
-        <p:spPr>
-          <a:xfrm xmlns:a="http://schemas.openxmlformats.org/drawingml/2006/main">
-            <a:off x="1057275" y="4942730"/>
-            <a:ext cx="5013293" cy="419736"/>
-          </a:xfrm>
-          <a:prstGeom xmlns:a="http://schemas.openxmlformats.org/drawingml/2006/main" prst="rect">
-            <a:avLst/>
-          </a:prstGeom>
-          <a:ln xmlns:a="http://schemas.openxmlformats.org/drawingml/2006/main" w="12700"/>
-        </p:spPr>
-        <p:txBody>
-          <a:bodyPr xmlns:a="http://schemas.openxmlformats.org/drawingml/2006/main" lIns="25400" tIns="25400" rIns="25400" bIns="25400">
-            <a:normAutofit fontScale="88223" lnSpcReduction="0"/>
-          </a:bodyPr>
-          <a:lstStyle xmlns:a="http://schemas.openxmlformats.org/drawingml/2006/main">
-            <a:lvl1pPr defTabSz="896111">
-              <a:lnSpc>
-                <a:spcPct val="140000"/>
-              </a:lnSpc>
-              <a:buNone/>
-              <a:defRPr sz="980">
-                <a:solidFill>
-                  <a:srgbClr val="666666"/>
-                </a:solidFill>
-                <a:latin typeface="Chivo"/>
-                <a:ea typeface="Chivo"/>
-                <a:cs typeface="Chivo"/>
-              </a:defRPr>
-            </a:lvl1pPr>
-          </a:lstStyle>
-          <a:p xmlns:a="http://schemas.openxmlformats.org/drawingml/2006/main">
-            <a:pPr>
-              <a:buNone/>
-            </a:pPr>
-            <a:r>
-              <a:t>Workers privados validan y transforman particiones; Curated desacopla el reproceso de la base analítica.</a:t>
-            </a:r>
-          </a:p>
-        </p:txBody>
-      </p:sp>
-      <p:sp>
-        <p:nvSpPr>
-          <p:cNvPr id="277" name="Shape 38">
-            <a:extLst xmlns:a="http://schemas.openxmlformats.org/drawingml/2006/main">
-              <a:ext uri="{FF2B5EF4-FFF2-40B4-BE49-F238E27FC236}">
-                <a16:creationId xmlns:a16="http://schemas.microsoft.com/office/drawing/2014/main" id="{198EF34B-3D55-457B-9911-469D0E95093D}"/>
-              </a:ext>
-            </a:extLst>
-          </p:cNvPr>
-          <p:cNvSpPr>
-            <a:spLocks xmlns:a="http://schemas.openxmlformats.org/drawingml/2006/main" noGrp="1"/>
-          </p:cNvSpPr>
-          <p:nvPr/>
-        </p:nvSpPr>
-        <p:spPr>
-          <a:xfrm xmlns:a="http://schemas.openxmlformats.org/drawingml/2006/main">
-            <a:off x="1057275" y="5411242"/>
-            <a:ext cx="1193900" cy="215951"/>
-          </a:xfrm>
-          <a:prstGeom xmlns:a="http://schemas.openxmlformats.org/drawingml/2006/main" prst="roundRect">
-            <a:avLst>
-              <a:gd name="adj" fmla="val 50000"/>
-            </a:avLst>
-          </a:prstGeom>
-          <a:solidFill xmlns:a="http://schemas.openxmlformats.org/drawingml/2006/main">
-            <a:srgbClr val="F5F5F5"/>
-          </a:solidFill>
-          <a:ln xmlns:a="http://schemas.openxmlformats.org/drawingml/2006/main">
-            <a:solidFill>
-              <a:srgbClr val="E6E6E6"/>
-            </a:solidFill>
-          </a:ln>
-        </p:spPr>
-        <p:txBody>
-          <a:bodyPr xmlns:a="http://schemas.openxmlformats.org/drawingml/2006/main" lIns="45719" rIns="45719"/>
-          <a:lstStyle xmlns:a="http://schemas.openxmlformats.org/drawingml/2006/main"/>
-          <a:p xmlns:a="http://schemas.openxmlformats.org/drawingml/2006/main">
-            <a:pPr>
-              <a:buNone/>
-            </a:pPr>
-          </a:p>
-        </p:txBody>
-      </p:sp>
-      <p:sp>
-        <p:nvSpPr>
-          <p:cNvPr id="278" name="Text 39">
-            <a:extLst xmlns:a="http://schemas.openxmlformats.org/drawingml/2006/main">
-              <a:ext uri="{FF2B5EF4-FFF2-40B4-BE49-F238E27FC236}">
-                <a16:creationId xmlns:a16="http://schemas.microsoft.com/office/drawing/2014/main" id="{E440ABF7-35C2-4574-A6E2-BC1F979FB035}"/>
-              </a:ext>
-            </a:extLst>
-          </p:cNvPr>
-          <p:cNvSpPr>
-            <a:spLocks xmlns:a="http://schemas.openxmlformats.org/drawingml/2006/main" noGrp="1"/>
-          </p:cNvSpPr>
-          <p:nvPr/>
-        </p:nvSpPr>
-        <p:spPr>
-          <a:xfrm xmlns:a="http://schemas.openxmlformats.org/drawingml/2006/main">
-            <a:off x="1143000" y="5439817"/>
-            <a:ext cx="1098650" cy="196901"/>
-          </a:xfrm>
-          <a:prstGeom xmlns:a="http://schemas.openxmlformats.org/drawingml/2006/main" prst="rect">
-            <a:avLst/>
-          </a:prstGeom>
-          <a:ln xmlns:a="http://schemas.openxmlformats.org/drawingml/2006/main" w="12700"/>
-        </p:spPr>
-        <p:txBody>
-          <a:bodyPr xmlns:a="http://schemas.openxmlformats.org/drawingml/2006/main" lIns="25400" tIns="25400" rIns="25400" bIns="25400">
-            <a:normAutofit fontScale="82644" lnSpcReduction="0"/>
-          </a:bodyPr>
-          <a:lstStyle xmlns:a="http://schemas.openxmlformats.org/drawingml/2006/main">
-            <a:lvl1pPr>
-              <a:lnSpc>
-                <a:spcPct val="145000"/>
-              </a:lnSpc>
-              <a:buNone/>
-              <a:defRPr sz="800">
-                <a:solidFill>
-                  <a:srgbClr val="666666"/>
-                </a:solidFill>
-                <a:latin typeface="ITBA Mono"/>
-                <a:ea typeface="ITBA Mono"/>
-                <a:cs typeface="ITBA Mono"/>
-              </a:defRPr>
-            </a:lvl1pPr>
-          </a:lstStyle>
-          <a:p xmlns:a="http://schemas.openxmlformats.org/drawingml/2006/main">
-            <a:pPr>
-              <a:buNone/>
-            </a:pPr>
-            <a:r>
-              <a:t>EC2</a:t>
-            </a:r>
-          </a:p>
-        </p:txBody>
-      </p:sp>
-      <p:sp>
-        <p:nvSpPr>
-          <p:cNvPr id="279" name="Shape 40">
-            <a:extLst xmlns:a="http://schemas.openxmlformats.org/drawingml/2006/main">
-              <a:ext uri="{FF2B5EF4-FFF2-40B4-BE49-F238E27FC236}">
-                <a16:creationId xmlns:a16="http://schemas.microsoft.com/office/drawing/2014/main" id="{F6E3E72F-A88F-42A5-8ADA-BC9CB992F423}"/>
-              </a:ext>
-            </a:extLst>
-          </p:cNvPr>
-          <p:cNvSpPr>
-            <a:spLocks xmlns:a="http://schemas.openxmlformats.org/drawingml/2006/main" noGrp="1"/>
-          </p:cNvSpPr>
-          <p:nvPr/>
-        </p:nvSpPr>
-        <p:spPr>
-          <a:xfrm xmlns:a="http://schemas.openxmlformats.org/drawingml/2006/main">
-            <a:off x="2308324" y="5411242"/>
-            <a:ext cx="682676" cy="215951"/>
-          </a:xfrm>
-          <a:prstGeom xmlns:a="http://schemas.openxmlformats.org/drawingml/2006/main" prst="roundRect">
-            <a:avLst>
-              <a:gd name="adj" fmla="val 50000"/>
-            </a:avLst>
-          </a:prstGeom>
-          <a:solidFill xmlns:a="http://schemas.openxmlformats.org/drawingml/2006/main">
-            <a:srgbClr val="F5F5F5"/>
-          </a:solidFill>
-          <a:ln xmlns:a="http://schemas.openxmlformats.org/drawingml/2006/main">
-            <a:solidFill>
-              <a:srgbClr val="E6E6E6"/>
-            </a:solidFill>
-          </a:ln>
-        </p:spPr>
-        <p:txBody>
-          <a:bodyPr xmlns:a="http://schemas.openxmlformats.org/drawingml/2006/main" lIns="45719" rIns="45719"/>
-          <a:lstStyle xmlns:a="http://schemas.openxmlformats.org/drawingml/2006/main"/>
-          <a:p xmlns:a="http://schemas.openxmlformats.org/drawingml/2006/main">
-            <a:pPr>
-              <a:buNone/>
-            </a:pPr>
-          </a:p>
-        </p:txBody>
-      </p:sp>
-      <p:sp>
-        <p:nvSpPr>
-          <p:cNvPr id="280" name="Text 41">
-            <a:extLst xmlns:a="http://schemas.openxmlformats.org/drawingml/2006/main">
-              <a:ext uri="{FF2B5EF4-FFF2-40B4-BE49-F238E27FC236}">
-                <a16:creationId xmlns:a16="http://schemas.microsoft.com/office/drawing/2014/main" id="{2CA94F20-F58F-4F22-A743-04227A6D29FF}"/>
-              </a:ext>
-            </a:extLst>
-          </p:cNvPr>
-          <p:cNvSpPr>
-            <a:spLocks xmlns:a="http://schemas.openxmlformats.org/drawingml/2006/main" noGrp="1"/>
-          </p:cNvSpPr>
-          <p:nvPr/>
-        </p:nvSpPr>
-        <p:spPr>
-          <a:xfrm xmlns:a="http://schemas.openxmlformats.org/drawingml/2006/main">
-            <a:off x="2394049" y="5439817"/>
-            <a:ext cx="587426" cy="196901"/>
-          </a:xfrm>
-          <a:prstGeom xmlns:a="http://schemas.openxmlformats.org/drawingml/2006/main" prst="rect">
-            <a:avLst/>
-          </a:prstGeom>
-          <a:ln xmlns:a="http://schemas.openxmlformats.org/drawingml/2006/main" w="12700"/>
-        </p:spPr>
-        <p:txBody>
-          <a:bodyPr xmlns:a="http://schemas.openxmlformats.org/drawingml/2006/main" lIns="25400" tIns="25400" rIns="25400" bIns="25400">
-            <a:normAutofit fontScale="82644" lnSpcReduction="0"/>
-          </a:bodyPr>
-          <a:lstStyle xmlns:a="http://schemas.openxmlformats.org/drawingml/2006/main">
-            <a:lvl1pPr>
-              <a:lnSpc>
-                <a:spcPct val="145000"/>
-              </a:lnSpc>
-              <a:buNone/>
-              <a:defRPr sz="800">
-                <a:solidFill>
-                  <a:srgbClr val="666666"/>
-                </a:solidFill>
-                <a:latin typeface="ITBA Mono"/>
-                <a:ea typeface="ITBA Mono"/>
-                <a:cs typeface="ITBA Mono"/>
-              </a:defRPr>
-            </a:lvl1pPr>
-          </a:lstStyle>
-          <a:p xmlns:a="http://schemas.openxmlformats.org/drawingml/2006/main">
-            <a:pPr>
-              <a:buNone/>
-            </a:pPr>
-            <a:r>
-              <a:t>Auto Scaling</a:t>
-            </a:r>
-          </a:p>
-        </p:txBody>
-      </p:sp>
-      <p:sp>
-        <p:nvSpPr>
-          <p:cNvPr id="281" name="Shape 42">
-            <a:extLst xmlns:a="http://schemas.openxmlformats.org/drawingml/2006/main">
-              <a:ext uri="{FF2B5EF4-FFF2-40B4-BE49-F238E27FC236}">
-                <a16:creationId xmlns:a16="http://schemas.microsoft.com/office/drawing/2014/main" id="{E7097838-B3F5-4E5D-A50D-7689CF5F30F8}"/>
-              </a:ext>
-            </a:extLst>
-          </p:cNvPr>
-          <p:cNvSpPr>
-            <a:spLocks xmlns:a="http://schemas.openxmlformats.org/drawingml/2006/main" noGrp="1"/>
-          </p:cNvSpPr>
-          <p:nvPr/>
-        </p:nvSpPr>
-        <p:spPr>
-          <a:xfrm xmlns:a="http://schemas.openxmlformats.org/drawingml/2006/main">
-            <a:off x="3048149" y="5411242"/>
-            <a:ext cx="390526" cy="215951"/>
-          </a:xfrm>
-          <a:prstGeom xmlns:a="http://schemas.openxmlformats.org/drawingml/2006/main" prst="roundRect">
-            <a:avLst>
-              <a:gd name="adj" fmla="val 50000"/>
-            </a:avLst>
-          </a:prstGeom>
-          <a:solidFill xmlns:a="http://schemas.openxmlformats.org/drawingml/2006/main">
-            <a:srgbClr val="F5F5F5"/>
-          </a:solidFill>
-          <a:ln xmlns:a="http://schemas.openxmlformats.org/drawingml/2006/main">
-            <a:solidFill>
-              <a:srgbClr val="E6E6E6"/>
-            </a:solidFill>
-          </a:ln>
-        </p:spPr>
-        <p:txBody>
-          <a:bodyPr xmlns:a="http://schemas.openxmlformats.org/drawingml/2006/main" lIns="45719" rIns="45719"/>
-          <a:lstStyle xmlns:a="http://schemas.openxmlformats.org/drawingml/2006/main"/>
-          <a:p xmlns:a="http://schemas.openxmlformats.org/drawingml/2006/main">
-            <a:pPr>
-              <a:buNone/>
-            </a:pPr>
-          </a:p>
-        </p:txBody>
-      </p:sp>
-      <p:sp>
-        <p:nvSpPr>
-          <p:cNvPr id="282" name="Text 43">
-            <a:extLst xmlns:a="http://schemas.openxmlformats.org/drawingml/2006/main">
-              <a:ext uri="{FF2B5EF4-FFF2-40B4-BE49-F238E27FC236}">
-                <a16:creationId xmlns:a16="http://schemas.microsoft.com/office/drawing/2014/main" id="{FE5ECBAF-0034-4F02-9ED3-E169CD6A8F21}"/>
-              </a:ext>
-            </a:extLst>
-          </p:cNvPr>
-          <p:cNvSpPr>
-            <a:spLocks xmlns:a="http://schemas.openxmlformats.org/drawingml/2006/main" noGrp="1"/>
-          </p:cNvSpPr>
-          <p:nvPr/>
-        </p:nvSpPr>
-        <p:spPr>
-          <a:xfrm xmlns:a="http://schemas.openxmlformats.org/drawingml/2006/main">
-            <a:off x="3133874" y="5439817"/>
-            <a:ext cx="295276" cy="196901"/>
-          </a:xfrm>
-          <a:prstGeom xmlns:a="http://schemas.openxmlformats.org/drawingml/2006/main" prst="rect">
-            <a:avLst/>
-          </a:prstGeom>
-          <a:ln xmlns:a="http://schemas.openxmlformats.org/drawingml/2006/main" w="12700"/>
-        </p:spPr>
-        <p:txBody>
-          <a:bodyPr xmlns:a="http://schemas.openxmlformats.org/drawingml/2006/main" lIns="25400" tIns="25400" rIns="25400" bIns="25400">
-            <a:normAutofit fontScale="82644" lnSpcReduction="0"/>
-          </a:bodyPr>
-          <a:lstStyle xmlns:a="http://schemas.openxmlformats.org/drawingml/2006/main">
-            <a:lvl1pPr>
-              <a:lnSpc>
-                <a:spcPct val="145000"/>
-              </a:lnSpc>
-              <a:buNone/>
-              <a:defRPr sz="800">
-                <a:solidFill>
-                  <a:srgbClr val="666666"/>
-                </a:solidFill>
-                <a:latin typeface="ITBA Mono"/>
-                <a:ea typeface="ITBA Mono"/>
-                <a:cs typeface="ITBA Mono"/>
-              </a:defRPr>
-            </a:lvl1pPr>
-          </a:lstStyle>
-          <a:p xmlns:a="http://schemas.openxmlformats.org/drawingml/2006/main">
-            <a:pPr>
-              <a:buNone/>
-            </a:pPr>
-            <a:r>
-              <a:t>S3</a:t>
-            </a:r>
-          </a:p>
-        </p:txBody>
-      </p:sp>
-      <p:sp>
-        <p:nvSpPr>
-          <p:cNvPr id="283" name="Shape 44">
-            <a:extLst xmlns:a="http://schemas.openxmlformats.org/drawingml/2006/main">
-              <a:ext uri="{FF2B5EF4-FFF2-40B4-BE49-F238E27FC236}">
-                <a16:creationId xmlns:a16="http://schemas.microsoft.com/office/drawing/2014/main" id="{01070DB3-7FA8-4796-AA76-D44ECA1E2163}"/>
-              </a:ext>
-            </a:extLst>
-          </p:cNvPr>
-          <p:cNvSpPr>
-            <a:spLocks xmlns:a="http://schemas.openxmlformats.org/drawingml/2006/main" noGrp="1"/>
-          </p:cNvSpPr>
-          <p:nvPr/>
-        </p:nvSpPr>
-        <p:spPr>
-          <a:xfrm xmlns:a="http://schemas.openxmlformats.org/drawingml/2006/main">
-            <a:off x="3495823" y="5411242"/>
-            <a:ext cx="390526" cy="215951"/>
-          </a:xfrm>
-          <a:prstGeom xmlns:a="http://schemas.openxmlformats.org/drawingml/2006/main" prst="roundRect">
-            <a:avLst>
-              <a:gd name="adj" fmla="val 50000"/>
-            </a:avLst>
-          </a:prstGeom>
-          <a:solidFill xmlns:a="http://schemas.openxmlformats.org/drawingml/2006/main">
-            <a:srgbClr val="F5F5F5"/>
-          </a:solidFill>
-          <a:ln xmlns:a="http://schemas.openxmlformats.org/drawingml/2006/main">
-            <a:solidFill>
-              <a:srgbClr val="E6E6E6"/>
-            </a:solidFill>
-          </a:ln>
-        </p:spPr>
-        <p:txBody>
-          <a:bodyPr xmlns:a="http://schemas.openxmlformats.org/drawingml/2006/main" lIns="45719" rIns="45719"/>
-          <a:lstStyle xmlns:a="http://schemas.openxmlformats.org/drawingml/2006/main"/>
-          <a:p xmlns:a="http://schemas.openxmlformats.org/drawingml/2006/main">
-            <a:pPr>
-              <a:buNone/>
-            </a:pPr>
-          </a:p>
-        </p:txBody>
-      </p:sp>
-      <p:sp>
-        <p:nvSpPr>
-          <p:cNvPr id="284" name="Text 45">
-            <a:extLst xmlns:a="http://schemas.openxmlformats.org/drawingml/2006/main">
-              <a:ext uri="{FF2B5EF4-FFF2-40B4-BE49-F238E27FC236}">
-                <a16:creationId xmlns:a16="http://schemas.microsoft.com/office/drawing/2014/main" id="{DCE1EBFD-79EE-4B08-81D9-1DBE870C0827}"/>
-              </a:ext>
-            </a:extLst>
-          </p:cNvPr>
-          <p:cNvSpPr>
-            <a:spLocks xmlns:a="http://schemas.openxmlformats.org/drawingml/2006/main" noGrp="1"/>
-          </p:cNvSpPr>
-          <p:nvPr/>
-        </p:nvSpPr>
-        <p:spPr>
-          <a:xfrm xmlns:a="http://schemas.openxmlformats.org/drawingml/2006/main">
-            <a:off x="3581548" y="5439817"/>
-            <a:ext cx="295276" cy="196901"/>
-          </a:xfrm>
-          <a:prstGeom xmlns:a="http://schemas.openxmlformats.org/drawingml/2006/main" prst="rect">
-            <a:avLst/>
-          </a:prstGeom>
-          <a:ln xmlns:a="http://schemas.openxmlformats.org/drawingml/2006/main" w="12700"/>
-        </p:spPr>
-        <p:txBody>
-          <a:bodyPr xmlns:a="http://schemas.openxmlformats.org/drawingml/2006/main" lIns="25400" tIns="25400" rIns="25400" bIns="25400">
-            <a:normAutofit fontScale="82644" lnSpcReduction="0"/>
-          </a:bodyPr>
-          <a:lstStyle xmlns:a="http://schemas.openxmlformats.org/drawingml/2006/main">
-            <a:lvl1pPr>
-              <a:lnSpc>
-                <a:spcPct val="145000"/>
-              </a:lnSpc>
-              <a:buNone/>
-              <a:defRPr sz="800">
-                <a:solidFill>
-                  <a:srgbClr val="666666"/>
-                </a:solidFill>
-                <a:latin typeface="ITBA Mono"/>
-                <a:ea typeface="ITBA Mono"/>
-                <a:cs typeface="ITBA Mono"/>
-              </a:defRPr>
-            </a:lvl1pPr>
-          </a:lstStyle>
-          <a:p xmlns:a="http://schemas.openxmlformats.org/drawingml/2006/main">
-            <a:pPr>
-              <a:buNone/>
-            </a:pPr>
-            <a:r>
-              <a:t>KMS</a:t>
-            </a:r>
-          </a:p>
-        </p:txBody>
-      </p:sp>
-      <p:sp>
-        <p:nvSpPr>
-          <p:cNvPr id="285" name="Shape 46">
-            <a:extLst xmlns:a="http://schemas.openxmlformats.org/drawingml/2006/main">
-              <a:ext uri="{FF2B5EF4-FFF2-40B4-BE49-F238E27FC236}">
-                <a16:creationId xmlns:a16="http://schemas.microsoft.com/office/drawing/2014/main" id="{4CA23EC8-9BD6-47B6-9AFB-8F245783AEA8}"/>
-              </a:ext>
-            </a:extLst>
-          </p:cNvPr>
-          <p:cNvSpPr>
-            <a:spLocks xmlns:a="http://schemas.openxmlformats.org/drawingml/2006/main" noGrp="1"/>
-          </p:cNvSpPr>
-          <p:nvPr/>
-        </p:nvSpPr>
-        <p:spPr>
-          <a:xfrm xmlns:a="http://schemas.openxmlformats.org/drawingml/2006/main">
-            <a:off x="6315075" y="4113757"/>
-            <a:ext cx="5305425" cy="1694409"/>
-          </a:xfrm>
-          <a:prstGeom xmlns:a="http://schemas.openxmlformats.org/drawingml/2006/main" prst="roundRect">
-            <a:avLst>
-              <a:gd name="adj" fmla="val 6746"/>
-            </a:avLst>
-          </a:prstGeom>
-          <a:solidFill xmlns:a="http://schemas.openxmlformats.org/drawingml/2006/main">
-            <a:srgbClr val="FFFFFF"/>
-          </a:solidFill>
-          <a:ln xmlns:a="http://schemas.openxmlformats.org/drawingml/2006/main">
-            <a:solidFill>
-              <a:srgbClr val="D8D8D8"/>
-            </a:solidFill>
-          </a:ln>
-        </p:spPr>
-        <p:txBody>
-          <a:bodyPr xmlns:a="http://schemas.openxmlformats.org/drawingml/2006/main" lIns="45719" rIns="45719"/>
-          <a:lstStyle xmlns:a="http://schemas.openxmlformats.org/drawingml/2006/main"/>
-          <a:p xmlns:a="http://schemas.openxmlformats.org/drawingml/2006/main">
-            <a:pPr>
-              <a:buNone/>
-            </a:pPr>
-          </a:p>
-        </p:txBody>
-      </p:sp>
-      <p:sp>
-        <p:nvSpPr>
-          <p:cNvPr id="286" name="Shape 47">
-            <a:extLst xmlns:a="http://schemas.openxmlformats.org/drawingml/2006/main">
-              <a:ext uri="{FF2B5EF4-FFF2-40B4-BE49-F238E27FC236}">
-                <a16:creationId xmlns:a16="http://schemas.microsoft.com/office/drawing/2014/main" id="{03A2DD9D-E5D5-488F-8D3D-48654A6498B0}"/>
-              </a:ext>
-            </a:extLst>
-          </p:cNvPr>
-          <p:cNvSpPr>
-            <a:spLocks xmlns:a="http://schemas.openxmlformats.org/drawingml/2006/main" noGrp="1"/>
-          </p:cNvSpPr>
-          <p:nvPr/>
-        </p:nvSpPr>
-        <p:spPr>
-          <a:xfrm xmlns:a="http://schemas.openxmlformats.org/drawingml/2006/main">
-            <a:off x="6534150" y="4332832"/>
-            <a:ext cx="1523108" cy="208956"/>
-          </a:xfrm>
-          <a:prstGeom xmlns:a="http://schemas.openxmlformats.org/drawingml/2006/main" prst="roundRect">
-            <a:avLst>
-              <a:gd name="adj" fmla="val 27350"/>
-            </a:avLst>
-          </a:prstGeom>
-          <a:solidFill xmlns:a="http://schemas.openxmlformats.org/drawingml/2006/main">
-            <a:srgbClr val="2458FF">
-              <a:alpha val="10000"/>
-            </a:srgbClr>
-          </a:solidFill>
-          <a:ln xmlns:a="http://schemas.openxmlformats.org/drawingml/2006/main" w="12700"/>
-        </p:spPr>
-        <p:txBody>
-          <a:bodyPr xmlns:a="http://schemas.openxmlformats.org/drawingml/2006/main" lIns="45719" rIns="45719"/>
-          <a:lstStyle xmlns:a="http://schemas.openxmlformats.org/drawingml/2006/main"/>
-          <a:p xmlns:a="http://schemas.openxmlformats.org/drawingml/2006/main">
-            <a:pPr>
-              <a:buNone/>
-            </a:pPr>
-          </a:p>
-        </p:txBody>
-      </p:sp>
-      <p:sp>
-        <p:nvSpPr>
-          <p:cNvPr id="287" name="Text 48">
-            <a:extLst xmlns:a="http://schemas.openxmlformats.org/drawingml/2006/main">
-              <a:ext uri="{FF2B5EF4-FFF2-40B4-BE49-F238E27FC236}">
-                <a16:creationId xmlns:a16="http://schemas.microsoft.com/office/drawing/2014/main" id="{176E34E2-FFEA-4669-84E7-377FEC336C77}"/>
-              </a:ext>
-            </a:extLst>
-          </p:cNvPr>
-          <p:cNvSpPr>
-            <a:spLocks xmlns:a="http://schemas.openxmlformats.org/drawingml/2006/main" noGrp="1"/>
-          </p:cNvSpPr>
-          <p:nvPr/>
-        </p:nvSpPr>
-        <p:spPr>
-          <a:xfrm xmlns:a="http://schemas.openxmlformats.org/drawingml/2006/main">
-            <a:off x="6619875" y="4361407"/>
-            <a:ext cx="1427858" cy="189906"/>
-          </a:xfrm>
-          <a:prstGeom xmlns:a="http://schemas.openxmlformats.org/drawingml/2006/main" prst="rect">
-            <a:avLst/>
-          </a:prstGeom>
-          <a:ln xmlns:a="http://schemas.openxmlformats.org/drawingml/2006/main" w="12700"/>
-        </p:spPr>
-        <p:txBody>
-          <a:bodyPr xmlns:a="http://schemas.openxmlformats.org/drawingml/2006/main" lIns="25400" tIns="25400" rIns="25400" bIns="25400">
-            <a:normAutofit fontScale="78687" lnSpcReduction="0"/>
-          </a:bodyPr>
-          <a:lstStyle xmlns:a="http://schemas.openxmlformats.org/drawingml/2006/main">
-            <a:lvl1pPr>
-              <a:lnSpc>
-                <a:spcPct val="145000"/>
-              </a:lnSpc>
-              <a:buNone/>
-              <a:defRPr sz="800">
-                <a:solidFill>
-                  <a:srgbClr val="2458FF"/>
-                </a:solidFill>
-                <a:latin typeface="ITBA Mono"/>
-                <a:ea typeface="ITBA Mono"/>
-                <a:cs typeface="ITBA Mono"/>
-              </a:defRPr>
-            </a:lvl1pPr>
-          </a:lstStyle>
-          <a:p xmlns:a="http://schemas.openxmlformats.org/drawingml/2006/main">
-            <a:pPr>
-              <a:buNone/>
-            </a:pPr>
-            <a:r>
-              <a:t>CONSUMO</a:t>
-            </a:r>
-          </a:p>
-        </p:txBody>
-      </p:sp>
-      <p:sp>
-        <p:nvSpPr>
-          <p:cNvPr id="288" name="Text 49">
-            <a:extLst xmlns:a="http://schemas.openxmlformats.org/drawingml/2006/main">
-              <a:ext uri="{FF2B5EF4-FFF2-40B4-BE49-F238E27FC236}">
-                <a16:creationId xmlns:a16="http://schemas.microsoft.com/office/drawing/2014/main" id="{870FC6BF-2432-4028-B72D-0D2217C51F1E}"/>
-              </a:ext>
-            </a:extLst>
-          </p:cNvPr>
-          <p:cNvSpPr>
-            <a:spLocks xmlns:a="http://schemas.openxmlformats.org/drawingml/2006/main" noGrp="1"/>
-          </p:cNvSpPr>
-          <p:nvPr/>
-        </p:nvSpPr>
-        <p:spPr>
-          <a:xfrm xmlns:a="http://schemas.openxmlformats.org/drawingml/2006/main">
-            <a:off x="6534150" y="4637037"/>
-            <a:ext cx="5354004" cy="286644"/>
-          </a:xfrm>
-          <a:prstGeom xmlns:a="http://schemas.openxmlformats.org/drawingml/2006/main" prst="rect">
-            <a:avLst/>
-          </a:prstGeom>
-          <a:ln xmlns:a="http://schemas.openxmlformats.org/drawingml/2006/main" w="12700"/>
-        </p:spPr>
-        <p:txBody>
-          <a:bodyPr xmlns:a="http://schemas.openxmlformats.org/drawingml/2006/main" lIns="25400" tIns="25400" rIns="25400" bIns="25400">
-            <a:normAutofit fontScale="82097" lnSpcReduction="0"/>
-          </a:bodyPr>
-          <a:lstStyle xmlns:a="http://schemas.openxmlformats.org/drawingml/2006/main">
-            <a:lvl1pPr>
-              <a:lnSpc>
-                <a:spcPct val="145000"/>
-              </a:lnSpc>
-              <a:buNone/>
-              <a:defRPr sz="1300" b="1">
-                <a:solidFill>
-                  <a:srgbClr val="111111"/>
-                </a:solidFill>
-                <a:latin typeface="Chivo"/>
-                <a:ea typeface="Chivo"/>
-                <a:cs typeface="Chivo"/>
-              </a:defRPr>
-            </a:lvl1pPr>
-          </a:lstStyle>
-          <a:p xmlns:a="http://schemas.openxmlformats.org/drawingml/2006/main">
-            <a:pPr>
-              <a:buNone/>
-            </a:pPr>
-            <a:r>
-              <a:t>RDS + BI</a:t>
-            </a:r>
-          </a:p>
-        </p:txBody>
-      </p:sp>
-      <p:sp>
-        <p:nvSpPr>
-          <p:cNvPr id="289" name="Text 50">
-            <a:extLst xmlns:a="http://schemas.openxmlformats.org/drawingml/2006/main">
-              <a:ext uri="{FF2B5EF4-FFF2-40B4-BE49-F238E27FC236}">
-                <a16:creationId xmlns:a16="http://schemas.microsoft.com/office/drawing/2014/main" id="{B1DCF016-1016-459A-AE50-5AF49E78B6DC}"/>
-              </a:ext>
-            </a:extLst>
-          </p:cNvPr>
-          <p:cNvSpPr>
-            <a:spLocks xmlns:a="http://schemas.openxmlformats.org/drawingml/2006/main" noGrp="1"/>
-          </p:cNvSpPr>
-          <p:nvPr/>
-        </p:nvSpPr>
-        <p:spPr>
-          <a:xfrm xmlns:a="http://schemas.openxmlformats.org/drawingml/2006/main">
-            <a:off x="6534150" y="4942730"/>
-            <a:ext cx="5013293" cy="419736"/>
-          </a:xfrm>
-          <a:prstGeom xmlns:a="http://schemas.openxmlformats.org/drawingml/2006/main" prst="rect">
-            <a:avLst/>
-          </a:prstGeom>
-          <a:ln xmlns:a="http://schemas.openxmlformats.org/drawingml/2006/main" w="12700"/>
-        </p:spPr>
-        <p:txBody>
-          <a:bodyPr xmlns:a="http://schemas.openxmlformats.org/drawingml/2006/main" lIns="25400" tIns="25400" rIns="25400" bIns="25400">
-            <a:normAutofit fontScale="88223" lnSpcReduction="0"/>
-          </a:bodyPr>
-          <a:lstStyle xmlns:a="http://schemas.openxmlformats.org/drawingml/2006/main">
-            <a:lvl1pPr defTabSz="896111">
-              <a:lnSpc>
-                <a:spcPct val="140000"/>
-              </a:lnSpc>
-              <a:buNone/>
-              <a:defRPr sz="980">
-                <a:solidFill>
-                  <a:srgbClr val="666666"/>
-                </a:solidFill>
-                <a:latin typeface="Chivo"/>
-                <a:ea typeface="Chivo"/>
-                <a:cs typeface="Chivo"/>
-              </a:defRPr>
-            </a:lvl1pPr>
-          </a:lstStyle>
-          <a:p xmlns:a="http://schemas.openxmlformats.org/drawingml/2006/main">
-            <a:pPr>
-              <a:buNone/>
-            </a:pPr>
-            <a:r>
-              <a:t>PostgreSQL permanece privado; usuarios entran por VPN y Power BI Service usa un gateway con TLS.</a:t>
-            </a:r>
-          </a:p>
-        </p:txBody>
-      </p:sp>
-      <p:sp>
-        <p:nvSpPr>
-          <p:cNvPr id="290" name="Shape 51">
-            <a:extLst xmlns:a="http://schemas.openxmlformats.org/drawingml/2006/main">
-              <a:ext uri="{FF2B5EF4-FFF2-40B4-BE49-F238E27FC236}">
-                <a16:creationId xmlns:a16="http://schemas.microsoft.com/office/drawing/2014/main" id="{9A83FF21-907C-4EB5-AA9C-6594E75BA7D7}"/>
-              </a:ext>
-            </a:extLst>
-          </p:cNvPr>
-          <p:cNvSpPr>
-            <a:spLocks xmlns:a="http://schemas.openxmlformats.org/drawingml/2006/main" noGrp="1"/>
-          </p:cNvSpPr>
-          <p:nvPr/>
-        </p:nvSpPr>
-        <p:spPr>
-          <a:xfrm xmlns:a="http://schemas.openxmlformats.org/drawingml/2006/main">
-            <a:off x="6534150" y="5411242"/>
-            <a:ext cx="1485900" cy="215951"/>
-          </a:xfrm>
-          <a:prstGeom xmlns:a="http://schemas.openxmlformats.org/drawingml/2006/main" prst="roundRect">
-            <a:avLst>
-              <a:gd name="adj" fmla="val 50000"/>
-            </a:avLst>
-          </a:prstGeom>
-          <a:solidFill xmlns:a="http://schemas.openxmlformats.org/drawingml/2006/main">
-            <a:srgbClr val="F5F5F5"/>
-          </a:solidFill>
-          <a:ln xmlns:a="http://schemas.openxmlformats.org/drawingml/2006/main">
-            <a:solidFill>
-              <a:srgbClr val="E6E6E6"/>
-            </a:solidFill>
-          </a:ln>
-        </p:spPr>
-        <p:txBody>
-          <a:bodyPr xmlns:a="http://schemas.openxmlformats.org/drawingml/2006/main" lIns="45719" rIns="45719"/>
-          <a:lstStyle xmlns:a="http://schemas.openxmlformats.org/drawingml/2006/main"/>
-          <a:p xmlns:a="http://schemas.openxmlformats.org/drawingml/2006/main">
-            <a:pPr>
-              <a:buNone/>
-            </a:pPr>
-          </a:p>
-        </p:txBody>
-      </p:sp>
-      <p:sp>
-        <p:nvSpPr>
-          <p:cNvPr id="291" name="Text 52">
-            <a:extLst xmlns:a="http://schemas.openxmlformats.org/drawingml/2006/main">
-              <a:ext uri="{FF2B5EF4-FFF2-40B4-BE49-F238E27FC236}">
-                <a16:creationId xmlns:a16="http://schemas.microsoft.com/office/drawing/2014/main" id="{DB2BA7AE-2F93-4A7F-B7AF-E827B44EAA16}"/>
-              </a:ext>
-            </a:extLst>
-          </p:cNvPr>
-          <p:cNvSpPr>
-            <a:spLocks xmlns:a="http://schemas.openxmlformats.org/drawingml/2006/main" noGrp="1"/>
-          </p:cNvSpPr>
-          <p:nvPr/>
-        </p:nvSpPr>
-        <p:spPr>
-          <a:xfrm xmlns:a="http://schemas.openxmlformats.org/drawingml/2006/main">
-            <a:off x="6619875" y="5439817"/>
-            <a:ext cx="1390650" cy="196901"/>
-          </a:xfrm>
-          <a:prstGeom xmlns:a="http://schemas.openxmlformats.org/drawingml/2006/main" prst="rect">
-            <a:avLst/>
-          </a:prstGeom>
-          <a:ln xmlns:a="http://schemas.openxmlformats.org/drawingml/2006/main" w="12700"/>
-        </p:spPr>
-        <p:txBody>
-          <a:bodyPr xmlns:a="http://schemas.openxmlformats.org/drawingml/2006/main" lIns="25400" tIns="25400" rIns="25400" bIns="25400">
-            <a:normAutofit fontScale="82644" lnSpcReduction="0"/>
-          </a:bodyPr>
-          <a:lstStyle xmlns:a="http://schemas.openxmlformats.org/drawingml/2006/main">
-            <a:lvl1pPr>
-              <a:lnSpc>
-                <a:spcPct val="145000"/>
-              </a:lnSpc>
-              <a:buNone/>
-              <a:defRPr sz="800">
-                <a:solidFill>
-                  <a:srgbClr val="666666"/>
-                </a:solidFill>
-                <a:latin typeface="ITBA Mono"/>
-                <a:ea typeface="ITBA Mono"/>
-                <a:cs typeface="ITBA Mono"/>
-              </a:defRPr>
-            </a:lvl1pPr>
-          </a:lstStyle>
-          <a:p xmlns:a="http://schemas.openxmlformats.org/drawingml/2006/main">
-            <a:pPr>
-              <a:buNone/>
-            </a:pPr>
-            <a:r>
-              <a:t>RDS</a:t>
-            </a:r>
-          </a:p>
-        </p:txBody>
-      </p:sp>
-      <p:sp>
-        <p:nvSpPr>
-          <p:cNvPr id="292" name="Shape 53">
-            <a:extLst xmlns:a="http://schemas.openxmlformats.org/drawingml/2006/main">
-              <a:ext uri="{FF2B5EF4-FFF2-40B4-BE49-F238E27FC236}">
-                <a16:creationId xmlns:a16="http://schemas.microsoft.com/office/drawing/2014/main" id="{ED18E502-8A1D-443F-846D-4BFA23B3BC6C}"/>
-              </a:ext>
-            </a:extLst>
-          </p:cNvPr>
-          <p:cNvSpPr>
-            <a:spLocks xmlns:a="http://schemas.openxmlformats.org/drawingml/2006/main" noGrp="1"/>
-          </p:cNvSpPr>
-          <p:nvPr/>
-        </p:nvSpPr>
-        <p:spPr>
-          <a:xfrm xmlns:a="http://schemas.openxmlformats.org/drawingml/2006/main">
-            <a:off x="8077200" y="5411242"/>
-            <a:ext cx="317600" cy="215951"/>
-          </a:xfrm>
-          <a:prstGeom xmlns:a="http://schemas.openxmlformats.org/drawingml/2006/main" prst="roundRect">
-            <a:avLst>
-              <a:gd name="adj" fmla="val 50000"/>
-            </a:avLst>
-          </a:prstGeom>
-          <a:solidFill xmlns:a="http://schemas.openxmlformats.org/drawingml/2006/main">
-            <a:srgbClr val="F5F5F5"/>
-          </a:solidFill>
-          <a:ln xmlns:a="http://schemas.openxmlformats.org/drawingml/2006/main">
-            <a:solidFill>
-              <a:srgbClr val="E6E6E6"/>
-            </a:solidFill>
-          </a:ln>
-        </p:spPr>
-        <p:txBody>
-          <a:bodyPr xmlns:a="http://schemas.openxmlformats.org/drawingml/2006/main" lIns="45719" rIns="45719"/>
-          <a:lstStyle xmlns:a="http://schemas.openxmlformats.org/drawingml/2006/main"/>
-          <a:p xmlns:a="http://schemas.openxmlformats.org/drawingml/2006/main">
-            <a:pPr>
-              <a:buNone/>
-            </a:pPr>
-          </a:p>
-        </p:txBody>
-      </p:sp>
-      <p:sp>
-        <p:nvSpPr>
-          <p:cNvPr id="293" name="Text 54">
-            <a:extLst xmlns:a="http://schemas.openxmlformats.org/drawingml/2006/main">
-              <a:ext uri="{FF2B5EF4-FFF2-40B4-BE49-F238E27FC236}">
-                <a16:creationId xmlns:a16="http://schemas.microsoft.com/office/drawing/2014/main" id="{22414B24-192E-4F18-9D55-51C22D5CFB12}"/>
-              </a:ext>
-            </a:extLst>
-          </p:cNvPr>
-          <p:cNvSpPr>
-            <a:spLocks xmlns:a="http://schemas.openxmlformats.org/drawingml/2006/main" noGrp="1"/>
-          </p:cNvSpPr>
-          <p:nvPr/>
-        </p:nvSpPr>
-        <p:spPr>
-          <a:xfrm xmlns:a="http://schemas.openxmlformats.org/drawingml/2006/main">
-            <a:off x="8162925" y="5439817"/>
-            <a:ext cx="222350" cy="196901"/>
-          </a:xfrm>
-          <a:prstGeom xmlns:a="http://schemas.openxmlformats.org/drawingml/2006/main" prst="rect">
-            <a:avLst/>
-          </a:prstGeom>
-          <a:ln xmlns:a="http://schemas.openxmlformats.org/drawingml/2006/main" w="12700"/>
-        </p:spPr>
-        <p:txBody>
-          <a:bodyPr xmlns:a="http://schemas.openxmlformats.org/drawingml/2006/main" lIns="25400" tIns="25400" rIns="25400" bIns="25400">
-            <a:normAutofit fontScale="44648" lnSpcReduction="0"/>
-          </a:bodyPr>
-          <a:lstStyle xmlns:a="http://schemas.openxmlformats.org/drawingml/2006/main">
-            <a:lvl1pPr>
-              <a:lnSpc>
-                <a:spcPct val="145000"/>
-              </a:lnSpc>
-              <a:buNone/>
-              <a:defRPr sz="800">
-                <a:solidFill>
-                  <a:srgbClr val="666666"/>
-                </a:solidFill>
-                <a:latin typeface="ITBA Mono"/>
-                <a:ea typeface="ITBA Mono"/>
-                <a:cs typeface="ITBA Mono"/>
-              </a:defRPr>
-            </a:lvl1pPr>
-          </a:lstStyle>
-          <a:p xmlns:a="http://schemas.openxmlformats.org/drawingml/2006/main">
-            <a:pPr>
-              <a:buNone/>
-            </a:pPr>
-            <a:r>
-              <a:t>Multi-AZ</a:t>
-            </a:r>
-          </a:p>
-        </p:txBody>
-      </p:sp>
-      <p:sp>
-        <p:nvSpPr>
-          <p:cNvPr id="294" name="Shape 55">
-            <a:extLst xmlns:a="http://schemas.openxmlformats.org/drawingml/2006/main">
-              <a:ext uri="{FF2B5EF4-FFF2-40B4-BE49-F238E27FC236}">
-                <a16:creationId xmlns:a16="http://schemas.microsoft.com/office/drawing/2014/main" id="{CADA1321-F51B-4438-B61F-D7880E8DCD5F}"/>
-              </a:ext>
-            </a:extLst>
-          </p:cNvPr>
-          <p:cNvSpPr>
-            <a:spLocks xmlns:a="http://schemas.openxmlformats.org/drawingml/2006/main" noGrp="1"/>
-          </p:cNvSpPr>
-          <p:nvPr/>
-        </p:nvSpPr>
-        <p:spPr>
-          <a:xfrm xmlns:a="http://schemas.openxmlformats.org/drawingml/2006/main">
-            <a:off x="8451949" y="5411242"/>
-            <a:ext cx="390526" cy="215951"/>
-          </a:xfrm>
-          <a:prstGeom xmlns:a="http://schemas.openxmlformats.org/drawingml/2006/main" prst="roundRect">
-            <a:avLst>
-              <a:gd name="adj" fmla="val 50000"/>
-            </a:avLst>
-          </a:prstGeom>
-          <a:solidFill xmlns:a="http://schemas.openxmlformats.org/drawingml/2006/main">
-            <a:srgbClr val="F5F5F5"/>
-          </a:solidFill>
-          <a:ln xmlns:a="http://schemas.openxmlformats.org/drawingml/2006/main">
-            <a:solidFill>
-              <a:srgbClr val="E6E6E6"/>
-            </a:solidFill>
-          </a:ln>
-        </p:spPr>
-        <p:txBody>
-          <a:bodyPr xmlns:a="http://schemas.openxmlformats.org/drawingml/2006/main" lIns="45719" rIns="45719"/>
-          <a:lstStyle xmlns:a="http://schemas.openxmlformats.org/drawingml/2006/main"/>
-          <a:p xmlns:a="http://schemas.openxmlformats.org/drawingml/2006/main">
-            <a:pPr>
-              <a:buNone/>
-            </a:pPr>
-          </a:p>
-        </p:txBody>
-      </p:sp>
-      <p:sp>
-        <p:nvSpPr>
-          <p:cNvPr id="295" name="Text 56">
-            <a:extLst xmlns:a="http://schemas.openxmlformats.org/drawingml/2006/main">
-              <a:ext uri="{FF2B5EF4-FFF2-40B4-BE49-F238E27FC236}">
-                <a16:creationId xmlns:a16="http://schemas.microsoft.com/office/drawing/2014/main" id="{918AB26C-5A06-4AD2-B0B2-F6A04B8FA60F}"/>
-              </a:ext>
-            </a:extLst>
-          </p:cNvPr>
-          <p:cNvSpPr>
-            <a:spLocks xmlns:a="http://schemas.openxmlformats.org/drawingml/2006/main" noGrp="1"/>
-          </p:cNvSpPr>
-          <p:nvPr/>
-        </p:nvSpPr>
-        <p:spPr>
-          <a:xfrm xmlns:a="http://schemas.openxmlformats.org/drawingml/2006/main">
-            <a:off x="8537674" y="5439817"/>
-            <a:ext cx="295276" cy="196901"/>
-          </a:xfrm>
-          <a:prstGeom xmlns:a="http://schemas.openxmlformats.org/drawingml/2006/main" prst="rect">
-            <a:avLst/>
-          </a:prstGeom>
-          <a:ln xmlns:a="http://schemas.openxmlformats.org/drawingml/2006/main" w="12700"/>
-        </p:spPr>
-        <p:txBody>
-          <a:bodyPr xmlns:a="http://schemas.openxmlformats.org/drawingml/2006/main" lIns="25400" tIns="25400" rIns="25400" bIns="25400">
-            <a:normAutofit fontScale="60848" lnSpcReduction="0"/>
-          </a:bodyPr>
-          <a:lstStyle xmlns:a="http://schemas.openxmlformats.org/drawingml/2006/main">
-            <a:lvl1pPr>
-              <a:lnSpc>
-                <a:spcPct val="145000"/>
-              </a:lnSpc>
-              <a:buNone/>
-              <a:defRPr sz="800">
-                <a:solidFill>
-                  <a:srgbClr val="666666"/>
-                </a:solidFill>
-                <a:latin typeface="ITBA Mono"/>
-                <a:ea typeface="ITBA Mono"/>
-                <a:cs typeface="ITBA Mono"/>
-              </a:defRPr>
-            </a:lvl1pPr>
-          </a:lstStyle>
-          <a:p xmlns:a="http://schemas.openxmlformats.org/drawingml/2006/main">
-            <a:pPr>
-              <a:buNone/>
-            </a:pPr>
-            <a:r>
-              <a:t>Gateway</a:t>
-            </a:r>
-          </a:p>
-        </p:txBody>
-      </p:sp>
-      <p:sp>
-        <p:nvSpPr>
-          <p:cNvPr id="296" name="Shape 57">
-            <a:extLst xmlns:a="http://schemas.openxmlformats.org/drawingml/2006/main">
-              <a:ext uri="{FF2B5EF4-FFF2-40B4-BE49-F238E27FC236}">
-                <a16:creationId xmlns:a16="http://schemas.microsoft.com/office/drawing/2014/main" id="{2E7617CE-25B9-4496-846C-237260B12EDA}"/>
-              </a:ext>
-            </a:extLst>
-          </p:cNvPr>
-          <p:cNvSpPr>
-            <a:spLocks xmlns:a="http://schemas.openxmlformats.org/drawingml/2006/main" noGrp="1"/>
-          </p:cNvSpPr>
-          <p:nvPr/>
-        </p:nvSpPr>
-        <p:spPr>
-          <a:xfrm xmlns:a="http://schemas.openxmlformats.org/drawingml/2006/main">
-            <a:off x="8899624" y="5411242"/>
-            <a:ext cx="390526" cy="215951"/>
-          </a:xfrm>
-          <a:prstGeom xmlns:a="http://schemas.openxmlformats.org/drawingml/2006/main" prst="roundRect">
-            <a:avLst>
-              <a:gd name="adj" fmla="val 50000"/>
-            </a:avLst>
-          </a:prstGeom>
-          <a:solidFill xmlns:a="http://schemas.openxmlformats.org/drawingml/2006/main">
-            <a:srgbClr val="F5F5F5"/>
-          </a:solidFill>
-          <a:ln xmlns:a="http://schemas.openxmlformats.org/drawingml/2006/main">
-            <a:solidFill>
-              <a:srgbClr val="E6E6E6"/>
-            </a:solidFill>
-          </a:ln>
-        </p:spPr>
-        <p:txBody>
-          <a:bodyPr xmlns:a="http://schemas.openxmlformats.org/drawingml/2006/main" lIns="45719" rIns="45719"/>
-          <a:lstStyle xmlns:a="http://schemas.openxmlformats.org/drawingml/2006/main"/>
-          <a:p xmlns:a="http://schemas.openxmlformats.org/drawingml/2006/main">
-            <a:pPr>
-              <a:buNone/>
-            </a:pPr>
-          </a:p>
-        </p:txBody>
-      </p:sp>
-      <p:sp>
-        <p:nvSpPr>
-          <p:cNvPr id="297" name="Text 58">
-            <a:extLst xmlns:a="http://schemas.openxmlformats.org/drawingml/2006/main">
-              <a:ext uri="{FF2B5EF4-FFF2-40B4-BE49-F238E27FC236}">
-                <a16:creationId xmlns:a16="http://schemas.microsoft.com/office/drawing/2014/main" id="{C321DF67-EB91-430B-8A7B-1C3C196567BD}"/>
-              </a:ext>
-            </a:extLst>
-          </p:cNvPr>
-          <p:cNvSpPr>
-            <a:spLocks xmlns:a="http://schemas.openxmlformats.org/drawingml/2006/main" noGrp="1"/>
-          </p:cNvSpPr>
-          <p:nvPr/>
-        </p:nvSpPr>
-        <p:spPr>
-          <a:xfrm xmlns:a="http://schemas.openxmlformats.org/drawingml/2006/main">
-            <a:off x="8985349" y="5439817"/>
-            <a:ext cx="295276" cy="196901"/>
-          </a:xfrm>
-          <a:prstGeom xmlns:a="http://schemas.openxmlformats.org/drawingml/2006/main" prst="rect">
-            <a:avLst/>
-          </a:prstGeom>
-          <a:ln xmlns:a="http://schemas.openxmlformats.org/drawingml/2006/main" w="12700"/>
-        </p:spPr>
-        <p:txBody>
-          <a:bodyPr xmlns:a="http://schemas.openxmlformats.org/drawingml/2006/main" lIns="25400" tIns="25400" rIns="25400" bIns="25400">
-            <a:normAutofit fontScale="82644" lnSpcReduction="0"/>
-          </a:bodyPr>
-          <a:lstStyle xmlns:a="http://schemas.openxmlformats.org/drawingml/2006/main">
-            <a:lvl1pPr>
-              <a:lnSpc>
-                <a:spcPct val="145000"/>
-              </a:lnSpc>
-              <a:buNone/>
-              <a:defRPr sz="800">
-                <a:solidFill>
-                  <a:srgbClr val="666666"/>
-                </a:solidFill>
-                <a:latin typeface="ITBA Mono"/>
-                <a:ea typeface="ITBA Mono"/>
-                <a:cs typeface="ITBA Mono"/>
-              </a:defRPr>
-            </a:lvl1pPr>
-          </a:lstStyle>
-          <a:p xmlns:a="http://schemas.openxmlformats.org/drawingml/2006/main">
-            <a:pPr>
-              <a:buNone/>
-            </a:pPr>
-            <a:r>
-              <a:t>TLS</a:t>
-            </a:r>
-          </a:p>
-        </p:txBody>
-      </p:sp>
-      <p:sp>
-        <p:nvSpPr>
-          <p:cNvPr id="298" name="Shape 59">
-            <a:extLst xmlns:a="http://schemas.openxmlformats.org/drawingml/2006/main">
-              <a:ext uri="{FF2B5EF4-FFF2-40B4-BE49-F238E27FC236}">
-                <a16:creationId xmlns:a16="http://schemas.microsoft.com/office/drawing/2014/main" id="{F440343B-A8B9-4A50-BCA2-E8335C0A1918}"/>
-              </a:ext>
-            </a:extLst>
-          </p:cNvPr>
-          <p:cNvSpPr>
-            <a:spLocks xmlns:a="http://schemas.openxmlformats.org/drawingml/2006/main" noGrp="1"/>
-          </p:cNvSpPr>
-          <p:nvPr/>
-        </p:nvSpPr>
-        <p:spPr>
-          <a:xfrm xmlns:a="http://schemas.openxmlformats.org/drawingml/2006/main">
-            <a:off x="9347299" y="5411242"/>
-            <a:ext cx="390526" cy="215951"/>
-          </a:xfrm>
-          <a:prstGeom xmlns:a="http://schemas.openxmlformats.org/drawingml/2006/main" prst="roundRect">
-            <a:avLst>
-              <a:gd name="adj" fmla="val 50000"/>
-            </a:avLst>
-          </a:prstGeom>
-          <a:solidFill xmlns:a="http://schemas.openxmlformats.org/drawingml/2006/main">
-            <a:srgbClr val="F5F5F5"/>
-          </a:solidFill>
-          <a:ln xmlns:a="http://schemas.openxmlformats.org/drawingml/2006/main">
-            <a:solidFill>
-              <a:srgbClr val="E6E6E6"/>
-            </a:solidFill>
-          </a:ln>
-        </p:spPr>
-        <p:txBody>
-          <a:bodyPr xmlns:a="http://schemas.openxmlformats.org/drawingml/2006/main" lIns="45719" rIns="45719"/>
-          <a:lstStyle xmlns:a="http://schemas.openxmlformats.org/drawingml/2006/main"/>
-          <a:p xmlns:a="http://schemas.openxmlformats.org/drawingml/2006/main">
-            <a:pPr>
-              <a:buNone/>
-            </a:pPr>
-          </a:p>
-        </p:txBody>
-      </p:sp>
-      <p:sp>
-        <p:nvSpPr>
-          <p:cNvPr id="299" name="Text 60">
-            <a:extLst xmlns:a="http://schemas.openxmlformats.org/drawingml/2006/main">
-              <a:ext uri="{FF2B5EF4-FFF2-40B4-BE49-F238E27FC236}">
-                <a16:creationId xmlns:a16="http://schemas.microsoft.com/office/drawing/2014/main" id="{0D1ED65E-2BC6-4D8A-9695-B193E07476E6}"/>
-              </a:ext>
-            </a:extLst>
-          </p:cNvPr>
-          <p:cNvSpPr>
-            <a:spLocks xmlns:a="http://schemas.openxmlformats.org/drawingml/2006/main" noGrp="1"/>
-          </p:cNvSpPr>
-          <p:nvPr/>
-        </p:nvSpPr>
-        <p:spPr>
-          <a:xfrm xmlns:a="http://schemas.openxmlformats.org/drawingml/2006/main">
-            <a:off x="9433024" y="5439817"/>
-            <a:ext cx="295276" cy="196901"/>
-          </a:xfrm>
-          <a:prstGeom xmlns:a="http://schemas.openxmlformats.org/drawingml/2006/main" prst="rect">
-            <a:avLst/>
-          </a:prstGeom>
-          <a:ln xmlns:a="http://schemas.openxmlformats.org/drawingml/2006/main" w="12700"/>
-        </p:spPr>
-        <p:txBody>
-          <a:bodyPr xmlns:a="http://schemas.openxmlformats.org/drawingml/2006/main" lIns="25400" tIns="25400" rIns="25400" bIns="25400">
-            <a:normAutofit fontScale="82644" lnSpcReduction="0"/>
-          </a:bodyPr>
-          <a:lstStyle xmlns:a="http://schemas.openxmlformats.org/drawingml/2006/main">
-            <a:lvl1pPr>
-              <a:lnSpc>
-                <a:spcPct val="145000"/>
-              </a:lnSpc>
-              <a:buNone/>
-              <a:defRPr sz="800">
-                <a:solidFill>
-                  <a:srgbClr val="666666"/>
-                </a:solidFill>
-                <a:latin typeface="ITBA Mono"/>
-                <a:ea typeface="ITBA Mono"/>
-                <a:cs typeface="ITBA Mono"/>
-              </a:defRPr>
-            </a:lvl1pPr>
-          </a:lstStyle>
-          <a:p xmlns:a="http://schemas.openxmlformats.org/drawingml/2006/main">
-            <a:pPr>
-              <a:buNone/>
-            </a:pPr>
-            <a:r>
-              <a:t>BI</a:t>
-            </a:r>
-          </a:p>
-        </p:txBody>
-      </p:sp>
-      <p:sp>
-        <p:nvSpPr>
-          <p:cNvPr id="300" name="Text 61">
-            <a:extLst xmlns:a="http://schemas.openxmlformats.org/drawingml/2006/main">
-              <a:ext uri="{FF2B5EF4-FFF2-40B4-BE49-F238E27FC236}">
-                <a16:creationId xmlns:a16="http://schemas.microsoft.com/office/drawing/2014/main" id="{A8B73CF1-39AF-47E3-81D0-FCAD94CD73F0}"/>
-              </a:ext>
-            </a:extLst>
-          </p:cNvPr>
-          <p:cNvSpPr>
-            <a:spLocks xmlns:a="http://schemas.openxmlformats.org/drawingml/2006/main" noGrp="1"/>
-          </p:cNvSpPr>
-          <p:nvPr/>
-        </p:nvSpPr>
-        <p:spPr>
-          <a:xfrm xmlns:a="http://schemas.openxmlformats.org/drawingml/2006/main">
-            <a:off x="838200" y="6229350"/>
-            <a:ext cx="5632802" cy="209550"/>
-          </a:xfrm>
-          <a:prstGeom xmlns:a="http://schemas.openxmlformats.org/drawingml/2006/main" prst="rect">
-            <a:avLst/>
-          </a:prstGeom>
-          <a:ln xmlns:a="http://schemas.openxmlformats.org/drawingml/2006/main" w="12700"/>
-        </p:spPr>
-        <p:txBody>
-          <a:bodyPr xmlns:a="http://schemas.openxmlformats.org/drawingml/2006/main" lIns="25400" tIns="25400" rIns="25400" bIns="25400">
-            <a:normAutofit fontScale="77160" lnSpcReduction="0"/>
-          </a:bodyPr>
-          <a:lstStyle xmlns:a="http://schemas.openxmlformats.org/drawingml/2006/main">
-            <a:lvl1pPr>
-              <a:lnSpc>
-                <a:spcPct val="150000"/>
-              </a:lnSpc>
-              <a:buNone/>
-              <a:defRPr sz="900">
-                <a:solidFill>
-                  <a:srgbClr val="7F7F7F"/>
-                </a:solidFill>
-                <a:latin typeface="Chivo"/>
-                <a:ea typeface="Chivo"/>
-                <a:cs typeface="Chivo"/>
-              </a:defRPr>
-            </a:lvl1pPr>
-          </a:lstStyle>
-          <a:p xmlns:a="http://schemas.openxmlformats.org/drawingml/2006/main">
-            <a:pPr>
-              <a:buNone/>
-            </a:pPr>
-            <a:r>
-              <a:t>Landing preserva; Curated valida; RDS sirve. La conectividad privada atraviesa todo el diseño.</a:t>
-            </a:r>
-          </a:p>
-        </p:txBody>
-      </p:sp>
-      <p:sp>
-        <p:nvSpPr>
-          <p:cNvPr id="301" name="Text 62">
-            <a:extLst xmlns:a="http://schemas.openxmlformats.org/drawingml/2006/main">
-              <a:ext uri="{FF2B5EF4-FFF2-40B4-BE49-F238E27FC236}">
-                <a16:creationId xmlns:a16="http://schemas.microsoft.com/office/drawing/2014/main" id="{DDC0C69F-BF51-4C42-A883-8608C46D38A0}"/>
-              </a:ext>
-            </a:extLst>
-          </p:cNvPr>
-          <p:cNvSpPr>
-            <a:spLocks xmlns:a="http://schemas.openxmlformats.org/drawingml/2006/main" noGrp="1"/>
-          </p:cNvSpPr>
-          <p:nvPr/>
-        </p:nvSpPr>
-        <p:spPr>
-          <a:xfrm xmlns:a="http://schemas.openxmlformats.org/drawingml/2006/main">
-            <a:off x="533400" y="6458544"/>
-            <a:ext cx="1399892" cy="189906"/>
-          </a:xfrm>
-          <a:prstGeom xmlns:a="http://schemas.openxmlformats.org/drawingml/2006/main" prst="rect">
-            <a:avLst/>
-          </a:prstGeom>
-          <a:ln xmlns:a="http://schemas.openxmlformats.org/drawingml/2006/main" w="12700"/>
-        </p:spPr>
-        <p:txBody>
-          <a:bodyPr xmlns:a="http://schemas.openxmlformats.org/drawingml/2006/main" lIns="25400" tIns="25400" rIns="25400" bIns="25400">
-            <a:normAutofit fontScale="78687" lnSpcReduction="0"/>
-          </a:bodyPr>
-          <a:lstStyle xmlns:a="http://schemas.openxmlformats.org/drawingml/2006/main">
-            <a:lvl1pPr>
-              <a:lnSpc>
-                <a:spcPct val="145000"/>
-              </a:lnSpc>
-              <a:buNone/>
-              <a:defRPr sz="800">
-                <a:solidFill>
-                  <a:srgbClr val="666666"/>
-                </a:solidFill>
-                <a:latin typeface="Chivo"/>
-                <a:ea typeface="Chivo"/>
-                <a:cs typeface="Chivo"/>
-              </a:defRPr>
-            </a:lvl1pPr>
-          </a:lstStyle>
-          <a:p xmlns:a="http://schemas.openxmlformats.org/drawingml/2006/main">
-            <a:pPr>
-              <a:buNone/>
-            </a:pPr>
-            <a:r>
-              <a:t>Proyecto Final · arquitectura</a:t>
-            </a:r>
-          </a:p>
-        </p:txBody>
-      </p:sp>
-      <p:sp>
-        <p:nvSpPr>
-          <p:cNvPr id="302" name="Text 63">
-            <a:extLst xmlns:a="http://schemas.openxmlformats.org/drawingml/2006/main">
-              <a:ext uri="{FF2B5EF4-FFF2-40B4-BE49-F238E27FC236}">
-                <a16:creationId xmlns:a16="http://schemas.microsoft.com/office/drawing/2014/main" id="{B4631AFC-3676-4771-82F8-9CAE95464A73}"/>
-              </a:ext>
-            </a:extLst>
-          </p:cNvPr>
-          <p:cNvSpPr>
-            <a:spLocks xmlns:a="http://schemas.openxmlformats.org/drawingml/2006/main" noGrp="1"/>
-          </p:cNvSpPr>
-          <p:nvPr/>
-        </p:nvSpPr>
-        <p:spPr>
-          <a:xfrm xmlns:a="http://schemas.openxmlformats.org/drawingml/2006/main">
-            <a:off x="11708159" y="6458544"/>
-            <a:ext cx="274291" cy="189906"/>
-          </a:xfrm>
-          <a:prstGeom xmlns:a="http://schemas.openxmlformats.org/drawingml/2006/main" prst="rect">
-            <a:avLst/>
-          </a:prstGeom>
-          <a:ln xmlns:a="http://schemas.openxmlformats.org/drawingml/2006/main" w="12700"/>
-        </p:spPr>
-        <p:txBody>
-          <a:bodyPr xmlns:a="http://schemas.openxmlformats.org/drawingml/2006/main" lIns="25400" tIns="25400" rIns="25400" bIns="25400">
-            <a:normAutofit fontScale="78687" lnSpcReduction="0"/>
-          </a:bodyPr>
-          <a:lstStyle xmlns:a="http://schemas.openxmlformats.org/drawingml/2006/main">
-            <a:lvl1pPr>
-              <a:lnSpc>
-                <a:spcPct val="145000"/>
-              </a:lnSpc>
-              <a:buNone/>
-              <a:defRPr sz="800">
-                <a:solidFill>
-                  <a:srgbClr val="666666"/>
-                </a:solidFill>
-                <a:latin typeface="Chivo"/>
-                <a:ea typeface="Chivo"/>
-                <a:cs typeface="Chivo"/>
-              </a:defRPr>
-            </a:lvl1pPr>
-          </a:lstStyle>
-          <a:p xmlns:a="http://schemas.openxmlformats.org/drawingml/2006/main">
-            <a:pPr>
-              <a:buNone/>
-            </a:pPr>
-            <a:r>
-              <a:t>3/8</a:t>
-            </a:r>
-          </a:p>
-        </p:txBody>
-      </p:sp>
     </p:spTree>
     <p:extLst>
       <p:ext uri="{BB962C8B-B14F-4D97-AF65-F5344CB8AC3E}">
@@ -7316,7 +4188,7 @@
           <p:nvPr/>
         </p:nvPicPr>
         <p:blipFill>
-          <a:blip xmlns:r="http://schemas.openxmlformats.org/officeDocument/2006/relationships" xmlns:a="http://schemas.openxmlformats.org/drawingml/2006/main" r:embed="R2407fa2435fd4db4"/>
+          <a:blip xmlns:r="http://schemas.openxmlformats.org/officeDocument/2006/relationships" xmlns:a="http://schemas.openxmlformats.org/drawingml/2006/main" r:embed="R33a5dd0d7cfe44bf"/>
           <a:srcRect xmlns:a="http://schemas.openxmlformats.org/drawingml/2006/main" l="19" t="0" r="18" b="0"/>
           <a:stretch xmlns:a="http://schemas.openxmlformats.org/drawingml/2006/main">
             <a:fillRect l="0" t="0" r="0" b="0"/>
@@ -9041,7 +5913,7 @@
           <p:nvPr/>
         </p:nvPicPr>
         <p:blipFill>
-          <a:blip xmlns:r="http://schemas.openxmlformats.org/officeDocument/2006/relationships" xmlns:a="http://schemas.openxmlformats.org/drawingml/2006/main" r:embed="R42c16e2976ee4112"/>
+          <a:blip xmlns:r="http://schemas.openxmlformats.org/officeDocument/2006/relationships" xmlns:a="http://schemas.openxmlformats.org/drawingml/2006/main" r:embed="R052b479eab3c43a9"/>
           <a:srcRect xmlns:a="http://schemas.openxmlformats.org/drawingml/2006/main" l="19" t="0" r="18" b="0"/>
           <a:stretch xmlns:a="http://schemas.openxmlformats.org/drawingml/2006/main">
             <a:fillRect l="0" t="0" r="0" b="0"/>
@@ -10766,7 +7638,7 @@
           <p:nvPr/>
         </p:nvPicPr>
         <p:blipFill>
-          <a:blip xmlns:r="http://schemas.openxmlformats.org/officeDocument/2006/relationships" xmlns:a="http://schemas.openxmlformats.org/drawingml/2006/main" r:embed="Rccc0af1c24ff442a"/>
+          <a:blip xmlns:r="http://schemas.openxmlformats.org/officeDocument/2006/relationships" xmlns:a="http://schemas.openxmlformats.org/drawingml/2006/main" r:embed="Re1fd445e25cb490f"/>
           <a:srcRect xmlns:a="http://schemas.openxmlformats.org/drawingml/2006/main" l="19" t="0" r="18" b="0"/>
           <a:stretch xmlns:a="http://schemas.openxmlformats.org/drawingml/2006/main">
             <a:fillRect l="0" t="0" r="0" b="0"/>
@@ -12491,7 +9363,7 @@
           <p:nvPr/>
         </p:nvPicPr>
         <p:blipFill>
-          <a:blip xmlns:r="http://schemas.openxmlformats.org/officeDocument/2006/relationships" xmlns:a="http://schemas.openxmlformats.org/drawingml/2006/main" r:embed="R7989e51e288a4100"/>
+          <a:blip xmlns:r="http://schemas.openxmlformats.org/officeDocument/2006/relationships" xmlns:a="http://schemas.openxmlformats.org/drawingml/2006/main" r:embed="Ra57a23b6571c494a"/>
           <a:srcRect xmlns:a="http://schemas.openxmlformats.org/drawingml/2006/main" l="19" t="0" r="18" b="0"/>
           <a:stretch xmlns:a="http://schemas.openxmlformats.org/drawingml/2006/main">
             <a:fillRect l="0" t="0" r="0" b="0"/>

</xml_diff>

<commit_message>
docs: close Amazon VPC boundary in architecture v3
</commit_message>
<xml_diff>
--- a/outputs/proyecto-final-sap-analytics-aws.pptx
+++ b/outputs/proyecto-final-sap-analytics-aws.pptx
@@ -2,20 +2,20 @@
 <file path=ppt/presentation.xml><?xml version="1.0" encoding="utf-8"?>
 <p:presentation xmlns:p="http://schemas.openxmlformats.org/presentationml/2006/main">
   <p:sldMasterIdLst>
-    <p:sldMasterId xmlns:r="http://schemas.openxmlformats.org/officeDocument/2006/relationships" id="2147483648" r:id="Rc1ec6c63a18044a9"/>
+    <p:sldMasterId xmlns:r="http://schemas.openxmlformats.org/officeDocument/2006/relationships" id="2147483648" r:id="R874a9d4829b542d9"/>
   </p:sldMasterIdLst>
   <p:notesMasterIdLst>
-    <p:notesMasterId xmlns:r="http://schemas.openxmlformats.org/officeDocument/2006/relationships" r:id="Rc663632451ce4f45"/>
+    <p:notesMasterId xmlns:r="http://schemas.openxmlformats.org/officeDocument/2006/relationships" r:id="R949038289a304bcf"/>
   </p:notesMasterIdLst>
   <p:sldIdLst>
-    <p:sldId xmlns:r="http://schemas.openxmlformats.org/officeDocument/2006/relationships" id="256" r:id="Re1af0c350e9b413c"/>
-    <p:sldId xmlns:r="http://schemas.openxmlformats.org/officeDocument/2006/relationships" id="257" r:id="R51337c4c3f7a4523"/>
-    <p:sldId xmlns:r="http://schemas.openxmlformats.org/officeDocument/2006/relationships" id="258" r:id="R770eb7305caf4149"/>
-    <p:sldId xmlns:r="http://schemas.openxmlformats.org/officeDocument/2006/relationships" id="259" r:id="R68156d012fca453a"/>
-    <p:sldId xmlns:r="http://schemas.openxmlformats.org/officeDocument/2006/relationships" id="260" r:id="R73056830521244d4"/>
-    <p:sldId xmlns:r="http://schemas.openxmlformats.org/officeDocument/2006/relationships" id="261" r:id="R00b97a4607654aaa"/>
-    <p:sldId xmlns:r="http://schemas.openxmlformats.org/officeDocument/2006/relationships" id="262" r:id="R636b2b42ae754eb2"/>
-    <p:sldId xmlns:r="http://schemas.openxmlformats.org/officeDocument/2006/relationships" id="263" r:id="R156cad9f774e4bc6"/>
+    <p:sldId xmlns:r="http://schemas.openxmlformats.org/officeDocument/2006/relationships" id="256" r:id="R54c9e3597a6847bb"/>
+    <p:sldId xmlns:r="http://schemas.openxmlformats.org/officeDocument/2006/relationships" id="257" r:id="R22659f9267344e98"/>
+    <p:sldId xmlns:r="http://schemas.openxmlformats.org/officeDocument/2006/relationships" id="258" r:id="R718a376392c049a6"/>
+    <p:sldId xmlns:r="http://schemas.openxmlformats.org/officeDocument/2006/relationships" id="259" r:id="Rb67ccfa902ed47e8"/>
+    <p:sldId xmlns:r="http://schemas.openxmlformats.org/officeDocument/2006/relationships" id="260" r:id="R9003389c586a4966"/>
+    <p:sldId xmlns:r="http://schemas.openxmlformats.org/officeDocument/2006/relationships" id="261" r:id="Rfd482a6f94aa42f6"/>
+    <p:sldId xmlns:r="http://schemas.openxmlformats.org/officeDocument/2006/relationships" id="262" r:id="Rb663dbf669d845fa"/>
+    <p:sldId xmlns:r="http://schemas.openxmlformats.org/officeDocument/2006/relationships" id="263" r:id="R3ecdd33163c14289"/>
   </p:sldIdLst>
   <p:sldSz cx="12192000" cy="6858000"/>
   <p:notesSz cx="6858000" cy="9144000"/>
@@ -1262,7 +1262,7 @@
   </p:cSld>
   <p:clrMap bg1="lt1" tx1="dk1" bg2="lt2" tx2="dk2" accent1="accent1" accent2="accent2" accent3="accent3" accent4="accent4" accent5="accent5" accent6="accent6" hlink="hlink" folHlink="folHlink"/>
   <p:sldLayoutIdLst>
-    <p:sldLayoutId xmlns:r="http://schemas.openxmlformats.org/officeDocument/2006/relationships" id="2147483649" r:id="R838c2b5227ee4c51"/>
+    <p:sldLayoutId xmlns:r="http://schemas.openxmlformats.org/officeDocument/2006/relationships" id="2147483649" r:id="R2a34c2d125cd4cee"/>
   </p:sldLayoutIdLst>
   <p:txStyles>
     <p:titleStyle>
@@ -2144,7 +2144,7 @@
           <p:nvPr/>
         </p:nvPicPr>
         <p:blipFill>
-          <a:blip xmlns:r="http://schemas.openxmlformats.org/officeDocument/2006/relationships" xmlns:a="http://schemas.openxmlformats.org/drawingml/2006/main" r:embed="Rc9b02ac328bf4b58"/>
+          <a:blip xmlns:r="http://schemas.openxmlformats.org/officeDocument/2006/relationships" xmlns:a="http://schemas.openxmlformats.org/drawingml/2006/main" r:embed="Raaddd077108a461f"/>
           <a:srcRect xmlns:a="http://schemas.openxmlformats.org/drawingml/2006/main" l="19" t="0" r="18" b="0"/>
           <a:stretch xmlns:a="http://schemas.openxmlformats.org/drawingml/2006/main">
             <a:fillRect l="0" t="0" r="0" b="0"/>
@@ -2172,7 +2172,7 @@
           <p:nvPr/>
         </p:nvPicPr>
         <p:blipFill>
-          <a:blip xmlns:r="http://schemas.openxmlformats.org/officeDocument/2006/relationships" xmlns:a="http://schemas.openxmlformats.org/drawingml/2006/main" r:embed="R011788ea841c417e"/>
+          <a:blip xmlns:r="http://schemas.openxmlformats.org/officeDocument/2006/relationships" xmlns:a="http://schemas.openxmlformats.org/drawingml/2006/main" r:embed="R45c70f047dec4bf3"/>
           <a:stretch xmlns:a="http://schemas.openxmlformats.org/drawingml/2006/main">
             <a:fillRect l="0" t="0" r="0" b="0"/>
           </a:stretch>
@@ -2420,7 +2420,7 @@
           <p:nvPr/>
         </p:nvPicPr>
         <p:blipFill>
-          <a:blip xmlns:r="http://schemas.openxmlformats.org/officeDocument/2006/relationships" xmlns:a="http://schemas.openxmlformats.org/drawingml/2006/main" r:embed="R4cf5fcb998874a9d"/>
+          <a:blip xmlns:r="http://schemas.openxmlformats.org/officeDocument/2006/relationships" xmlns:a="http://schemas.openxmlformats.org/drawingml/2006/main" r:embed="R69338ccfb3a54f4b"/>
           <a:srcRect xmlns:a="http://schemas.openxmlformats.org/drawingml/2006/main" l="19" t="0" r="18" b="0"/>
           <a:stretch xmlns:a="http://schemas.openxmlformats.org/drawingml/2006/main">
             <a:fillRect l="0" t="0" r="0" b="0"/>
@@ -2824,7 +2824,7 @@
           <p:nvPr/>
         </p:nvPicPr>
         <p:blipFill>
-          <a:blip xmlns:r="http://schemas.openxmlformats.org/officeDocument/2006/relationships" xmlns:a="http://schemas.openxmlformats.org/drawingml/2006/main" r:embed="R5d0a0c4fcd344f92"/>
+          <a:blip xmlns:r="http://schemas.openxmlformats.org/officeDocument/2006/relationships" xmlns:a="http://schemas.openxmlformats.org/drawingml/2006/main" r:embed="R2cdd9824979c4a22"/>
           <a:srcRect xmlns:a="http://schemas.openxmlformats.org/drawingml/2006/main" l="19" t="0" r="18" b="0"/>
           <a:stretch xmlns:a="http://schemas.openxmlformats.org/drawingml/2006/main">
             <a:fillRect l="0" t="0" r="0" b="0"/>
@@ -4107,13 +4107,13 @@
           <p:nvPr/>
         </p:nvPicPr>
         <p:blipFill>
-          <a:blip xmlns:r="http://schemas.openxmlformats.org/officeDocument/2006/relationships" xmlns:a="http://schemas.openxmlformats.org/drawingml/2006/main" r:embed="R2390ee0ed4ea4a9f"/>
+          <a:blip xmlns:r="http://schemas.openxmlformats.org/officeDocument/2006/relationships" xmlns:a="http://schemas.openxmlformats.org/drawingml/2006/main" r:embed="R16f9c8aafe014d03"/>
           <a:stretch xmlns:a="http://schemas.openxmlformats.org/drawingml/2006/main"/>
         </p:blipFill>
         <p:spPr>
           <a:xfrm xmlns:a="http://schemas.openxmlformats.org/drawingml/2006/main">
-            <a:off x="6883" y="0"/>
-            <a:ext cx="12178234" cy="6858000"/>
+            <a:off x="10527" y="0"/>
+            <a:ext cx="12170946" cy="6858000"/>
           </a:xfrm>
           <a:prstGeom xmlns:a="http://schemas.openxmlformats.org/drawingml/2006/main" prst="rect">
             <a:avLst/>
@@ -4188,7 +4188,7 @@
           <p:nvPr/>
         </p:nvPicPr>
         <p:blipFill>
-          <a:blip xmlns:r="http://schemas.openxmlformats.org/officeDocument/2006/relationships" xmlns:a="http://schemas.openxmlformats.org/drawingml/2006/main" r:embed="R33a5dd0d7cfe44bf"/>
+          <a:blip xmlns:r="http://schemas.openxmlformats.org/officeDocument/2006/relationships" xmlns:a="http://schemas.openxmlformats.org/drawingml/2006/main" r:embed="R474f29784e614da9"/>
           <a:srcRect xmlns:a="http://schemas.openxmlformats.org/drawingml/2006/main" l="19" t="0" r="18" b="0"/>
           <a:stretch xmlns:a="http://schemas.openxmlformats.org/drawingml/2006/main">
             <a:fillRect l="0" t="0" r="0" b="0"/>
@@ -5913,7 +5913,7 @@
           <p:nvPr/>
         </p:nvPicPr>
         <p:blipFill>
-          <a:blip xmlns:r="http://schemas.openxmlformats.org/officeDocument/2006/relationships" xmlns:a="http://schemas.openxmlformats.org/drawingml/2006/main" r:embed="R052b479eab3c43a9"/>
+          <a:blip xmlns:r="http://schemas.openxmlformats.org/officeDocument/2006/relationships" xmlns:a="http://schemas.openxmlformats.org/drawingml/2006/main" r:embed="Re5ab5b323d4e481a"/>
           <a:srcRect xmlns:a="http://schemas.openxmlformats.org/drawingml/2006/main" l="19" t="0" r="18" b="0"/>
           <a:stretch xmlns:a="http://schemas.openxmlformats.org/drawingml/2006/main">
             <a:fillRect l="0" t="0" r="0" b="0"/>
@@ -7638,7 +7638,7 @@
           <p:nvPr/>
         </p:nvPicPr>
         <p:blipFill>
-          <a:blip xmlns:r="http://schemas.openxmlformats.org/officeDocument/2006/relationships" xmlns:a="http://schemas.openxmlformats.org/drawingml/2006/main" r:embed="Re1fd445e25cb490f"/>
+          <a:blip xmlns:r="http://schemas.openxmlformats.org/officeDocument/2006/relationships" xmlns:a="http://schemas.openxmlformats.org/drawingml/2006/main" r:embed="R6e5ea09e08754654"/>
           <a:srcRect xmlns:a="http://schemas.openxmlformats.org/drawingml/2006/main" l="19" t="0" r="18" b="0"/>
           <a:stretch xmlns:a="http://schemas.openxmlformats.org/drawingml/2006/main">
             <a:fillRect l="0" t="0" r="0" b="0"/>
@@ -9363,7 +9363,7 @@
           <p:nvPr/>
         </p:nvPicPr>
         <p:blipFill>
-          <a:blip xmlns:r="http://schemas.openxmlformats.org/officeDocument/2006/relationships" xmlns:a="http://schemas.openxmlformats.org/drawingml/2006/main" r:embed="Ra57a23b6571c494a"/>
+          <a:blip xmlns:r="http://schemas.openxmlformats.org/officeDocument/2006/relationships" xmlns:a="http://schemas.openxmlformats.org/drawingml/2006/main" r:embed="R08ebc3e13b234936"/>
           <a:srcRect xmlns:a="http://schemas.openxmlformats.org/drawingml/2006/main" l="19" t="0" r="18" b="0"/>
           <a:stretch xmlns:a="http://schemas.openxmlformats.org/drawingml/2006/main">
             <a:fillRect l="0" t="0" r="0" b="0"/>

</xml_diff>

<commit_message>
docs: distinguish curated storage from S3 endpoint
</commit_message>
<xml_diff>
--- a/outputs/proyecto-final-sap-analytics-aws.pptx
+++ b/outputs/proyecto-final-sap-analytics-aws.pptx
@@ -2,20 +2,20 @@
 <file path=ppt/presentation.xml><?xml version="1.0" encoding="utf-8"?>
 <p:presentation xmlns:p="http://schemas.openxmlformats.org/presentationml/2006/main">
   <p:sldMasterIdLst>
-    <p:sldMasterId xmlns:r="http://schemas.openxmlformats.org/officeDocument/2006/relationships" id="2147483648" r:id="R874a9d4829b542d9"/>
+    <p:sldMasterId xmlns:r="http://schemas.openxmlformats.org/officeDocument/2006/relationships" id="2147483648" r:id="R5ca3e45a88a84a61"/>
   </p:sldMasterIdLst>
   <p:notesMasterIdLst>
-    <p:notesMasterId xmlns:r="http://schemas.openxmlformats.org/officeDocument/2006/relationships" r:id="R949038289a304bcf"/>
+    <p:notesMasterId xmlns:r="http://schemas.openxmlformats.org/officeDocument/2006/relationships" r:id="R3fef9673e4f54342"/>
   </p:notesMasterIdLst>
   <p:sldIdLst>
-    <p:sldId xmlns:r="http://schemas.openxmlformats.org/officeDocument/2006/relationships" id="256" r:id="R54c9e3597a6847bb"/>
-    <p:sldId xmlns:r="http://schemas.openxmlformats.org/officeDocument/2006/relationships" id="257" r:id="R22659f9267344e98"/>
-    <p:sldId xmlns:r="http://schemas.openxmlformats.org/officeDocument/2006/relationships" id="258" r:id="R718a376392c049a6"/>
-    <p:sldId xmlns:r="http://schemas.openxmlformats.org/officeDocument/2006/relationships" id="259" r:id="Rb67ccfa902ed47e8"/>
-    <p:sldId xmlns:r="http://schemas.openxmlformats.org/officeDocument/2006/relationships" id="260" r:id="R9003389c586a4966"/>
-    <p:sldId xmlns:r="http://schemas.openxmlformats.org/officeDocument/2006/relationships" id="261" r:id="Rfd482a6f94aa42f6"/>
-    <p:sldId xmlns:r="http://schemas.openxmlformats.org/officeDocument/2006/relationships" id="262" r:id="Rb663dbf669d845fa"/>
-    <p:sldId xmlns:r="http://schemas.openxmlformats.org/officeDocument/2006/relationships" id="263" r:id="R3ecdd33163c14289"/>
+    <p:sldId xmlns:r="http://schemas.openxmlformats.org/officeDocument/2006/relationships" id="256" r:id="R3ef25245cbf74806"/>
+    <p:sldId xmlns:r="http://schemas.openxmlformats.org/officeDocument/2006/relationships" id="257" r:id="R987db5bd5da64763"/>
+    <p:sldId xmlns:r="http://schemas.openxmlformats.org/officeDocument/2006/relationships" id="258" r:id="R19b2186cf36040b5"/>
+    <p:sldId xmlns:r="http://schemas.openxmlformats.org/officeDocument/2006/relationships" id="259" r:id="Reef16448d63a4ea5"/>
+    <p:sldId xmlns:r="http://schemas.openxmlformats.org/officeDocument/2006/relationships" id="260" r:id="Ra61b40fee8bd4329"/>
+    <p:sldId xmlns:r="http://schemas.openxmlformats.org/officeDocument/2006/relationships" id="261" r:id="Rbf9d1cf1885b4269"/>
+    <p:sldId xmlns:r="http://schemas.openxmlformats.org/officeDocument/2006/relationships" id="262" r:id="R5d8ae123f6a74efa"/>
+    <p:sldId xmlns:r="http://schemas.openxmlformats.org/officeDocument/2006/relationships" id="263" r:id="Rabe0ea3b8b624e5e"/>
   </p:sldIdLst>
   <p:sldSz cx="12192000" cy="6858000"/>
   <p:notesSz cx="6858000" cy="9144000"/>
@@ -634,7 +634,7 @@
           <a:lstStyle xmlns:a="http://schemas.openxmlformats.org/drawingml/2006/main"/>
           <a:p xmlns:a="http://schemas.openxmlformats.org/drawingml/2006/main">
             <a:r>
-              <a:t>La arquitectura v3 incorpora los controles solicitados para producción: endpoints privados, egress restringido y backend remoto de Terraform.</a:t>
+              <a:t>La arquitectura v4 diferencia S3 Landing y S3 Curated del S3 Gateway Endpoint, además de incorporar endpoints privados, egress restringido y backend remoto de Terraform.</a:t>
             </a:r>
           </a:p>
           <a:p xmlns:a="http://schemas.openxmlformats.org/drawingml/2006/main">
@@ -644,7 +644,7 @@
           </a:p>
           <a:p xmlns:a="http://schemas.openxmlformats.org/drawingml/2006/main">
             <a:r>
-              <a:t>- outputs/arquitectura-sap-erp-slt-aws-consumo-v3.png</a:t>
+              <a:t>- outputs/arquitectura-sap-erp-slt-aws-consumo-v4.png</a:t>
             </a:r>
           </a:p>
           <a:p xmlns:a="http://schemas.openxmlformats.org/drawingml/2006/main">
@@ -1262,7 +1262,7 @@
   </p:cSld>
   <p:clrMap bg1="lt1" tx1="dk1" bg2="lt2" tx2="dk2" accent1="accent1" accent2="accent2" accent3="accent3" accent4="accent4" accent5="accent5" accent6="accent6" hlink="hlink" folHlink="folHlink"/>
   <p:sldLayoutIdLst>
-    <p:sldLayoutId xmlns:r="http://schemas.openxmlformats.org/officeDocument/2006/relationships" id="2147483649" r:id="R2a34c2d125cd4cee"/>
+    <p:sldLayoutId xmlns:r="http://schemas.openxmlformats.org/officeDocument/2006/relationships" id="2147483649" r:id="R36e14c06be1347ba"/>
   </p:sldLayoutIdLst>
   <p:txStyles>
     <p:titleStyle>
@@ -2144,7 +2144,7 @@
           <p:nvPr/>
         </p:nvPicPr>
         <p:blipFill>
-          <a:blip xmlns:r="http://schemas.openxmlformats.org/officeDocument/2006/relationships" xmlns:a="http://schemas.openxmlformats.org/drawingml/2006/main" r:embed="Raaddd077108a461f"/>
+          <a:blip xmlns:r="http://schemas.openxmlformats.org/officeDocument/2006/relationships" xmlns:a="http://schemas.openxmlformats.org/drawingml/2006/main" r:embed="R052f2547e6a44ead"/>
           <a:srcRect xmlns:a="http://schemas.openxmlformats.org/drawingml/2006/main" l="19" t="0" r="18" b="0"/>
           <a:stretch xmlns:a="http://schemas.openxmlformats.org/drawingml/2006/main">
             <a:fillRect l="0" t="0" r="0" b="0"/>
@@ -2172,7 +2172,7 @@
           <p:nvPr/>
         </p:nvPicPr>
         <p:blipFill>
-          <a:blip xmlns:r="http://schemas.openxmlformats.org/officeDocument/2006/relationships" xmlns:a="http://schemas.openxmlformats.org/drawingml/2006/main" r:embed="R45c70f047dec4bf3"/>
+          <a:blip xmlns:r="http://schemas.openxmlformats.org/officeDocument/2006/relationships" xmlns:a="http://schemas.openxmlformats.org/drawingml/2006/main" r:embed="R7147f368cfd14a23"/>
           <a:stretch xmlns:a="http://schemas.openxmlformats.org/drawingml/2006/main">
             <a:fillRect l="0" t="0" r="0" b="0"/>
           </a:stretch>
@@ -2420,7 +2420,7 @@
           <p:nvPr/>
         </p:nvPicPr>
         <p:blipFill>
-          <a:blip xmlns:r="http://schemas.openxmlformats.org/officeDocument/2006/relationships" xmlns:a="http://schemas.openxmlformats.org/drawingml/2006/main" r:embed="R69338ccfb3a54f4b"/>
+          <a:blip xmlns:r="http://schemas.openxmlformats.org/officeDocument/2006/relationships" xmlns:a="http://schemas.openxmlformats.org/drawingml/2006/main" r:embed="Re721ed183a804342"/>
           <a:srcRect xmlns:a="http://schemas.openxmlformats.org/drawingml/2006/main" l="19" t="0" r="18" b="0"/>
           <a:stretch xmlns:a="http://schemas.openxmlformats.org/drawingml/2006/main">
             <a:fillRect l="0" t="0" r="0" b="0"/>
@@ -2824,7 +2824,7 @@
           <p:nvPr/>
         </p:nvPicPr>
         <p:blipFill>
-          <a:blip xmlns:r="http://schemas.openxmlformats.org/officeDocument/2006/relationships" xmlns:a="http://schemas.openxmlformats.org/drawingml/2006/main" r:embed="R2cdd9824979c4a22"/>
+          <a:blip xmlns:r="http://schemas.openxmlformats.org/officeDocument/2006/relationships" xmlns:a="http://schemas.openxmlformats.org/drawingml/2006/main" r:embed="Rbc826c30ed334b0f"/>
           <a:srcRect xmlns:a="http://schemas.openxmlformats.org/drawingml/2006/main" l="19" t="0" r="18" b="0"/>
           <a:stretch xmlns:a="http://schemas.openxmlformats.org/drawingml/2006/main">
             <a:fillRect l="0" t="0" r="0" b="0"/>
@@ -4107,7 +4107,7 @@
           <p:nvPr/>
         </p:nvPicPr>
         <p:blipFill>
-          <a:blip xmlns:r="http://schemas.openxmlformats.org/officeDocument/2006/relationships" xmlns:a="http://schemas.openxmlformats.org/drawingml/2006/main" r:embed="R16f9c8aafe014d03"/>
+          <a:blip xmlns:r="http://schemas.openxmlformats.org/officeDocument/2006/relationships" xmlns:a="http://schemas.openxmlformats.org/drawingml/2006/main" r:embed="R1d18badd2c8b4cd5"/>
           <a:stretch xmlns:a="http://schemas.openxmlformats.org/drawingml/2006/main"/>
         </p:blipFill>
         <p:spPr>
@@ -4188,7 +4188,7 @@
           <p:nvPr/>
         </p:nvPicPr>
         <p:blipFill>
-          <a:blip xmlns:r="http://schemas.openxmlformats.org/officeDocument/2006/relationships" xmlns:a="http://schemas.openxmlformats.org/drawingml/2006/main" r:embed="R474f29784e614da9"/>
+          <a:blip xmlns:r="http://schemas.openxmlformats.org/officeDocument/2006/relationships" xmlns:a="http://schemas.openxmlformats.org/drawingml/2006/main" r:embed="Rebc6579d3f464997"/>
           <a:srcRect xmlns:a="http://schemas.openxmlformats.org/drawingml/2006/main" l="19" t="0" r="18" b="0"/>
           <a:stretch xmlns:a="http://schemas.openxmlformats.org/drawingml/2006/main">
             <a:fillRect l="0" t="0" r="0" b="0"/>
@@ -5913,7 +5913,7 @@
           <p:nvPr/>
         </p:nvPicPr>
         <p:blipFill>
-          <a:blip xmlns:r="http://schemas.openxmlformats.org/officeDocument/2006/relationships" xmlns:a="http://schemas.openxmlformats.org/drawingml/2006/main" r:embed="Re5ab5b323d4e481a"/>
+          <a:blip xmlns:r="http://schemas.openxmlformats.org/officeDocument/2006/relationships" xmlns:a="http://schemas.openxmlformats.org/drawingml/2006/main" r:embed="R06a24d4df1cd4c86"/>
           <a:srcRect xmlns:a="http://schemas.openxmlformats.org/drawingml/2006/main" l="19" t="0" r="18" b="0"/>
           <a:stretch xmlns:a="http://schemas.openxmlformats.org/drawingml/2006/main">
             <a:fillRect l="0" t="0" r="0" b="0"/>
@@ -7638,7 +7638,7 @@
           <p:nvPr/>
         </p:nvPicPr>
         <p:blipFill>
-          <a:blip xmlns:r="http://schemas.openxmlformats.org/officeDocument/2006/relationships" xmlns:a="http://schemas.openxmlformats.org/drawingml/2006/main" r:embed="R6e5ea09e08754654"/>
+          <a:blip xmlns:r="http://schemas.openxmlformats.org/officeDocument/2006/relationships" xmlns:a="http://schemas.openxmlformats.org/drawingml/2006/main" r:embed="R3a901313adce444e"/>
           <a:srcRect xmlns:a="http://schemas.openxmlformats.org/drawingml/2006/main" l="19" t="0" r="18" b="0"/>
           <a:stretch xmlns:a="http://schemas.openxmlformats.org/drawingml/2006/main">
             <a:fillRect l="0" t="0" r="0" b="0"/>
@@ -9363,7 +9363,7 @@
           <p:nvPr/>
         </p:nvPicPr>
         <p:blipFill>
-          <a:blip xmlns:r="http://schemas.openxmlformats.org/officeDocument/2006/relationships" xmlns:a="http://schemas.openxmlformats.org/drawingml/2006/main" r:embed="R08ebc3e13b234936"/>
+          <a:blip xmlns:r="http://schemas.openxmlformats.org/officeDocument/2006/relationships" xmlns:a="http://schemas.openxmlformats.org/drawingml/2006/main" r:embed="R99ef24b5b57d41fb"/>
           <a:srcRect xmlns:a="http://schemas.openxmlformats.org/drawingml/2006/main" l="19" t="0" r="18" b="0"/>
           <a:stretch xmlns:a="http://schemas.openxmlformats.org/drawingml/2006/main">
             <a:fillRect l="0" t="0" r="0" b="0"/>

</xml_diff>

<commit_message>
docs: remove orphan AppFlow connector
</commit_message>
<xml_diff>
--- a/outputs/proyecto-final-sap-analytics-aws.pptx
+++ b/outputs/proyecto-final-sap-analytics-aws.pptx
@@ -2,20 +2,20 @@
 <file path=ppt/presentation.xml><?xml version="1.0" encoding="utf-8"?>
 <p:presentation xmlns:p="http://schemas.openxmlformats.org/presentationml/2006/main">
   <p:sldMasterIdLst>
-    <p:sldMasterId xmlns:r="http://schemas.openxmlformats.org/officeDocument/2006/relationships" id="2147483648" r:id="R5ca3e45a88a84a61"/>
+    <p:sldMasterId xmlns:r="http://schemas.openxmlformats.org/officeDocument/2006/relationships" id="2147483648" r:id="Rb0a19b1baef540b3"/>
   </p:sldMasterIdLst>
   <p:notesMasterIdLst>
-    <p:notesMasterId xmlns:r="http://schemas.openxmlformats.org/officeDocument/2006/relationships" r:id="R3fef9673e4f54342"/>
+    <p:notesMasterId xmlns:r="http://schemas.openxmlformats.org/officeDocument/2006/relationships" r:id="R2a1a7ef74a6c4e28"/>
   </p:notesMasterIdLst>
   <p:sldIdLst>
-    <p:sldId xmlns:r="http://schemas.openxmlformats.org/officeDocument/2006/relationships" id="256" r:id="R3ef25245cbf74806"/>
-    <p:sldId xmlns:r="http://schemas.openxmlformats.org/officeDocument/2006/relationships" id="257" r:id="R987db5bd5da64763"/>
-    <p:sldId xmlns:r="http://schemas.openxmlformats.org/officeDocument/2006/relationships" id="258" r:id="R19b2186cf36040b5"/>
-    <p:sldId xmlns:r="http://schemas.openxmlformats.org/officeDocument/2006/relationships" id="259" r:id="Reef16448d63a4ea5"/>
-    <p:sldId xmlns:r="http://schemas.openxmlformats.org/officeDocument/2006/relationships" id="260" r:id="Ra61b40fee8bd4329"/>
-    <p:sldId xmlns:r="http://schemas.openxmlformats.org/officeDocument/2006/relationships" id="261" r:id="Rbf9d1cf1885b4269"/>
-    <p:sldId xmlns:r="http://schemas.openxmlformats.org/officeDocument/2006/relationships" id="262" r:id="R5d8ae123f6a74efa"/>
-    <p:sldId xmlns:r="http://schemas.openxmlformats.org/officeDocument/2006/relationships" id="263" r:id="Rabe0ea3b8b624e5e"/>
+    <p:sldId xmlns:r="http://schemas.openxmlformats.org/officeDocument/2006/relationships" id="256" r:id="R7247a147cbd84e2e"/>
+    <p:sldId xmlns:r="http://schemas.openxmlformats.org/officeDocument/2006/relationships" id="257" r:id="R9d58ccf90e0a4870"/>
+    <p:sldId xmlns:r="http://schemas.openxmlformats.org/officeDocument/2006/relationships" id="258" r:id="R2a605ed8ec544abf"/>
+    <p:sldId xmlns:r="http://schemas.openxmlformats.org/officeDocument/2006/relationships" id="259" r:id="R7272335e3d944e94"/>
+    <p:sldId xmlns:r="http://schemas.openxmlformats.org/officeDocument/2006/relationships" id="260" r:id="R14e2401c47944b7d"/>
+    <p:sldId xmlns:r="http://schemas.openxmlformats.org/officeDocument/2006/relationships" id="261" r:id="R9ec39b76358141b6"/>
+    <p:sldId xmlns:r="http://schemas.openxmlformats.org/officeDocument/2006/relationships" id="262" r:id="R4d58e2315f2548a3"/>
+    <p:sldId xmlns:r="http://schemas.openxmlformats.org/officeDocument/2006/relationships" id="263" r:id="Rc6585f8b339b4cc9"/>
   </p:sldIdLst>
   <p:sldSz cx="12192000" cy="6858000"/>
   <p:notesSz cx="6858000" cy="9144000"/>
@@ -1262,7 +1262,7 @@
   </p:cSld>
   <p:clrMap bg1="lt1" tx1="dk1" bg2="lt2" tx2="dk2" accent1="accent1" accent2="accent2" accent3="accent3" accent4="accent4" accent5="accent5" accent6="accent6" hlink="hlink" folHlink="folHlink"/>
   <p:sldLayoutIdLst>
-    <p:sldLayoutId xmlns:r="http://schemas.openxmlformats.org/officeDocument/2006/relationships" id="2147483649" r:id="R36e14c06be1347ba"/>
+    <p:sldLayoutId xmlns:r="http://schemas.openxmlformats.org/officeDocument/2006/relationships" id="2147483649" r:id="Rc8c2ae3516de4789"/>
   </p:sldLayoutIdLst>
   <p:txStyles>
     <p:titleStyle>
@@ -2144,7 +2144,7 @@
           <p:nvPr/>
         </p:nvPicPr>
         <p:blipFill>
-          <a:blip xmlns:r="http://schemas.openxmlformats.org/officeDocument/2006/relationships" xmlns:a="http://schemas.openxmlformats.org/drawingml/2006/main" r:embed="R052f2547e6a44ead"/>
+          <a:blip xmlns:r="http://schemas.openxmlformats.org/officeDocument/2006/relationships" xmlns:a="http://schemas.openxmlformats.org/drawingml/2006/main" r:embed="Red26b264b9c348b4"/>
           <a:srcRect xmlns:a="http://schemas.openxmlformats.org/drawingml/2006/main" l="19" t="0" r="18" b="0"/>
           <a:stretch xmlns:a="http://schemas.openxmlformats.org/drawingml/2006/main">
             <a:fillRect l="0" t="0" r="0" b="0"/>
@@ -2172,7 +2172,7 @@
           <p:nvPr/>
         </p:nvPicPr>
         <p:blipFill>
-          <a:blip xmlns:r="http://schemas.openxmlformats.org/officeDocument/2006/relationships" xmlns:a="http://schemas.openxmlformats.org/drawingml/2006/main" r:embed="R7147f368cfd14a23"/>
+          <a:blip xmlns:r="http://schemas.openxmlformats.org/officeDocument/2006/relationships" xmlns:a="http://schemas.openxmlformats.org/drawingml/2006/main" r:embed="R6f967da3fab844fa"/>
           <a:stretch xmlns:a="http://schemas.openxmlformats.org/drawingml/2006/main">
             <a:fillRect l="0" t="0" r="0" b="0"/>
           </a:stretch>
@@ -2420,7 +2420,7 @@
           <p:nvPr/>
         </p:nvPicPr>
         <p:blipFill>
-          <a:blip xmlns:r="http://schemas.openxmlformats.org/officeDocument/2006/relationships" xmlns:a="http://schemas.openxmlformats.org/drawingml/2006/main" r:embed="Re721ed183a804342"/>
+          <a:blip xmlns:r="http://schemas.openxmlformats.org/officeDocument/2006/relationships" xmlns:a="http://schemas.openxmlformats.org/drawingml/2006/main" r:embed="R5b6d4587904446c7"/>
           <a:srcRect xmlns:a="http://schemas.openxmlformats.org/drawingml/2006/main" l="19" t="0" r="18" b="0"/>
           <a:stretch xmlns:a="http://schemas.openxmlformats.org/drawingml/2006/main">
             <a:fillRect l="0" t="0" r="0" b="0"/>
@@ -2824,7 +2824,7 @@
           <p:nvPr/>
         </p:nvPicPr>
         <p:blipFill>
-          <a:blip xmlns:r="http://schemas.openxmlformats.org/officeDocument/2006/relationships" xmlns:a="http://schemas.openxmlformats.org/drawingml/2006/main" r:embed="Rbc826c30ed334b0f"/>
+          <a:blip xmlns:r="http://schemas.openxmlformats.org/officeDocument/2006/relationships" xmlns:a="http://schemas.openxmlformats.org/drawingml/2006/main" r:embed="R65ce18b9e4954177"/>
           <a:srcRect xmlns:a="http://schemas.openxmlformats.org/drawingml/2006/main" l="19" t="0" r="18" b="0"/>
           <a:stretch xmlns:a="http://schemas.openxmlformats.org/drawingml/2006/main">
             <a:fillRect l="0" t="0" r="0" b="0"/>
@@ -4107,7 +4107,7 @@
           <p:nvPr/>
         </p:nvPicPr>
         <p:blipFill>
-          <a:blip xmlns:r="http://schemas.openxmlformats.org/officeDocument/2006/relationships" xmlns:a="http://schemas.openxmlformats.org/drawingml/2006/main" r:embed="R1d18badd2c8b4cd5"/>
+          <a:blip xmlns:r="http://schemas.openxmlformats.org/officeDocument/2006/relationships" xmlns:a="http://schemas.openxmlformats.org/drawingml/2006/main" r:embed="Ra526ac786e3a4248"/>
           <a:stretch xmlns:a="http://schemas.openxmlformats.org/drawingml/2006/main"/>
         </p:blipFill>
         <p:spPr>
@@ -4188,7 +4188,7 @@
           <p:nvPr/>
         </p:nvPicPr>
         <p:blipFill>
-          <a:blip xmlns:r="http://schemas.openxmlformats.org/officeDocument/2006/relationships" xmlns:a="http://schemas.openxmlformats.org/drawingml/2006/main" r:embed="Rebc6579d3f464997"/>
+          <a:blip xmlns:r="http://schemas.openxmlformats.org/officeDocument/2006/relationships" xmlns:a="http://schemas.openxmlformats.org/drawingml/2006/main" r:embed="R7dae344c780e48d1"/>
           <a:srcRect xmlns:a="http://schemas.openxmlformats.org/drawingml/2006/main" l="19" t="0" r="18" b="0"/>
           <a:stretch xmlns:a="http://schemas.openxmlformats.org/drawingml/2006/main">
             <a:fillRect l="0" t="0" r="0" b="0"/>
@@ -5913,7 +5913,7 @@
           <p:nvPr/>
         </p:nvPicPr>
         <p:blipFill>
-          <a:blip xmlns:r="http://schemas.openxmlformats.org/officeDocument/2006/relationships" xmlns:a="http://schemas.openxmlformats.org/drawingml/2006/main" r:embed="R06a24d4df1cd4c86"/>
+          <a:blip xmlns:r="http://schemas.openxmlformats.org/officeDocument/2006/relationships" xmlns:a="http://schemas.openxmlformats.org/drawingml/2006/main" r:embed="R530012a7ed494171"/>
           <a:srcRect xmlns:a="http://schemas.openxmlformats.org/drawingml/2006/main" l="19" t="0" r="18" b="0"/>
           <a:stretch xmlns:a="http://schemas.openxmlformats.org/drawingml/2006/main">
             <a:fillRect l="0" t="0" r="0" b="0"/>
@@ -7638,7 +7638,7 @@
           <p:nvPr/>
         </p:nvPicPr>
         <p:blipFill>
-          <a:blip xmlns:r="http://schemas.openxmlformats.org/officeDocument/2006/relationships" xmlns:a="http://schemas.openxmlformats.org/drawingml/2006/main" r:embed="R3a901313adce444e"/>
+          <a:blip xmlns:r="http://schemas.openxmlformats.org/officeDocument/2006/relationships" xmlns:a="http://schemas.openxmlformats.org/drawingml/2006/main" r:embed="Rd97ca11caaff4ae9"/>
           <a:srcRect xmlns:a="http://schemas.openxmlformats.org/drawingml/2006/main" l="19" t="0" r="18" b="0"/>
           <a:stretch xmlns:a="http://schemas.openxmlformats.org/drawingml/2006/main">
             <a:fillRect l="0" t="0" r="0" b="0"/>
@@ -9363,7 +9363,7 @@
           <p:nvPr/>
         </p:nvPicPr>
         <p:blipFill>
-          <a:blip xmlns:r="http://schemas.openxmlformats.org/officeDocument/2006/relationships" xmlns:a="http://schemas.openxmlformats.org/drawingml/2006/main" r:embed="R99ef24b5b57d41fb"/>
+          <a:blip xmlns:r="http://schemas.openxmlformats.org/officeDocument/2006/relationships" xmlns:a="http://schemas.openxmlformats.org/drawingml/2006/main" r:embed="R8e68c466495e4366"/>
           <a:srcRect xmlns:a="http://schemas.openxmlformats.org/drawingml/2006/main" l="19" t="0" r="18" b="0"/>
           <a:stretch xmlns:a="http://schemas.openxmlformats.org/drawingml/2006/main">
             <a:fillRect l="0" t="0" r="0" b="0"/>

</xml_diff>

<commit_message>
docs: publish corrected SAP migration architecture v5
</commit_message>
<xml_diff>
--- a/outputs/proyecto-final-sap-analytics-aws.pptx
+++ b/outputs/proyecto-final-sap-analytics-aws.pptx
@@ -2,20 +2,20 @@
 <file path=ppt/presentation.xml><?xml version="1.0" encoding="utf-8"?>
 <p:presentation xmlns:p="http://schemas.openxmlformats.org/presentationml/2006/main">
   <p:sldMasterIdLst>
-    <p:sldMasterId xmlns:r="http://schemas.openxmlformats.org/officeDocument/2006/relationships" id="2147483648" r:id="Rb0a19b1baef540b3"/>
+    <p:sldMasterId xmlns:r="http://schemas.openxmlformats.org/officeDocument/2006/relationships" id="2147483648" r:id="R1de7919405f44c60"/>
   </p:sldMasterIdLst>
   <p:notesMasterIdLst>
-    <p:notesMasterId xmlns:r="http://schemas.openxmlformats.org/officeDocument/2006/relationships" r:id="R2a1a7ef74a6c4e28"/>
+    <p:notesMasterId xmlns:r="http://schemas.openxmlformats.org/officeDocument/2006/relationships" r:id="R45ffc247c66b492b"/>
   </p:notesMasterIdLst>
   <p:sldIdLst>
-    <p:sldId xmlns:r="http://schemas.openxmlformats.org/officeDocument/2006/relationships" id="256" r:id="R7247a147cbd84e2e"/>
-    <p:sldId xmlns:r="http://schemas.openxmlformats.org/officeDocument/2006/relationships" id="257" r:id="R9d58ccf90e0a4870"/>
-    <p:sldId xmlns:r="http://schemas.openxmlformats.org/officeDocument/2006/relationships" id="258" r:id="R2a605ed8ec544abf"/>
-    <p:sldId xmlns:r="http://schemas.openxmlformats.org/officeDocument/2006/relationships" id="259" r:id="R7272335e3d944e94"/>
-    <p:sldId xmlns:r="http://schemas.openxmlformats.org/officeDocument/2006/relationships" id="260" r:id="R14e2401c47944b7d"/>
-    <p:sldId xmlns:r="http://schemas.openxmlformats.org/officeDocument/2006/relationships" id="261" r:id="R9ec39b76358141b6"/>
-    <p:sldId xmlns:r="http://schemas.openxmlformats.org/officeDocument/2006/relationships" id="262" r:id="R4d58e2315f2548a3"/>
-    <p:sldId xmlns:r="http://schemas.openxmlformats.org/officeDocument/2006/relationships" id="263" r:id="Rc6585f8b339b4cc9"/>
+    <p:sldId xmlns:r="http://schemas.openxmlformats.org/officeDocument/2006/relationships" id="256" r:id="R820e0e0f1a32477b"/>
+    <p:sldId xmlns:r="http://schemas.openxmlformats.org/officeDocument/2006/relationships" id="257" r:id="Rb0f5cf0a6e26481a"/>
+    <p:sldId xmlns:r="http://schemas.openxmlformats.org/officeDocument/2006/relationships" id="258" r:id="R7ff4c15291924b59"/>
+    <p:sldId xmlns:r="http://schemas.openxmlformats.org/officeDocument/2006/relationships" id="259" r:id="Rba76c63cf577489e"/>
+    <p:sldId xmlns:r="http://schemas.openxmlformats.org/officeDocument/2006/relationships" id="260" r:id="Rc1908618568a44f9"/>
+    <p:sldId xmlns:r="http://schemas.openxmlformats.org/officeDocument/2006/relationships" id="261" r:id="R16f620e1d2744e69"/>
+    <p:sldId xmlns:r="http://schemas.openxmlformats.org/officeDocument/2006/relationships" id="262" r:id="Rdb316b45b42e4159"/>
+    <p:sldId xmlns:r="http://schemas.openxmlformats.org/officeDocument/2006/relationships" id="263" r:id="Rd1b833d33c8a4a76"/>
   </p:sldIdLst>
   <p:sldSz cx="12192000" cy="6858000"/>
   <p:notesSz cx="6858000" cy="9144000"/>
@@ -634,7 +634,7 @@
           <a:lstStyle xmlns:a="http://schemas.openxmlformats.org/drawingml/2006/main"/>
           <a:p xmlns:a="http://schemas.openxmlformats.org/drawingml/2006/main">
             <a:r>
-              <a:t>La arquitectura v4 diferencia S3 Landing y S3 Curated del S3 Gateway Endpoint, además de incorporar endpoints privados, egress restringido y backend remoto de Terraform.</a:t>
+              <a:t>La arquitectura v5 contiene subredes y servicios compartidos dentro de una VPC cerrada, representa un único ASG ETL Multi-AZ y explicita Curated → ETL → RDS.</a:t>
             </a:r>
           </a:p>
           <a:p xmlns:a="http://schemas.openxmlformats.org/drawingml/2006/main">
@@ -644,7 +644,7 @@
           </a:p>
           <a:p xmlns:a="http://schemas.openxmlformats.org/drawingml/2006/main">
             <a:r>
-              <a:t>- outputs/arquitectura-sap-erp-slt-aws-consumo-v4.png</a:t>
+              <a:t>- outputs/arquitectura-sap-erp-slt-aws-consumo-v5.png</a:t>
             </a:r>
           </a:p>
           <a:p xmlns:a="http://schemas.openxmlformats.org/drawingml/2006/main">
@@ -1262,7 +1262,7 @@
   </p:cSld>
   <p:clrMap bg1="lt1" tx1="dk1" bg2="lt2" tx2="dk2" accent1="accent1" accent2="accent2" accent3="accent3" accent4="accent4" accent5="accent5" accent6="accent6" hlink="hlink" folHlink="folHlink"/>
   <p:sldLayoutIdLst>
-    <p:sldLayoutId xmlns:r="http://schemas.openxmlformats.org/officeDocument/2006/relationships" id="2147483649" r:id="Rc8c2ae3516de4789"/>
+    <p:sldLayoutId xmlns:r="http://schemas.openxmlformats.org/officeDocument/2006/relationships" id="2147483649" r:id="R4f74be7a195e479a"/>
   </p:sldLayoutIdLst>
   <p:txStyles>
     <p:titleStyle>
@@ -2144,7 +2144,7 @@
           <p:nvPr/>
         </p:nvPicPr>
         <p:blipFill>
-          <a:blip xmlns:r="http://schemas.openxmlformats.org/officeDocument/2006/relationships" xmlns:a="http://schemas.openxmlformats.org/drawingml/2006/main" r:embed="Red26b264b9c348b4"/>
+          <a:blip xmlns:r="http://schemas.openxmlformats.org/officeDocument/2006/relationships" xmlns:a="http://schemas.openxmlformats.org/drawingml/2006/main" r:embed="Rf114781148d84f07"/>
           <a:srcRect xmlns:a="http://schemas.openxmlformats.org/drawingml/2006/main" l="19" t="0" r="18" b="0"/>
           <a:stretch xmlns:a="http://schemas.openxmlformats.org/drawingml/2006/main">
             <a:fillRect l="0" t="0" r="0" b="0"/>
@@ -2172,7 +2172,7 @@
           <p:nvPr/>
         </p:nvPicPr>
         <p:blipFill>
-          <a:blip xmlns:r="http://schemas.openxmlformats.org/officeDocument/2006/relationships" xmlns:a="http://schemas.openxmlformats.org/drawingml/2006/main" r:embed="R6f967da3fab844fa"/>
+          <a:blip xmlns:r="http://schemas.openxmlformats.org/officeDocument/2006/relationships" xmlns:a="http://schemas.openxmlformats.org/drawingml/2006/main" r:embed="R29f7544137764d4a"/>
           <a:stretch xmlns:a="http://schemas.openxmlformats.org/drawingml/2006/main">
             <a:fillRect l="0" t="0" r="0" b="0"/>
           </a:stretch>
@@ -2420,7 +2420,7 @@
           <p:nvPr/>
         </p:nvPicPr>
         <p:blipFill>
-          <a:blip xmlns:r="http://schemas.openxmlformats.org/officeDocument/2006/relationships" xmlns:a="http://schemas.openxmlformats.org/drawingml/2006/main" r:embed="R5b6d4587904446c7"/>
+          <a:blip xmlns:r="http://schemas.openxmlformats.org/officeDocument/2006/relationships" xmlns:a="http://schemas.openxmlformats.org/drawingml/2006/main" r:embed="R37439746a43d4e67"/>
           <a:srcRect xmlns:a="http://schemas.openxmlformats.org/drawingml/2006/main" l="19" t="0" r="18" b="0"/>
           <a:stretch xmlns:a="http://schemas.openxmlformats.org/drawingml/2006/main">
             <a:fillRect l="0" t="0" r="0" b="0"/>
@@ -2824,7 +2824,7 @@
           <p:nvPr/>
         </p:nvPicPr>
         <p:blipFill>
-          <a:blip xmlns:r="http://schemas.openxmlformats.org/officeDocument/2006/relationships" xmlns:a="http://schemas.openxmlformats.org/drawingml/2006/main" r:embed="R65ce18b9e4954177"/>
+          <a:blip xmlns:r="http://schemas.openxmlformats.org/officeDocument/2006/relationships" xmlns:a="http://schemas.openxmlformats.org/drawingml/2006/main" r:embed="R459577b163004fdd"/>
           <a:srcRect xmlns:a="http://schemas.openxmlformats.org/drawingml/2006/main" l="19" t="0" r="18" b="0"/>
           <a:stretch xmlns:a="http://schemas.openxmlformats.org/drawingml/2006/main">
             <a:fillRect l="0" t="0" r="0" b="0"/>
@@ -4107,13 +4107,13 @@
           <p:nvPr/>
         </p:nvPicPr>
         <p:blipFill>
-          <a:blip xmlns:r="http://schemas.openxmlformats.org/officeDocument/2006/relationships" xmlns:a="http://schemas.openxmlformats.org/drawingml/2006/main" r:embed="Ra526ac786e3a4248"/>
+          <a:blip xmlns:r="http://schemas.openxmlformats.org/officeDocument/2006/relationships" xmlns:a="http://schemas.openxmlformats.org/drawingml/2006/main" r:embed="R7f809a14d0eb4b88"/>
           <a:stretch xmlns:a="http://schemas.openxmlformats.org/drawingml/2006/main"/>
         </p:blipFill>
         <p:spPr>
           <a:xfrm xmlns:a="http://schemas.openxmlformats.org/drawingml/2006/main">
-            <a:off x="10527" y="0"/>
-            <a:ext cx="12170946" cy="6858000"/>
+            <a:off x="3239" y="0"/>
+            <a:ext cx="12185522" cy="6858000"/>
           </a:xfrm>
           <a:prstGeom xmlns:a="http://schemas.openxmlformats.org/drawingml/2006/main" prst="rect">
             <a:avLst/>
@@ -4188,7 +4188,7 @@
           <p:nvPr/>
         </p:nvPicPr>
         <p:blipFill>
-          <a:blip xmlns:r="http://schemas.openxmlformats.org/officeDocument/2006/relationships" xmlns:a="http://schemas.openxmlformats.org/drawingml/2006/main" r:embed="R7dae344c780e48d1"/>
+          <a:blip xmlns:r="http://schemas.openxmlformats.org/officeDocument/2006/relationships" xmlns:a="http://schemas.openxmlformats.org/drawingml/2006/main" r:embed="R9d27efeafca14b94"/>
           <a:srcRect xmlns:a="http://schemas.openxmlformats.org/drawingml/2006/main" l="19" t="0" r="18" b="0"/>
           <a:stretch xmlns:a="http://schemas.openxmlformats.org/drawingml/2006/main">
             <a:fillRect l="0" t="0" r="0" b="0"/>
@@ -5913,7 +5913,7 @@
           <p:nvPr/>
         </p:nvPicPr>
         <p:blipFill>
-          <a:blip xmlns:r="http://schemas.openxmlformats.org/officeDocument/2006/relationships" xmlns:a="http://schemas.openxmlformats.org/drawingml/2006/main" r:embed="R530012a7ed494171"/>
+          <a:blip xmlns:r="http://schemas.openxmlformats.org/officeDocument/2006/relationships" xmlns:a="http://schemas.openxmlformats.org/drawingml/2006/main" r:embed="R0c355ec4a96c4d40"/>
           <a:srcRect xmlns:a="http://schemas.openxmlformats.org/drawingml/2006/main" l="19" t="0" r="18" b="0"/>
           <a:stretch xmlns:a="http://schemas.openxmlformats.org/drawingml/2006/main">
             <a:fillRect l="0" t="0" r="0" b="0"/>
@@ -7638,7 +7638,7 @@
           <p:nvPr/>
         </p:nvPicPr>
         <p:blipFill>
-          <a:blip xmlns:r="http://schemas.openxmlformats.org/officeDocument/2006/relationships" xmlns:a="http://schemas.openxmlformats.org/drawingml/2006/main" r:embed="Rd97ca11caaff4ae9"/>
+          <a:blip xmlns:r="http://schemas.openxmlformats.org/officeDocument/2006/relationships" xmlns:a="http://schemas.openxmlformats.org/drawingml/2006/main" r:embed="Rb2d2f72d52014a86"/>
           <a:srcRect xmlns:a="http://schemas.openxmlformats.org/drawingml/2006/main" l="19" t="0" r="18" b="0"/>
           <a:stretch xmlns:a="http://schemas.openxmlformats.org/drawingml/2006/main">
             <a:fillRect l="0" t="0" r="0" b="0"/>
@@ -9363,7 +9363,7 @@
           <p:nvPr/>
         </p:nvPicPr>
         <p:blipFill>
-          <a:blip xmlns:r="http://schemas.openxmlformats.org/officeDocument/2006/relationships" xmlns:a="http://schemas.openxmlformats.org/drawingml/2006/main" r:embed="R8e68c466495e4366"/>
+          <a:blip xmlns:r="http://schemas.openxmlformats.org/officeDocument/2006/relationships" xmlns:a="http://schemas.openxmlformats.org/drawingml/2006/main" r:embed="Rfdbb3ef73e524938"/>
           <a:srcRect xmlns:a="http://schemas.openxmlformats.org/drawingml/2006/main" l="19" t="0" r="18" b="0"/>
           <a:stretch xmlns:a="http://schemas.openxmlformats.org/drawingml/2006/main">
             <a:fillRect l="0" t="0" r="0" b="0"/>

</xml_diff>